<commit_message>
Poster Draft Iteration 0
</commit_message>
<xml_diff>
--- a/Poster/SiteSafeAiPoster.pptx
+++ b/Poster/SiteSafeAiPoster.pptx
@@ -801,6 +801,4167 @@
 </pc:chgInfo>
 </file>
 
+<file path=ppt/diagrams/colors1.xml><?xml version="1.0" encoding="utf-8"?>
+<dgm:colorsDef xmlns:dgm="http://schemas.openxmlformats.org/drawingml/2006/diagram" xmlns:a="http://schemas.openxmlformats.org/drawingml/2006/main" uniqueId="urn:microsoft.com/office/officeart/2005/8/colors/accent1_2">
+  <dgm:title val=""/>
+  <dgm:desc val=""/>
+  <dgm:catLst>
+    <dgm:cat type="accent1" pri="11200"/>
+  </dgm:catLst>
+  <dgm:styleLbl name="node0">
+    <dgm:fillClrLst meth="repeat">
+      <a:schemeClr val="accent1"/>
+    </dgm:fillClrLst>
+    <dgm:linClrLst meth="repeat">
+      <a:schemeClr val="lt1"/>
+    </dgm:linClrLst>
+    <dgm:effectClrLst/>
+    <dgm:txLinClrLst/>
+    <dgm:txFillClrLst/>
+    <dgm:txEffectClrLst/>
+  </dgm:styleLbl>
+  <dgm:styleLbl name="alignNode1">
+    <dgm:fillClrLst meth="repeat">
+      <a:schemeClr val="accent1"/>
+    </dgm:fillClrLst>
+    <dgm:linClrLst meth="repeat">
+      <a:schemeClr val="accent1"/>
+    </dgm:linClrLst>
+    <dgm:effectClrLst/>
+    <dgm:txLinClrLst/>
+    <dgm:txFillClrLst/>
+    <dgm:txEffectClrLst/>
+  </dgm:styleLbl>
+  <dgm:styleLbl name="node1">
+    <dgm:fillClrLst meth="repeat">
+      <a:schemeClr val="accent1"/>
+    </dgm:fillClrLst>
+    <dgm:linClrLst meth="repeat">
+      <a:schemeClr val="lt1"/>
+    </dgm:linClrLst>
+    <dgm:effectClrLst/>
+    <dgm:txLinClrLst/>
+    <dgm:txFillClrLst/>
+    <dgm:txEffectClrLst/>
+  </dgm:styleLbl>
+  <dgm:styleLbl name="lnNode1">
+    <dgm:fillClrLst meth="repeat">
+      <a:schemeClr val="accent1"/>
+    </dgm:fillClrLst>
+    <dgm:linClrLst meth="repeat">
+      <a:schemeClr val="lt1"/>
+    </dgm:linClrLst>
+    <dgm:effectClrLst/>
+    <dgm:txLinClrLst/>
+    <dgm:txFillClrLst/>
+    <dgm:txEffectClrLst/>
+  </dgm:styleLbl>
+  <dgm:styleLbl name="vennNode1">
+    <dgm:fillClrLst meth="repeat">
+      <a:schemeClr val="accent1">
+        <a:alpha val="50000"/>
+      </a:schemeClr>
+    </dgm:fillClrLst>
+    <dgm:linClrLst meth="repeat">
+      <a:schemeClr val="lt1"/>
+    </dgm:linClrLst>
+    <dgm:effectClrLst/>
+    <dgm:txLinClrLst/>
+    <dgm:txFillClrLst/>
+    <dgm:txEffectClrLst/>
+  </dgm:styleLbl>
+  <dgm:styleLbl name="node2">
+    <dgm:fillClrLst meth="repeat">
+      <a:schemeClr val="accent1"/>
+    </dgm:fillClrLst>
+    <dgm:linClrLst meth="repeat">
+      <a:schemeClr val="lt1"/>
+    </dgm:linClrLst>
+    <dgm:effectClrLst/>
+    <dgm:txLinClrLst/>
+    <dgm:txFillClrLst/>
+    <dgm:txEffectClrLst/>
+  </dgm:styleLbl>
+  <dgm:styleLbl name="node3">
+    <dgm:fillClrLst meth="repeat">
+      <a:schemeClr val="accent1"/>
+    </dgm:fillClrLst>
+    <dgm:linClrLst meth="repeat">
+      <a:schemeClr val="lt1"/>
+    </dgm:linClrLst>
+    <dgm:effectClrLst/>
+    <dgm:txLinClrLst/>
+    <dgm:txFillClrLst/>
+    <dgm:txEffectClrLst/>
+  </dgm:styleLbl>
+  <dgm:styleLbl name="node4">
+    <dgm:fillClrLst meth="repeat">
+      <a:schemeClr val="accent1"/>
+    </dgm:fillClrLst>
+    <dgm:linClrLst meth="repeat">
+      <a:schemeClr val="lt1"/>
+    </dgm:linClrLst>
+    <dgm:effectClrLst/>
+    <dgm:txLinClrLst/>
+    <dgm:txFillClrLst/>
+    <dgm:txEffectClrLst/>
+  </dgm:styleLbl>
+  <dgm:styleLbl name="fgImgPlace1">
+    <dgm:fillClrLst meth="repeat">
+      <a:schemeClr val="accent1">
+        <a:tint val="50000"/>
+      </a:schemeClr>
+    </dgm:fillClrLst>
+    <dgm:linClrLst meth="repeat">
+      <a:schemeClr val="lt1"/>
+    </dgm:linClrLst>
+    <dgm:effectClrLst/>
+    <dgm:txLinClrLst/>
+    <dgm:txFillClrLst meth="repeat">
+      <a:schemeClr val="lt1"/>
+    </dgm:txFillClrLst>
+    <dgm:txEffectClrLst/>
+  </dgm:styleLbl>
+  <dgm:styleLbl name="alignImgPlace1">
+    <dgm:fillClrLst meth="repeat">
+      <a:schemeClr val="accent1">
+        <a:tint val="50000"/>
+      </a:schemeClr>
+    </dgm:fillClrLst>
+    <dgm:linClrLst meth="repeat">
+      <a:schemeClr val="lt1"/>
+    </dgm:linClrLst>
+    <dgm:effectClrLst/>
+    <dgm:txLinClrLst/>
+    <dgm:txFillClrLst meth="repeat">
+      <a:schemeClr val="lt1"/>
+    </dgm:txFillClrLst>
+    <dgm:txEffectClrLst/>
+  </dgm:styleLbl>
+  <dgm:styleLbl name="bgImgPlace1">
+    <dgm:fillClrLst meth="repeat">
+      <a:schemeClr val="accent1">
+        <a:tint val="50000"/>
+      </a:schemeClr>
+    </dgm:fillClrLst>
+    <dgm:linClrLst meth="repeat">
+      <a:schemeClr val="lt1"/>
+    </dgm:linClrLst>
+    <dgm:effectClrLst/>
+    <dgm:txLinClrLst/>
+    <dgm:txFillClrLst meth="repeat">
+      <a:schemeClr val="lt1"/>
+    </dgm:txFillClrLst>
+    <dgm:txEffectClrLst/>
+  </dgm:styleLbl>
+  <dgm:styleLbl name="sibTrans2D1">
+    <dgm:fillClrLst meth="repeat">
+      <a:schemeClr val="accent1">
+        <a:tint val="60000"/>
+      </a:schemeClr>
+    </dgm:fillClrLst>
+    <dgm:linClrLst meth="repeat">
+      <a:schemeClr val="accent1">
+        <a:tint val="60000"/>
+      </a:schemeClr>
+    </dgm:linClrLst>
+    <dgm:effectClrLst/>
+    <dgm:txLinClrLst/>
+    <dgm:txFillClrLst/>
+    <dgm:txEffectClrLst/>
+  </dgm:styleLbl>
+  <dgm:styleLbl name="fgSibTrans2D1">
+    <dgm:fillClrLst meth="repeat">
+      <a:schemeClr val="accent1">
+        <a:tint val="60000"/>
+      </a:schemeClr>
+    </dgm:fillClrLst>
+    <dgm:linClrLst meth="repeat">
+      <a:schemeClr val="accent1">
+        <a:tint val="60000"/>
+      </a:schemeClr>
+    </dgm:linClrLst>
+    <dgm:effectClrLst/>
+    <dgm:txLinClrLst/>
+    <dgm:txFillClrLst/>
+    <dgm:txEffectClrLst/>
+  </dgm:styleLbl>
+  <dgm:styleLbl name="bgSibTrans2D1">
+    <dgm:fillClrLst meth="repeat">
+      <a:schemeClr val="accent1">
+        <a:tint val="60000"/>
+      </a:schemeClr>
+    </dgm:fillClrLst>
+    <dgm:linClrLst meth="repeat">
+      <a:schemeClr val="accent1">
+        <a:tint val="60000"/>
+      </a:schemeClr>
+    </dgm:linClrLst>
+    <dgm:effectClrLst/>
+    <dgm:txLinClrLst/>
+    <dgm:txFillClrLst/>
+    <dgm:txEffectClrLst/>
+  </dgm:styleLbl>
+  <dgm:styleLbl name="sibTrans1D1">
+    <dgm:fillClrLst meth="repeat">
+      <a:schemeClr val="accent1"/>
+    </dgm:fillClrLst>
+    <dgm:linClrLst meth="repeat">
+      <a:schemeClr val="accent1"/>
+    </dgm:linClrLst>
+    <dgm:effectClrLst/>
+    <dgm:txLinClrLst/>
+    <dgm:txFillClrLst meth="repeat">
+      <a:schemeClr val="tx1"/>
+    </dgm:txFillClrLst>
+    <dgm:txEffectClrLst/>
+  </dgm:styleLbl>
+  <dgm:styleLbl name="callout">
+    <dgm:fillClrLst meth="repeat">
+      <a:schemeClr val="accent1"/>
+    </dgm:fillClrLst>
+    <dgm:linClrLst meth="repeat">
+      <a:schemeClr val="accent1">
+        <a:tint val="50000"/>
+      </a:schemeClr>
+    </dgm:linClrLst>
+    <dgm:effectClrLst/>
+    <dgm:txLinClrLst/>
+    <dgm:txFillClrLst meth="repeat">
+      <a:schemeClr val="tx1"/>
+    </dgm:txFillClrLst>
+    <dgm:txEffectClrLst/>
+  </dgm:styleLbl>
+  <dgm:styleLbl name="asst0">
+    <dgm:fillClrLst meth="repeat">
+      <a:schemeClr val="accent1"/>
+    </dgm:fillClrLst>
+    <dgm:linClrLst meth="repeat">
+      <a:schemeClr val="lt1"/>
+    </dgm:linClrLst>
+    <dgm:effectClrLst/>
+    <dgm:txLinClrLst/>
+    <dgm:txFillClrLst/>
+    <dgm:txEffectClrLst/>
+  </dgm:styleLbl>
+  <dgm:styleLbl name="asst1">
+    <dgm:fillClrLst meth="repeat">
+      <a:schemeClr val="accent1"/>
+    </dgm:fillClrLst>
+    <dgm:linClrLst meth="repeat">
+      <a:schemeClr val="lt1"/>
+    </dgm:linClrLst>
+    <dgm:effectClrLst/>
+    <dgm:txLinClrLst/>
+    <dgm:txFillClrLst/>
+    <dgm:txEffectClrLst/>
+  </dgm:styleLbl>
+  <dgm:styleLbl name="asst2">
+    <dgm:fillClrLst meth="repeat">
+      <a:schemeClr val="accent1"/>
+    </dgm:fillClrLst>
+    <dgm:linClrLst meth="repeat">
+      <a:schemeClr val="lt1"/>
+    </dgm:linClrLst>
+    <dgm:effectClrLst/>
+    <dgm:txLinClrLst/>
+    <dgm:txFillClrLst/>
+    <dgm:txEffectClrLst/>
+  </dgm:styleLbl>
+  <dgm:styleLbl name="asst3">
+    <dgm:fillClrLst meth="repeat">
+      <a:schemeClr val="accent1"/>
+    </dgm:fillClrLst>
+    <dgm:linClrLst meth="repeat">
+      <a:schemeClr val="lt1"/>
+    </dgm:linClrLst>
+    <dgm:effectClrLst/>
+    <dgm:txLinClrLst/>
+    <dgm:txFillClrLst/>
+    <dgm:txEffectClrLst/>
+  </dgm:styleLbl>
+  <dgm:styleLbl name="asst4">
+    <dgm:fillClrLst meth="repeat">
+      <a:schemeClr val="accent1"/>
+    </dgm:fillClrLst>
+    <dgm:linClrLst meth="repeat">
+      <a:schemeClr val="lt1"/>
+    </dgm:linClrLst>
+    <dgm:effectClrLst/>
+    <dgm:txLinClrLst/>
+    <dgm:txFillClrLst/>
+    <dgm:txEffectClrLst/>
+  </dgm:styleLbl>
+  <dgm:styleLbl name="parChTrans2D1">
+    <dgm:fillClrLst meth="repeat">
+      <a:schemeClr val="accent1">
+        <a:tint val="60000"/>
+      </a:schemeClr>
+    </dgm:fillClrLst>
+    <dgm:linClrLst meth="repeat">
+      <a:schemeClr val="accent1">
+        <a:tint val="60000"/>
+      </a:schemeClr>
+    </dgm:linClrLst>
+    <dgm:effectClrLst/>
+    <dgm:txLinClrLst/>
+    <dgm:txFillClrLst meth="repeat">
+      <a:schemeClr val="lt1"/>
+    </dgm:txFillClrLst>
+    <dgm:txEffectClrLst/>
+  </dgm:styleLbl>
+  <dgm:styleLbl name="parChTrans2D2">
+    <dgm:fillClrLst meth="repeat">
+      <a:schemeClr val="accent1"/>
+    </dgm:fillClrLst>
+    <dgm:linClrLst meth="repeat">
+      <a:schemeClr val="accent1"/>
+    </dgm:linClrLst>
+    <dgm:effectClrLst/>
+    <dgm:txLinClrLst/>
+    <dgm:txFillClrLst meth="repeat">
+      <a:schemeClr val="lt1"/>
+    </dgm:txFillClrLst>
+    <dgm:txEffectClrLst/>
+  </dgm:styleLbl>
+  <dgm:styleLbl name="parChTrans2D3">
+    <dgm:fillClrLst meth="repeat">
+      <a:schemeClr val="accent1"/>
+    </dgm:fillClrLst>
+    <dgm:linClrLst meth="repeat">
+      <a:schemeClr val="accent1"/>
+    </dgm:linClrLst>
+    <dgm:effectClrLst/>
+    <dgm:txLinClrLst/>
+    <dgm:txFillClrLst meth="repeat">
+      <a:schemeClr val="lt1"/>
+    </dgm:txFillClrLst>
+    <dgm:txEffectClrLst/>
+  </dgm:styleLbl>
+  <dgm:styleLbl name="parChTrans2D4">
+    <dgm:fillClrLst meth="repeat">
+      <a:schemeClr val="accent1"/>
+    </dgm:fillClrLst>
+    <dgm:linClrLst meth="repeat">
+      <a:schemeClr val="accent1"/>
+    </dgm:linClrLst>
+    <dgm:effectClrLst/>
+    <dgm:txLinClrLst/>
+    <dgm:txFillClrLst meth="repeat">
+      <a:schemeClr val="lt1"/>
+    </dgm:txFillClrLst>
+    <dgm:txEffectClrLst/>
+  </dgm:styleLbl>
+  <dgm:styleLbl name="parChTrans1D1">
+    <dgm:fillClrLst meth="repeat">
+      <a:schemeClr val="accent1"/>
+    </dgm:fillClrLst>
+    <dgm:linClrLst meth="repeat">
+      <a:schemeClr val="accent1">
+        <a:shade val="60000"/>
+      </a:schemeClr>
+    </dgm:linClrLst>
+    <dgm:effectClrLst/>
+    <dgm:txLinClrLst/>
+    <dgm:txFillClrLst meth="repeat">
+      <a:schemeClr val="tx1"/>
+    </dgm:txFillClrLst>
+    <dgm:txEffectClrLst/>
+  </dgm:styleLbl>
+  <dgm:styleLbl name="parChTrans1D2">
+    <dgm:fillClrLst meth="repeat">
+      <a:schemeClr val="accent1"/>
+    </dgm:fillClrLst>
+    <dgm:linClrLst meth="repeat">
+      <a:schemeClr val="accent1">
+        <a:shade val="60000"/>
+      </a:schemeClr>
+    </dgm:linClrLst>
+    <dgm:effectClrLst/>
+    <dgm:txLinClrLst/>
+    <dgm:txFillClrLst meth="repeat">
+      <a:schemeClr val="tx1"/>
+    </dgm:txFillClrLst>
+    <dgm:txEffectClrLst/>
+  </dgm:styleLbl>
+  <dgm:styleLbl name="parChTrans1D3">
+    <dgm:fillClrLst meth="repeat">
+      <a:schemeClr val="accent1"/>
+    </dgm:fillClrLst>
+    <dgm:linClrLst meth="repeat">
+      <a:schemeClr val="accent1">
+        <a:shade val="80000"/>
+      </a:schemeClr>
+    </dgm:linClrLst>
+    <dgm:effectClrLst/>
+    <dgm:txLinClrLst/>
+    <dgm:txFillClrLst meth="repeat">
+      <a:schemeClr val="tx1"/>
+    </dgm:txFillClrLst>
+    <dgm:txEffectClrLst/>
+  </dgm:styleLbl>
+  <dgm:styleLbl name="parChTrans1D4">
+    <dgm:fillClrLst meth="repeat">
+      <a:schemeClr val="accent1"/>
+    </dgm:fillClrLst>
+    <dgm:linClrLst meth="repeat">
+      <a:schemeClr val="accent1">
+        <a:shade val="80000"/>
+      </a:schemeClr>
+    </dgm:linClrLst>
+    <dgm:effectClrLst/>
+    <dgm:txLinClrLst/>
+    <dgm:txFillClrLst meth="repeat">
+      <a:schemeClr val="tx1"/>
+    </dgm:txFillClrLst>
+    <dgm:txEffectClrLst/>
+  </dgm:styleLbl>
+  <dgm:styleLbl name="fgAcc1">
+    <dgm:fillClrLst meth="repeat">
+      <a:schemeClr val="lt1">
+        <a:alpha val="90000"/>
+      </a:schemeClr>
+    </dgm:fillClrLst>
+    <dgm:linClrLst meth="repeat">
+      <a:schemeClr val="accent1"/>
+    </dgm:linClrLst>
+    <dgm:effectClrLst/>
+    <dgm:txLinClrLst/>
+    <dgm:txFillClrLst meth="repeat">
+      <a:schemeClr val="dk1"/>
+    </dgm:txFillClrLst>
+    <dgm:txEffectClrLst/>
+  </dgm:styleLbl>
+  <dgm:styleLbl name="conFgAcc1">
+    <dgm:fillClrLst meth="repeat">
+      <a:schemeClr val="lt1">
+        <a:alpha val="90000"/>
+      </a:schemeClr>
+    </dgm:fillClrLst>
+    <dgm:linClrLst meth="repeat">
+      <a:schemeClr val="accent1"/>
+    </dgm:linClrLst>
+    <dgm:effectClrLst/>
+    <dgm:txLinClrLst/>
+    <dgm:txFillClrLst meth="repeat">
+      <a:schemeClr val="dk1"/>
+    </dgm:txFillClrLst>
+    <dgm:txEffectClrLst/>
+  </dgm:styleLbl>
+  <dgm:styleLbl name="alignAcc1">
+    <dgm:fillClrLst meth="repeat">
+      <a:schemeClr val="lt1">
+        <a:alpha val="90000"/>
+      </a:schemeClr>
+    </dgm:fillClrLst>
+    <dgm:linClrLst meth="repeat">
+      <a:schemeClr val="accent1"/>
+    </dgm:linClrLst>
+    <dgm:effectClrLst/>
+    <dgm:txLinClrLst/>
+    <dgm:txFillClrLst meth="repeat">
+      <a:schemeClr val="dk1"/>
+    </dgm:txFillClrLst>
+    <dgm:txEffectClrLst/>
+  </dgm:styleLbl>
+  <dgm:styleLbl name="trAlignAcc1">
+    <dgm:fillClrLst meth="repeat">
+      <a:schemeClr val="lt1">
+        <a:alpha val="40000"/>
+      </a:schemeClr>
+    </dgm:fillClrLst>
+    <dgm:linClrLst meth="repeat">
+      <a:schemeClr val="accent1"/>
+    </dgm:linClrLst>
+    <dgm:effectClrLst/>
+    <dgm:txLinClrLst/>
+    <dgm:txFillClrLst meth="repeat">
+      <a:schemeClr val="dk1"/>
+    </dgm:txFillClrLst>
+    <dgm:txEffectClrLst/>
+  </dgm:styleLbl>
+  <dgm:styleLbl name="bgAcc1">
+    <dgm:fillClrLst meth="repeat">
+      <a:schemeClr val="lt1">
+        <a:alpha val="90000"/>
+      </a:schemeClr>
+    </dgm:fillClrLst>
+    <dgm:linClrLst meth="repeat">
+      <a:schemeClr val="accent1"/>
+    </dgm:linClrLst>
+    <dgm:effectClrLst/>
+    <dgm:txLinClrLst/>
+    <dgm:txFillClrLst meth="repeat">
+      <a:schemeClr val="dk1"/>
+    </dgm:txFillClrLst>
+    <dgm:txEffectClrLst/>
+  </dgm:styleLbl>
+  <dgm:styleLbl name="solidFgAcc1">
+    <dgm:fillClrLst meth="repeat">
+      <a:schemeClr val="lt1"/>
+    </dgm:fillClrLst>
+    <dgm:linClrLst meth="repeat">
+      <a:schemeClr val="accent1"/>
+    </dgm:linClrLst>
+    <dgm:effectClrLst/>
+    <dgm:txLinClrLst/>
+    <dgm:txFillClrLst meth="repeat">
+      <a:schemeClr val="dk1"/>
+    </dgm:txFillClrLst>
+    <dgm:txEffectClrLst/>
+  </dgm:styleLbl>
+  <dgm:styleLbl name="solidAlignAcc1">
+    <dgm:fillClrLst meth="repeat">
+      <a:schemeClr val="lt1"/>
+    </dgm:fillClrLst>
+    <dgm:linClrLst meth="repeat">
+      <a:schemeClr val="accent1"/>
+    </dgm:linClrLst>
+    <dgm:effectClrLst/>
+    <dgm:txLinClrLst/>
+    <dgm:txFillClrLst meth="repeat">
+      <a:schemeClr val="dk1"/>
+    </dgm:txFillClrLst>
+    <dgm:txEffectClrLst/>
+  </dgm:styleLbl>
+  <dgm:styleLbl name="solidBgAcc1">
+    <dgm:fillClrLst meth="repeat">
+      <a:schemeClr val="lt1"/>
+    </dgm:fillClrLst>
+    <dgm:linClrLst meth="repeat">
+      <a:schemeClr val="accent1"/>
+    </dgm:linClrLst>
+    <dgm:effectClrLst/>
+    <dgm:txLinClrLst/>
+    <dgm:txFillClrLst meth="repeat">
+      <a:schemeClr val="dk1"/>
+    </dgm:txFillClrLst>
+    <dgm:txEffectClrLst/>
+  </dgm:styleLbl>
+  <dgm:styleLbl name="fgAccFollowNode1">
+    <dgm:fillClrLst meth="repeat">
+      <a:schemeClr val="accent1">
+        <a:alpha val="90000"/>
+        <a:tint val="40000"/>
+      </a:schemeClr>
+    </dgm:fillClrLst>
+    <dgm:linClrLst meth="repeat">
+      <a:schemeClr val="accent1">
+        <a:alpha val="90000"/>
+        <a:tint val="40000"/>
+      </a:schemeClr>
+    </dgm:linClrLst>
+    <dgm:effectClrLst/>
+    <dgm:txLinClrLst/>
+    <dgm:txFillClrLst meth="repeat">
+      <a:schemeClr val="dk1"/>
+    </dgm:txFillClrLst>
+    <dgm:txEffectClrLst/>
+  </dgm:styleLbl>
+  <dgm:styleLbl name="alignAccFollowNode1">
+    <dgm:fillClrLst meth="repeat">
+      <a:schemeClr val="accent1">
+        <a:alpha val="90000"/>
+        <a:tint val="40000"/>
+      </a:schemeClr>
+    </dgm:fillClrLst>
+    <dgm:linClrLst meth="repeat">
+      <a:schemeClr val="accent1">
+        <a:alpha val="90000"/>
+        <a:tint val="40000"/>
+      </a:schemeClr>
+    </dgm:linClrLst>
+    <dgm:effectClrLst/>
+    <dgm:txLinClrLst/>
+    <dgm:txFillClrLst meth="repeat">
+      <a:schemeClr val="dk1"/>
+    </dgm:txFillClrLst>
+    <dgm:txEffectClrLst/>
+  </dgm:styleLbl>
+  <dgm:styleLbl name="bgAccFollowNode1">
+    <dgm:fillClrLst meth="repeat">
+      <a:schemeClr val="accent1">
+        <a:alpha val="90000"/>
+        <a:tint val="40000"/>
+      </a:schemeClr>
+    </dgm:fillClrLst>
+    <dgm:linClrLst meth="repeat">
+      <a:schemeClr val="accent1">
+        <a:alpha val="90000"/>
+        <a:tint val="40000"/>
+      </a:schemeClr>
+    </dgm:linClrLst>
+    <dgm:effectClrLst/>
+    <dgm:txLinClrLst/>
+    <dgm:txFillClrLst meth="repeat">
+      <a:schemeClr val="dk1"/>
+    </dgm:txFillClrLst>
+    <dgm:txEffectClrLst/>
+  </dgm:styleLbl>
+  <dgm:styleLbl name="fgAcc0">
+    <dgm:fillClrLst meth="repeat">
+      <a:schemeClr val="lt1">
+        <a:alpha val="90000"/>
+      </a:schemeClr>
+    </dgm:fillClrLst>
+    <dgm:linClrLst meth="repeat">
+      <a:schemeClr val="accent1"/>
+    </dgm:linClrLst>
+    <dgm:effectClrLst/>
+    <dgm:txLinClrLst/>
+    <dgm:txFillClrLst meth="repeat">
+      <a:schemeClr val="dk1"/>
+    </dgm:txFillClrLst>
+    <dgm:txEffectClrLst/>
+  </dgm:styleLbl>
+  <dgm:styleLbl name="fgAcc2">
+    <dgm:fillClrLst meth="repeat">
+      <a:schemeClr val="lt1">
+        <a:alpha val="90000"/>
+      </a:schemeClr>
+    </dgm:fillClrLst>
+    <dgm:linClrLst meth="repeat">
+      <a:schemeClr val="accent1"/>
+    </dgm:linClrLst>
+    <dgm:effectClrLst/>
+    <dgm:txLinClrLst/>
+    <dgm:txFillClrLst meth="repeat">
+      <a:schemeClr val="dk1"/>
+    </dgm:txFillClrLst>
+    <dgm:txEffectClrLst/>
+  </dgm:styleLbl>
+  <dgm:styleLbl name="fgAcc3">
+    <dgm:fillClrLst meth="repeat">
+      <a:schemeClr val="lt1">
+        <a:alpha val="90000"/>
+      </a:schemeClr>
+    </dgm:fillClrLst>
+    <dgm:linClrLst meth="repeat">
+      <a:schemeClr val="accent1"/>
+    </dgm:linClrLst>
+    <dgm:effectClrLst/>
+    <dgm:txLinClrLst/>
+    <dgm:txFillClrLst meth="repeat">
+      <a:schemeClr val="dk1"/>
+    </dgm:txFillClrLst>
+    <dgm:txEffectClrLst/>
+  </dgm:styleLbl>
+  <dgm:styleLbl name="fgAcc4">
+    <dgm:fillClrLst meth="repeat">
+      <a:schemeClr val="lt1">
+        <a:alpha val="90000"/>
+      </a:schemeClr>
+    </dgm:fillClrLst>
+    <dgm:linClrLst meth="repeat">
+      <a:schemeClr val="accent1"/>
+    </dgm:linClrLst>
+    <dgm:effectClrLst/>
+    <dgm:txLinClrLst/>
+    <dgm:txFillClrLst meth="repeat">
+      <a:schemeClr val="dk1"/>
+    </dgm:txFillClrLst>
+    <dgm:txEffectClrLst/>
+  </dgm:styleLbl>
+  <dgm:styleLbl name="bgShp">
+    <dgm:fillClrLst meth="repeat">
+      <a:schemeClr val="accent1">
+        <a:tint val="40000"/>
+      </a:schemeClr>
+    </dgm:fillClrLst>
+    <dgm:linClrLst meth="repeat">
+      <a:schemeClr val="accent1"/>
+    </dgm:linClrLst>
+    <dgm:effectClrLst/>
+    <dgm:txLinClrLst/>
+    <dgm:txFillClrLst meth="repeat">
+      <a:schemeClr val="dk1"/>
+    </dgm:txFillClrLst>
+    <dgm:txEffectClrLst/>
+  </dgm:styleLbl>
+  <dgm:styleLbl name="dkBgShp">
+    <dgm:fillClrLst meth="repeat">
+      <a:schemeClr val="accent1">
+        <a:shade val="80000"/>
+      </a:schemeClr>
+    </dgm:fillClrLst>
+    <dgm:linClrLst meth="repeat">
+      <a:schemeClr val="accent1"/>
+    </dgm:linClrLst>
+    <dgm:effectClrLst/>
+    <dgm:txLinClrLst/>
+    <dgm:txFillClrLst meth="repeat">
+      <a:schemeClr val="lt1"/>
+    </dgm:txFillClrLst>
+    <dgm:txEffectClrLst/>
+  </dgm:styleLbl>
+  <dgm:styleLbl name="trBgShp">
+    <dgm:fillClrLst meth="repeat">
+      <a:schemeClr val="accent1">
+        <a:tint val="50000"/>
+        <a:alpha val="40000"/>
+      </a:schemeClr>
+    </dgm:fillClrLst>
+    <dgm:linClrLst meth="repeat">
+      <a:schemeClr val="accent1"/>
+    </dgm:linClrLst>
+    <dgm:effectClrLst/>
+    <dgm:txLinClrLst/>
+    <dgm:txFillClrLst meth="repeat">
+      <a:schemeClr val="lt1"/>
+    </dgm:txFillClrLst>
+    <dgm:txEffectClrLst/>
+  </dgm:styleLbl>
+  <dgm:styleLbl name="fgShp">
+    <dgm:fillClrLst meth="repeat">
+      <a:schemeClr val="accent1">
+        <a:tint val="60000"/>
+      </a:schemeClr>
+    </dgm:fillClrLst>
+    <dgm:linClrLst meth="repeat">
+      <a:schemeClr val="lt1"/>
+    </dgm:linClrLst>
+    <dgm:effectClrLst/>
+    <dgm:txLinClrLst/>
+    <dgm:txFillClrLst meth="repeat">
+      <a:schemeClr val="dk1"/>
+    </dgm:txFillClrLst>
+    <dgm:txEffectClrLst/>
+  </dgm:styleLbl>
+  <dgm:styleLbl name="revTx">
+    <dgm:fillClrLst meth="repeat">
+      <a:schemeClr val="lt1">
+        <a:alpha val="0"/>
+      </a:schemeClr>
+    </dgm:fillClrLst>
+    <dgm:linClrLst meth="repeat">
+      <a:schemeClr val="dk1">
+        <a:alpha val="0"/>
+      </a:schemeClr>
+    </dgm:linClrLst>
+    <dgm:effectClrLst/>
+    <dgm:txLinClrLst/>
+    <dgm:txFillClrLst meth="repeat">
+      <a:schemeClr val="tx1"/>
+    </dgm:txFillClrLst>
+    <dgm:txEffectClrLst/>
+  </dgm:styleLbl>
+</dgm:colorsDef>
+</file>
+
+<file path=ppt/diagrams/data1.xml><?xml version="1.0" encoding="utf-8"?>
+<dgm:dataModel xmlns:dgm="http://schemas.openxmlformats.org/drawingml/2006/diagram" xmlns:a="http://schemas.openxmlformats.org/drawingml/2006/main">
+  <dgm:ptLst>
+    <dgm:pt modelId="{DF5A7E0E-00B7-4A9C-A3C3-ECB4D9BF32BC}" type="doc">
+      <dgm:prSet loTypeId="urn:microsoft.com/office/officeart/2018/2/layout/IconCircleList" loCatId="icon" qsTypeId="urn:microsoft.com/office/officeart/2005/8/quickstyle/simple1" qsCatId="simple" csTypeId="urn:microsoft.com/office/officeart/2005/8/colors/accent1_2" csCatId="accent1" phldr="1"/>
+      <dgm:spPr/>
+      <dgm:t>
+        <a:bodyPr/>
+        <a:lstStyle/>
+        <a:p>
+          <a:endParaRPr lang="en-US"/>
+        </a:p>
+      </dgm:t>
+    </dgm:pt>
+    <dgm:pt modelId="{694B7AF4-3A8B-4ADF-926E-D04343A67A5B}">
+      <dgm:prSet custT="1"/>
+      <dgm:spPr/>
+      <dgm:t>
+        <a:bodyPr/>
+        <a:lstStyle/>
+        <a:p>
+          <a:pPr>
+            <a:lnSpc>
+              <a:spcPct val="100000"/>
+            </a:lnSpc>
+          </a:pPr>
+          <a:r>
+            <a:rPr lang="en-GB" sz="2000" dirty="0"/>
+            <a:t>Python - Main Programming Language</a:t>
+          </a:r>
+          <a:endParaRPr lang="en-US" sz="2000" dirty="0"/>
+        </a:p>
+      </dgm:t>
+    </dgm:pt>
+    <dgm:pt modelId="{52F53AF0-7B6B-477F-BFA1-7477333598B6}" type="parTrans" cxnId="{8563A864-B2CF-4112-B3EA-459656073B2C}">
+      <dgm:prSet/>
+      <dgm:spPr/>
+      <dgm:t>
+        <a:bodyPr/>
+        <a:lstStyle/>
+        <a:p>
+          <a:endParaRPr lang="en-US"/>
+        </a:p>
+      </dgm:t>
+    </dgm:pt>
+    <dgm:pt modelId="{E2B6EA70-59A0-4B65-AAAD-E68BF09AE32C}" type="sibTrans" cxnId="{8563A864-B2CF-4112-B3EA-459656073B2C}">
+      <dgm:prSet/>
+      <dgm:spPr/>
+      <dgm:t>
+        <a:bodyPr/>
+        <a:lstStyle/>
+        <a:p>
+          <a:pPr>
+            <a:lnSpc>
+              <a:spcPct val="100000"/>
+            </a:lnSpc>
+          </a:pPr>
+          <a:endParaRPr lang="en-US"/>
+        </a:p>
+      </dgm:t>
+    </dgm:pt>
+    <dgm:pt modelId="{FAE58B5E-C93F-41D0-A6F6-D1E16200C15F}">
+      <dgm:prSet custT="1"/>
+      <dgm:spPr/>
+      <dgm:t>
+        <a:bodyPr/>
+        <a:lstStyle/>
+        <a:p>
+          <a:pPr>
+            <a:lnSpc>
+              <a:spcPct val="100000"/>
+            </a:lnSpc>
+          </a:pPr>
+          <a:r>
+            <a:rPr lang="en-GB" sz="2000" dirty="0"/>
+            <a:t>YOLO - Object Detection  </a:t>
+          </a:r>
+          <a:endParaRPr lang="en-US" sz="2000" dirty="0"/>
+        </a:p>
+      </dgm:t>
+    </dgm:pt>
+    <dgm:pt modelId="{3F225B14-8235-484D-8566-E644604961F1}" type="parTrans" cxnId="{560700C7-0D7A-401A-96D6-21BE1D10372B}">
+      <dgm:prSet/>
+      <dgm:spPr/>
+      <dgm:t>
+        <a:bodyPr/>
+        <a:lstStyle/>
+        <a:p>
+          <a:endParaRPr lang="en-US"/>
+        </a:p>
+      </dgm:t>
+    </dgm:pt>
+    <dgm:pt modelId="{E5B63A6D-49F9-4FFB-98B2-A8BE431F9CD6}" type="sibTrans" cxnId="{560700C7-0D7A-401A-96D6-21BE1D10372B}">
+      <dgm:prSet/>
+      <dgm:spPr/>
+      <dgm:t>
+        <a:bodyPr/>
+        <a:lstStyle/>
+        <a:p>
+          <a:pPr>
+            <a:lnSpc>
+              <a:spcPct val="100000"/>
+            </a:lnSpc>
+          </a:pPr>
+          <a:endParaRPr lang="en-US"/>
+        </a:p>
+      </dgm:t>
+    </dgm:pt>
+    <dgm:pt modelId="{A936FE28-DE30-4F99-9D61-A0E9F5DEDAEB}">
+      <dgm:prSet custT="1"/>
+      <dgm:spPr/>
+      <dgm:t>
+        <a:bodyPr/>
+        <a:lstStyle/>
+        <a:p>
+          <a:pPr>
+            <a:lnSpc>
+              <a:spcPct val="100000"/>
+            </a:lnSpc>
+          </a:pPr>
+          <a:r>
+            <a:rPr lang="en-GB" sz="2000" dirty="0" err="1"/>
+            <a:t>Ultralytics</a:t>
+          </a:r>
+          <a:r>
+            <a:rPr lang="en-GB" sz="2000" dirty="0"/>
+            <a:t> - Framework</a:t>
+          </a:r>
+          <a:endParaRPr lang="en-US" sz="2000" dirty="0"/>
+        </a:p>
+      </dgm:t>
+    </dgm:pt>
+    <dgm:pt modelId="{56422E37-A5DC-436A-AEFC-E932DC9A3BB8}" type="parTrans" cxnId="{AD7BDC29-341E-45F4-AC6D-EDB5812013E3}">
+      <dgm:prSet/>
+      <dgm:spPr/>
+      <dgm:t>
+        <a:bodyPr/>
+        <a:lstStyle/>
+        <a:p>
+          <a:endParaRPr lang="en-US"/>
+        </a:p>
+      </dgm:t>
+    </dgm:pt>
+    <dgm:pt modelId="{533C9DD2-E670-4E24-8788-2DFF1C707758}" type="sibTrans" cxnId="{AD7BDC29-341E-45F4-AC6D-EDB5812013E3}">
+      <dgm:prSet/>
+      <dgm:spPr/>
+      <dgm:t>
+        <a:bodyPr/>
+        <a:lstStyle/>
+        <a:p>
+          <a:pPr>
+            <a:lnSpc>
+              <a:spcPct val="100000"/>
+            </a:lnSpc>
+          </a:pPr>
+          <a:endParaRPr lang="en-US"/>
+        </a:p>
+      </dgm:t>
+    </dgm:pt>
+    <dgm:pt modelId="{05172726-9EC8-4DAB-9C24-AF72B6B26FE5}">
+      <dgm:prSet custT="1"/>
+      <dgm:spPr/>
+      <dgm:t>
+        <a:bodyPr/>
+        <a:lstStyle/>
+        <a:p>
+          <a:pPr>
+            <a:lnSpc>
+              <a:spcPct val="100000"/>
+            </a:lnSpc>
+          </a:pPr>
+          <a:r>
+            <a:rPr lang="en-GB" sz="2000" dirty="0"/>
+            <a:t>OpenCV – Computer Vision Library</a:t>
+          </a:r>
+          <a:endParaRPr lang="en-US" sz="2000" dirty="0"/>
+        </a:p>
+      </dgm:t>
+    </dgm:pt>
+    <dgm:pt modelId="{73FFB3CB-7C33-41DD-8A12-882B39708925}" type="parTrans" cxnId="{51E24B2F-0359-432E-85DB-CAB8CA647DA9}">
+      <dgm:prSet/>
+      <dgm:spPr/>
+      <dgm:t>
+        <a:bodyPr/>
+        <a:lstStyle/>
+        <a:p>
+          <a:endParaRPr lang="en-US"/>
+        </a:p>
+      </dgm:t>
+    </dgm:pt>
+    <dgm:pt modelId="{AA1BEEFC-D513-46CB-9B46-15F5BB078A9E}" type="sibTrans" cxnId="{51E24B2F-0359-432E-85DB-CAB8CA647DA9}">
+      <dgm:prSet/>
+      <dgm:spPr/>
+      <dgm:t>
+        <a:bodyPr/>
+        <a:lstStyle/>
+        <a:p>
+          <a:pPr>
+            <a:lnSpc>
+              <a:spcPct val="100000"/>
+            </a:lnSpc>
+          </a:pPr>
+          <a:endParaRPr lang="en-US"/>
+        </a:p>
+      </dgm:t>
+    </dgm:pt>
+    <dgm:pt modelId="{472CDD00-1D69-4A6B-8AC4-8A36F0E79CA1}">
+      <dgm:prSet custT="1"/>
+      <dgm:spPr/>
+      <dgm:t>
+        <a:bodyPr/>
+        <a:lstStyle/>
+        <a:p>
+          <a:pPr>
+            <a:lnSpc>
+              <a:spcPct val="100000"/>
+            </a:lnSpc>
+          </a:pPr>
+          <a:r>
+            <a:rPr lang="en-GB" sz="2000" dirty="0"/>
+            <a:t>Flask – Web Framework</a:t>
+          </a:r>
+          <a:endParaRPr lang="en-US" sz="2000" dirty="0"/>
+        </a:p>
+      </dgm:t>
+    </dgm:pt>
+    <dgm:pt modelId="{8E9D8986-50DA-4A02-84B3-0AF8D257A10B}" type="parTrans" cxnId="{D3D34EF3-A831-4F86-A88B-1FE184433EC2}">
+      <dgm:prSet/>
+      <dgm:spPr/>
+      <dgm:t>
+        <a:bodyPr/>
+        <a:lstStyle/>
+        <a:p>
+          <a:endParaRPr lang="en-US"/>
+        </a:p>
+      </dgm:t>
+    </dgm:pt>
+    <dgm:pt modelId="{C9B88B39-EB2D-4ABF-8671-D02D136D903F}" type="sibTrans" cxnId="{D3D34EF3-A831-4F86-A88B-1FE184433EC2}">
+      <dgm:prSet/>
+      <dgm:spPr/>
+      <dgm:t>
+        <a:bodyPr/>
+        <a:lstStyle/>
+        <a:p>
+          <a:pPr>
+            <a:lnSpc>
+              <a:spcPct val="100000"/>
+            </a:lnSpc>
+          </a:pPr>
+          <a:endParaRPr lang="en-US"/>
+        </a:p>
+      </dgm:t>
+    </dgm:pt>
+    <dgm:pt modelId="{6153FF18-8BD2-45BB-854A-CD8632CDC26A}">
+      <dgm:prSet/>
+      <dgm:spPr/>
+      <dgm:t>
+        <a:bodyPr/>
+        <a:lstStyle/>
+        <a:p>
+          <a:pPr>
+            <a:lnSpc>
+              <a:spcPct val="100000"/>
+            </a:lnSpc>
+          </a:pPr>
+          <a:r>
+            <a:rPr lang="en-GB"/>
+            <a:t>React – Front End</a:t>
+          </a:r>
+          <a:endParaRPr lang="en-US"/>
+        </a:p>
+      </dgm:t>
+    </dgm:pt>
+    <dgm:pt modelId="{3F312DDF-C86D-4D1A-BEA9-CA1ED720A1E9}" type="parTrans" cxnId="{E4931362-CEA6-46A7-8B79-64FE4862E462}">
+      <dgm:prSet/>
+      <dgm:spPr/>
+      <dgm:t>
+        <a:bodyPr/>
+        <a:lstStyle/>
+        <a:p>
+          <a:endParaRPr lang="en-US"/>
+        </a:p>
+      </dgm:t>
+    </dgm:pt>
+    <dgm:pt modelId="{5A6C4911-DC52-4C0C-AB33-5529B1A85664}" type="sibTrans" cxnId="{E4931362-CEA6-46A7-8B79-64FE4862E462}">
+      <dgm:prSet/>
+      <dgm:spPr/>
+      <dgm:t>
+        <a:bodyPr/>
+        <a:lstStyle/>
+        <a:p>
+          <a:pPr>
+            <a:lnSpc>
+              <a:spcPct val="100000"/>
+            </a:lnSpc>
+          </a:pPr>
+          <a:endParaRPr lang="en-US"/>
+        </a:p>
+      </dgm:t>
+    </dgm:pt>
+    <dgm:pt modelId="{D4B3BAF0-1DFF-452A-8E9F-7F6DAEDD5259}">
+      <dgm:prSet custT="1"/>
+      <dgm:spPr/>
+      <dgm:t>
+        <a:bodyPr/>
+        <a:lstStyle/>
+        <a:p>
+          <a:pPr>
+            <a:lnSpc>
+              <a:spcPct val="100000"/>
+            </a:lnSpc>
+          </a:pPr>
+          <a:r>
+            <a:rPr lang="en-GB" sz="2000" dirty="0"/>
+            <a:t>SMTP – Email Service</a:t>
+          </a:r>
+          <a:endParaRPr lang="en-US" sz="2000" dirty="0"/>
+        </a:p>
+      </dgm:t>
+    </dgm:pt>
+    <dgm:pt modelId="{529EDF02-577C-4951-983B-D7146AD68EE1}" type="parTrans" cxnId="{057C216F-C623-4183-9313-45DF76E23918}">
+      <dgm:prSet/>
+      <dgm:spPr/>
+      <dgm:t>
+        <a:bodyPr/>
+        <a:lstStyle/>
+        <a:p>
+          <a:endParaRPr lang="en-US"/>
+        </a:p>
+      </dgm:t>
+    </dgm:pt>
+    <dgm:pt modelId="{37073D6E-DE9C-466D-B8A7-DA360793B53F}" type="sibTrans" cxnId="{057C216F-C623-4183-9313-45DF76E23918}">
+      <dgm:prSet/>
+      <dgm:spPr/>
+      <dgm:t>
+        <a:bodyPr/>
+        <a:lstStyle/>
+        <a:p>
+          <a:pPr>
+            <a:lnSpc>
+              <a:spcPct val="100000"/>
+            </a:lnSpc>
+          </a:pPr>
+          <a:endParaRPr lang="en-US"/>
+        </a:p>
+      </dgm:t>
+    </dgm:pt>
+    <dgm:pt modelId="{E3A74F75-AC17-48AD-A734-885D21E05F60}">
+      <dgm:prSet/>
+      <dgm:spPr/>
+      <dgm:t>
+        <a:bodyPr/>
+        <a:lstStyle/>
+        <a:p>
+          <a:pPr>
+            <a:lnSpc>
+              <a:spcPct val="100000"/>
+            </a:lnSpc>
+          </a:pPr>
+          <a:r>
+            <a:rPr lang="en-GB"/>
+            <a:t>MySQL - Database</a:t>
+          </a:r>
+          <a:endParaRPr lang="en-US"/>
+        </a:p>
+      </dgm:t>
+    </dgm:pt>
+    <dgm:pt modelId="{A78D69D4-C481-4375-86E7-E6DA0FDB81C4}" type="parTrans" cxnId="{4FC51E18-3D43-40B6-8ABD-C8F0DD2AADFE}">
+      <dgm:prSet/>
+      <dgm:spPr/>
+      <dgm:t>
+        <a:bodyPr/>
+        <a:lstStyle/>
+        <a:p>
+          <a:endParaRPr lang="en-US"/>
+        </a:p>
+      </dgm:t>
+    </dgm:pt>
+    <dgm:pt modelId="{476BB39E-B252-4D9F-A234-5C771C87B329}" type="sibTrans" cxnId="{4FC51E18-3D43-40B6-8ABD-C8F0DD2AADFE}">
+      <dgm:prSet/>
+      <dgm:spPr/>
+      <dgm:t>
+        <a:bodyPr/>
+        <a:lstStyle/>
+        <a:p>
+          <a:endParaRPr lang="en-US"/>
+        </a:p>
+      </dgm:t>
+    </dgm:pt>
+    <dgm:pt modelId="{F81935D9-ED78-4E69-99F9-0E39E5576FC3}" type="pres">
+      <dgm:prSet presAssocID="{DF5A7E0E-00B7-4A9C-A3C3-ECB4D9BF32BC}" presName="root" presStyleCnt="0">
+        <dgm:presLayoutVars>
+          <dgm:dir/>
+          <dgm:resizeHandles val="exact"/>
+        </dgm:presLayoutVars>
+      </dgm:prSet>
+      <dgm:spPr/>
+    </dgm:pt>
+    <dgm:pt modelId="{522A7C9A-4EA9-4DDE-996C-76B8BD70627D}" type="pres">
+      <dgm:prSet presAssocID="{DF5A7E0E-00B7-4A9C-A3C3-ECB4D9BF32BC}" presName="container" presStyleCnt="0">
+        <dgm:presLayoutVars>
+          <dgm:dir/>
+          <dgm:resizeHandles val="exact"/>
+        </dgm:presLayoutVars>
+      </dgm:prSet>
+      <dgm:spPr/>
+    </dgm:pt>
+    <dgm:pt modelId="{4E6D419B-BC5A-4E67-8223-0A4521DD8DB4}" type="pres">
+      <dgm:prSet presAssocID="{694B7AF4-3A8B-4ADF-926E-D04343A67A5B}" presName="compNode" presStyleCnt="0"/>
+      <dgm:spPr/>
+    </dgm:pt>
+    <dgm:pt modelId="{2AD9908B-4848-434F-9EFE-0BC3A842C512}" type="pres">
+      <dgm:prSet presAssocID="{694B7AF4-3A8B-4ADF-926E-D04343A67A5B}" presName="iconBgRect" presStyleLbl="bgShp" presStyleIdx="0" presStyleCnt="8"/>
+      <dgm:spPr/>
+    </dgm:pt>
+    <dgm:pt modelId="{4BAE8EAF-ADBE-4539-806A-4E0C49C7972A}" type="pres">
+      <dgm:prSet presAssocID="{694B7AF4-3A8B-4ADF-926E-D04343A67A5B}" presName="iconRect" presStyleLbl="node1" presStyleIdx="0" presStyleCnt="8"/>
+      <dgm:spPr>
+        <a:blipFill>
+          <a:blip xmlns:r="http://schemas.openxmlformats.org/officeDocument/2006/relationships" r:embed="rId1">
+            <a:extLst>
+              <a:ext uri="{28A0092B-C50C-407E-A947-70E740481C1C}">
+                <a14:useLocalDpi xmlns:a14="http://schemas.microsoft.com/office/drawing/2010/main" val="0"/>
+              </a:ext>
+              <a:ext uri="{96DAC541-7B7A-43D3-8B79-37D633B846F1}">
+                <asvg:svgBlip xmlns:asvg="http://schemas.microsoft.com/office/drawing/2016/SVG/main" r:embed="rId2"/>
+              </a:ext>
+            </a:extLst>
+          </a:blip>
+          <a:stretch>
+            <a:fillRect/>
+          </a:stretch>
+        </a:blipFill>
+      </dgm:spPr>
+      <dgm:extLst>
+        <a:ext uri="{E40237B7-FDA0-4F09-8148-C483321AD2D9}">
+          <dgm14:cNvPr xmlns:dgm14="http://schemas.microsoft.com/office/drawing/2010/diagram" id="0" name="" descr="Web Design"/>
+        </a:ext>
+      </dgm:extLst>
+    </dgm:pt>
+    <dgm:pt modelId="{5A72B12D-36FB-4963-A09D-CABBD85A79D8}" type="pres">
+      <dgm:prSet presAssocID="{694B7AF4-3A8B-4ADF-926E-D04343A67A5B}" presName="spaceRect" presStyleCnt="0"/>
+      <dgm:spPr/>
+    </dgm:pt>
+    <dgm:pt modelId="{78D769C6-C2A1-4934-8341-175D00ECACE4}" type="pres">
+      <dgm:prSet presAssocID="{694B7AF4-3A8B-4ADF-926E-D04343A67A5B}" presName="textRect" presStyleLbl="revTx" presStyleIdx="0" presStyleCnt="8">
+        <dgm:presLayoutVars>
+          <dgm:chMax val="1"/>
+          <dgm:chPref val="1"/>
+        </dgm:presLayoutVars>
+      </dgm:prSet>
+      <dgm:spPr/>
+    </dgm:pt>
+    <dgm:pt modelId="{0DBA7B9D-6474-46AF-881B-D93034A3AFDD}" type="pres">
+      <dgm:prSet presAssocID="{E2B6EA70-59A0-4B65-AAAD-E68BF09AE32C}" presName="sibTrans" presStyleLbl="sibTrans2D1" presStyleIdx="0" presStyleCnt="0"/>
+      <dgm:spPr/>
+    </dgm:pt>
+    <dgm:pt modelId="{3B2DC819-7056-4EAE-AEA4-9FD9879A0ADE}" type="pres">
+      <dgm:prSet presAssocID="{FAE58B5E-C93F-41D0-A6F6-D1E16200C15F}" presName="compNode" presStyleCnt="0"/>
+      <dgm:spPr/>
+    </dgm:pt>
+    <dgm:pt modelId="{6429BE27-F80E-40E8-AD6E-BCF5F22ACF2F}" type="pres">
+      <dgm:prSet presAssocID="{FAE58B5E-C93F-41D0-A6F6-D1E16200C15F}" presName="iconBgRect" presStyleLbl="bgShp" presStyleIdx="1" presStyleCnt="8"/>
+      <dgm:spPr/>
+    </dgm:pt>
+    <dgm:pt modelId="{906EF14B-2438-4714-AD22-63842EB6F1E0}" type="pres">
+      <dgm:prSet presAssocID="{FAE58B5E-C93F-41D0-A6F6-D1E16200C15F}" presName="iconRect" presStyleLbl="node1" presStyleIdx="1" presStyleCnt="8"/>
+      <dgm:spPr>
+        <a:blipFill>
+          <a:blip xmlns:r="http://schemas.openxmlformats.org/officeDocument/2006/relationships" r:embed="rId3">
+            <a:extLst>
+              <a:ext uri="{28A0092B-C50C-407E-A947-70E740481C1C}">
+                <a14:useLocalDpi xmlns:a14="http://schemas.microsoft.com/office/drawing/2010/main" val="0"/>
+              </a:ext>
+              <a:ext uri="{96DAC541-7B7A-43D3-8B79-37D633B846F1}">
+                <asvg:svgBlip xmlns:asvg="http://schemas.microsoft.com/office/drawing/2016/SVG/main" r:embed="rId4"/>
+              </a:ext>
+            </a:extLst>
+          </a:blip>
+          <a:stretch>
+            <a:fillRect/>
+          </a:stretch>
+        </a:blipFill>
+      </dgm:spPr>
+      <dgm:extLst>
+        <a:ext uri="{E40237B7-FDA0-4F09-8148-C483321AD2D9}">
+          <dgm14:cNvPr xmlns:dgm14="http://schemas.microsoft.com/office/drawing/2010/diagram" id="0" name="" descr="Camera"/>
+        </a:ext>
+      </dgm:extLst>
+    </dgm:pt>
+    <dgm:pt modelId="{FE623779-3B7E-40B4-B073-2778679AA538}" type="pres">
+      <dgm:prSet presAssocID="{FAE58B5E-C93F-41D0-A6F6-D1E16200C15F}" presName="spaceRect" presStyleCnt="0"/>
+      <dgm:spPr/>
+    </dgm:pt>
+    <dgm:pt modelId="{014EF6EE-6A61-415B-9F59-82878761BCF6}" type="pres">
+      <dgm:prSet presAssocID="{FAE58B5E-C93F-41D0-A6F6-D1E16200C15F}" presName="textRect" presStyleLbl="revTx" presStyleIdx="1" presStyleCnt="8">
+        <dgm:presLayoutVars>
+          <dgm:chMax val="1"/>
+          <dgm:chPref val="1"/>
+        </dgm:presLayoutVars>
+      </dgm:prSet>
+      <dgm:spPr/>
+    </dgm:pt>
+    <dgm:pt modelId="{CAABA910-E77F-4BBA-AB26-EFAF7D5A42B3}" type="pres">
+      <dgm:prSet presAssocID="{E5B63A6D-49F9-4FFB-98B2-A8BE431F9CD6}" presName="sibTrans" presStyleLbl="sibTrans2D1" presStyleIdx="0" presStyleCnt="0"/>
+      <dgm:spPr/>
+    </dgm:pt>
+    <dgm:pt modelId="{6156EBE7-C30F-4D08-9FA5-70E13AC42593}" type="pres">
+      <dgm:prSet presAssocID="{A936FE28-DE30-4F99-9D61-A0E9F5DEDAEB}" presName="compNode" presStyleCnt="0"/>
+      <dgm:spPr/>
+    </dgm:pt>
+    <dgm:pt modelId="{93EFC311-3163-4675-AD5A-7C5466D8B716}" type="pres">
+      <dgm:prSet presAssocID="{A936FE28-DE30-4F99-9D61-A0E9F5DEDAEB}" presName="iconBgRect" presStyleLbl="bgShp" presStyleIdx="2" presStyleCnt="8"/>
+      <dgm:spPr/>
+    </dgm:pt>
+    <dgm:pt modelId="{D53E28EE-343E-461D-B22A-DCB62CB19F62}" type="pres">
+      <dgm:prSet presAssocID="{A936FE28-DE30-4F99-9D61-A0E9F5DEDAEB}" presName="iconRect" presStyleLbl="node1" presStyleIdx="2" presStyleCnt="8"/>
+      <dgm:spPr>
+        <a:blipFill>
+          <a:blip xmlns:r="http://schemas.openxmlformats.org/officeDocument/2006/relationships" r:embed="rId5">
+            <a:extLst>
+              <a:ext uri="{28A0092B-C50C-407E-A947-70E740481C1C}">
+                <a14:useLocalDpi xmlns:a14="http://schemas.microsoft.com/office/drawing/2010/main" val="0"/>
+              </a:ext>
+              <a:ext uri="{96DAC541-7B7A-43D3-8B79-37D633B846F1}">
+                <asvg:svgBlip xmlns:asvg="http://schemas.microsoft.com/office/drawing/2016/SVG/main" r:embed="rId6"/>
+              </a:ext>
+            </a:extLst>
+          </a:blip>
+          <a:stretch>
+            <a:fillRect/>
+          </a:stretch>
+        </a:blipFill>
+      </dgm:spPr>
+      <dgm:extLst>
+        <a:ext uri="{E40237B7-FDA0-4F09-8148-C483321AD2D9}">
+          <dgm14:cNvPr xmlns:dgm14="http://schemas.microsoft.com/office/drawing/2010/diagram" id="0" name="" descr="Hierarchy"/>
+        </a:ext>
+      </dgm:extLst>
+    </dgm:pt>
+    <dgm:pt modelId="{5BF33D79-4656-41CD-A6E8-A83A4A468FC5}" type="pres">
+      <dgm:prSet presAssocID="{A936FE28-DE30-4F99-9D61-A0E9F5DEDAEB}" presName="spaceRect" presStyleCnt="0"/>
+      <dgm:spPr/>
+    </dgm:pt>
+    <dgm:pt modelId="{B2D728B1-EBB0-4B82-A07E-5A89FFDCFC6C}" type="pres">
+      <dgm:prSet presAssocID="{A936FE28-DE30-4F99-9D61-A0E9F5DEDAEB}" presName="textRect" presStyleLbl="revTx" presStyleIdx="2" presStyleCnt="8">
+        <dgm:presLayoutVars>
+          <dgm:chMax val="1"/>
+          <dgm:chPref val="1"/>
+        </dgm:presLayoutVars>
+      </dgm:prSet>
+      <dgm:spPr/>
+    </dgm:pt>
+    <dgm:pt modelId="{1B1B7DA3-360E-4232-A669-53A1E80E14B7}" type="pres">
+      <dgm:prSet presAssocID="{533C9DD2-E670-4E24-8788-2DFF1C707758}" presName="sibTrans" presStyleLbl="sibTrans2D1" presStyleIdx="0" presStyleCnt="0"/>
+      <dgm:spPr/>
+    </dgm:pt>
+    <dgm:pt modelId="{4B0EE68C-2568-4B79-8471-A9098B85DB20}" type="pres">
+      <dgm:prSet presAssocID="{05172726-9EC8-4DAB-9C24-AF72B6B26FE5}" presName="compNode" presStyleCnt="0"/>
+      <dgm:spPr/>
+    </dgm:pt>
+    <dgm:pt modelId="{D086BA99-BDD5-4735-80BD-B0517490BB2B}" type="pres">
+      <dgm:prSet presAssocID="{05172726-9EC8-4DAB-9C24-AF72B6B26FE5}" presName="iconBgRect" presStyleLbl="bgShp" presStyleIdx="3" presStyleCnt="8"/>
+      <dgm:spPr/>
+    </dgm:pt>
+    <dgm:pt modelId="{31A3621F-3969-491A-A712-E795557EBBD1}" type="pres">
+      <dgm:prSet presAssocID="{05172726-9EC8-4DAB-9C24-AF72B6B26FE5}" presName="iconRect" presStyleLbl="node1" presStyleIdx="3" presStyleCnt="8"/>
+      <dgm:spPr>
+        <a:blipFill>
+          <a:blip xmlns:r="http://schemas.openxmlformats.org/officeDocument/2006/relationships" r:embed="rId7">
+            <a:extLst>
+              <a:ext uri="{28A0092B-C50C-407E-A947-70E740481C1C}">
+                <a14:useLocalDpi xmlns:a14="http://schemas.microsoft.com/office/drawing/2010/main" val="0"/>
+              </a:ext>
+              <a:ext uri="{96DAC541-7B7A-43D3-8B79-37D633B846F1}">
+                <asvg:svgBlip xmlns:asvg="http://schemas.microsoft.com/office/drawing/2016/SVG/main" r:embed="rId8"/>
+              </a:ext>
+            </a:extLst>
+          </a:blip>
+          <a:stretch>
+            <a:fillRect/>
+          </a:stretch>
+        </a:blipFill>
+      </dgm:spPr>
+      <dgm:extLst>
+        <a:ext uri="{E40237B7-FDA0-4F09-8148-C483321AD2D9}">
+          <dgm14:cNvPr xmlns:dgm14="http://schemas.microsoft.com/office/drawing/2010/diagram" id="0" name="" descr="Books on Shelf"/>
+        </a:ext>
+      </dgm:extLst>
+    </dgm:pt>
+    <dgm:pt modelId="{55E9C20E-C647-45FF-870D-25E0975085F5}" type="pres">
+      <dgm:prSet presAssocID="{05172726-9EC8-4DAB-9C24-AF72B6B26FE5}" presName="spaceRect" presStyleCnt="0"/>
+      <dgm:spPr/>
+    </dgm:pt>
+    <dgm:pt modelId="{849CD35C-B223-47BF-8151-9396B4E709FE}" type="pres">
+      <dgm:prSet presAssocID="{05172726-9EC8-4DAB-9C24-AF72B6B26FE5}" presName="textRect" presStyleLbl="revTx" presStyleIdx="3" presStyleCnt="8">
+        <dgm:presLayoutVars>
+          <dgm:chMax val="1"/>
+          <dgm:chPref val="1"/>
+        </dgm:presLayoutVars>
+      </dgm:prSet>
+      <dgm:spPr/>
+    </dgm:pt>
+    <dgm:pt modelId="{EA867568-FABB-40E0-A8DC-2830EDAED5E9}" type="pres">
+      <dgm:prSet presAssocID="{AA1BEEFC-D513-46CB-9B46-15F5BB078A9E}" presName="sibTrans" presStyleLbl="sibTrans2D1" presStyleIdx="0" presStyleCnt="0"/>
+      <dgm:spPr/>
+    </dgm:pt>
+    <dgm:pt modelId="{B4793F64-45F5-41AF-8C7D-3B30C8F64560}" type="pres">
+      <dgm:prSet presAssocID="{472CDD00-1D69-4A6B-8AC4-8A36F0E79CA1}" presName="compNode" presStyleCnt="0"/>
+      <dgm:spPr/>
+    </dgm:pt>
+    <dgm:pt modelId="{230E90DD-B592-4283-A161-126B3624F6DA}" type="pres">
+      <dgm:prSet presAssocID="{472CDD00-1D69-4A6B-8AC4-8A36F0E79CA1}" presName="iconBgRect" presStyleLbl="bgShp" presStyleIdx="4" presStyleCnt="8"/>
+      <dgm:spPr/>
+    </dgm:pt>
+    <dgm:pt modelId="{1E2A6E66-6D92-4B3C-946C-D067F50F008C}" type="pres">
+      <dgm:prSet presAssocID="{472CDD00-1D69-4A6B-8AC4-8A36F0E79CA1}" presName="iconRect" presStyleLbl="node1" presStyleIdx="4" presStyleCnt="8"/>
+      <dgm:spPr>
+        <a:blipFill>
+          <a:blip xmlns:r="http://schemas.openxmlformats.org/officeDocument/2006/relationships" r:embed="rId9">
+            <a:extLst>
+              <a:ext uri="{28A0092B-C50C-407E-A947-70E740481C1C}">
+                <a14:useLocalDpi xmlns:a14="http://schemas.microsoft.com/office/drawing/2010/main" val="0"/>
+              </a:ext>
+              <a:ext uri="{96DAC541-7B7A-43D3-8B79-37D633B846F1}">
+                <asvg:svgBlip xmlns:asvg="http://schemas.microsoft.com/office/drawing/2016/SVG/main" r:embed="rId10"/>
+              </a:ext>
+            </a:extLst>
+          </a:blip>
+          <a:stretch>
+            <a:fillRect/>
+          </a:stretch>
+        </a:blipFill>
+      </dgm:spPr>
+      <dgm:extLst>
+        <a:ext uri="{E40237B7-FDA0-4F09-8148-C483321AD2D9}">
+          <dgm14:cNvPr xmlns:dgm14="http://schemas.microsoft.com/office/drawing/2010/diagram" id="0" name="" descr="Flask"/>
+        </a:ext>
+      </dgm:extLst>
+    </dgm:pt>
+    <dgm:pt modelId="{B773059A-2183-4C7C-A11B-AF404735963D}" type="pres">
+      <dgm:prSet presAssocID="{472CDD00-1D69-4A6B-8AC4-8A36F0E79CA1}" presName="spaceRect" presStyleCnt="0"/>
+      <dgm:spPr/>
+    </dgm:pt>
+    <dgm:pt modelId="{2C92A4C9-A4A1-486F-BB11-2CE4FCC41BC8}" type="pres">
+      <dgm:prSet presAssocID="{472CDD00-1D69-4A6B-8AC4-8A36F0E79CA1}" presName="textRect" presStyleLbl="revTx" presStyleIdx="4" presStyleCnt="8">
+        <dgm:presLayoutVars>
+          <dgm:chMax val="1"/>
+          <dgm:chPref val="1"/>
+        </dgm:presLayoutVars>
+      </dgm:prSet>
+      <dgm:spPr/>
+    </dgm:pt>
+    <dgm:pt modelId="{688FBCBE-48AB-492D-A16C-7647775AC9B3}" type="pres">
+      <dgm:prSet presAssocID="{C9B88B39-EB2D-4ABF-8671-D02D136D903F}" presName="sibTrans" presStyleLbl="sibTrans2D1" presStyleIdx="0" presStyleCnt="0"/>
+      <dgm:spPr/>
+    </dgm:pt>
+    <dgm:pt modelId="{B5B05572-F54B-4E8A-95F5-3023B86A8F6C}" type="pres">
+      <dgm:prSet presAssocID="{6153FF18-8BD2-45BB-854A-CD8632CDC26A}" presName="compNode" presStyleCnt="0"/>
+      <dgm:spPr/>
+    </dgm:pt>
+    <dgm:pt modelId="{5E08B028-D48B-43E3-8B29-4B2BAEB7BB71}" type="pres">
+      <dgm:prSet presAssocID="{6153FF18-8BD2-45BB-854A-CD8632CDC26A}" presName="iconBgRect" presStyleLbl="bgShp" presStyleIdx="5" presStyleCnt="8"/>
+      <dgm:spPr/>
+    </dgm:pt>
+    <dgm:pt modelId="{5C0DFA92-FC88-416D-A93F-4F63BA45CB72}" type="pres">
+      <dgm:prSet presAssocID="{6153FF18-8BD2-45BB-854A-CD8632CDC26A}" presName="iconRect" presStyleLbl="node1" presStyleIdx="5" presStyleCnt="8"/>
+      <dgm:spPr>
+        <a:blipFill>
+          <a:blip xmlns:r="http://schemas.openxmlformats.org/officeDocument/2006/relationships" r:embed="rId11">
+            <a:extLst>
+              <a:ext uri="{28A0092B-C50C-407E-A947-70E740481C1C}">
+                <a14:useLocalDpi xmlns:a14="http://schemas.microsoft.com/office/drawing/2010/main" val="0"/>
+              </a:ext>
+              <a:ext uri="{96DAC541-7B7A-43D3-8B79-37D633B846F1}">
+                <asvg:svgBlip xmlns:asvg="http://schemas.microsoft.com/office/drawing/2016/SVG/main" r:embed="rId12"/>
+              </a:ext>
+            </a:extLst>
+          </a:blip>
+          <a:stretch>
+            <a:fillRect/>
+          </a:stretch>
+        </a:blipFill>
+      </dgm:spPr>
+      <dgm:extLst>
+        <a:ext uri="{E40237B7-FDA0-4F09-8148-C483321AD2D9}">
+          <dgm14:cNvPr xmlns:dgm14="http://schemas.microsoft.com/office/drawing/2010/diagram" id="0" name="" descr="Robot"/>
+        </a:ext>
+      </dgm:extLst>
+    </dgm:pt>
+    <dgm:pt modelId="{B35F52B9-86A2-4F18-88F3-34CB4E661EEE}" type="pres">
+      <dgm:prSet presAssocID="{6153FF18-8BD2-45BB-854A-CD8632CDC26A}" presName="spaceRect" presStyleCnt="0"/>
+      <dgm:spPr/>
+    </dgm:pt>
+    <dgm:pt modelId="{F4629CC3-0C20-4301-9F76-4BAD0A2A8F00}" type="pres">
+      <dgm:prSet presAssocID="{6153FF18-8BD2-45BB-854A-CD8632CDC26A}" presName="textRect" presStyleLbl="revTx" presStyleIdx="5" presStyleCnt="8">
+        <dgm:presLayoutVars>
+          <dgm:chMax val="1"/>
+          <dgm:chPref val="1"/>
+        </dgm:presLayoutVars>
+      </dgm:prSet>
+      <dgm:spPr/>
+    </dgm:pt>
+    <dgm:pt modelId="{136ACD61-CD3B-4B4A-B271-6B179AC197A7}" type="pres">
+      <dgm:prSet presAssocID="{5A6C4911-DC52-4C0C-AB33-5529B1A85664}" presName="sibTrans" presStyleLbl="sibTrans2D1" presStyleIdx="0" presStyleCnt="0"/>
+      <dgm:spPr/>
+    </dgm:pt>
+    <dgm:pt modelId="{8A7BB095-EF89-4C1D-9655-2D1CE3770D9E}" type="pres">
+      <dgm:prSet presAssocID="{D4B3BAF0-1DFF-452A-8E9F-7F6DAEDD5259}" presName="compNode" presStyleCnt="0"/>
+      <dgm:spPr/>
+    </dgm:pt>
+    <dgm:pt modelId="{58B8AE8F-260D-42F7-BBE5-DD2F7E1CBF28}" type="pres">
+      <dgm:prSet presAssocID="{D4B3BAF0-1DFF-452A-8E9F-7F6DAEDD5259}" presName="iconBgRect" presStyleLbl="bgShp" presStyleIdx="6" presStyleCnt="8"/>
+      <dgm:spPr/>
+    </dgm:pt>
+    <dgm:pt modelId="{93F08456-3D4B-4A75-9D1B-DAA22C0971BE}" type="pres">
+      <dgm:prSet presAssocID="{D4B3BAF0-1DFF-452A-8E9F-7F6DAEDD5259}" presName="iconRect" presStyleLbl="node1" presStyleIdx="6" presStyleCnt="8"/>
+      <dgm:spPr>
+        <a:blipFill>
+          <a:blip xmlns:r="http://schemas.openxmlformats.org/officeDocument/2006/relationships" r:embed="rId13">
+            <a:extLst>
+              <a:ext uri="{28A0092B-C50C-407E-A947-70E740481C1C}">
+                <a14:useLocalDpi xmlns:a14="http://schemas.microsoft.com/office/drawing/2010/main" val="0"/>
+              </a:ext>
+              <a:ext uri="{96DAC541-7B7A-43D3-8B79-37D633B846F1}">
+                <asvg:svgBlip xmlns:asvg="http://schemas.microsoft.com/office/drawing/2016/SVG/main" r:embed="rId14"/>
+              </a:ext>
+            </a:extLst>
+          </a:blip>
+          <a:stretch>
+            <a:fillRect/>
+          </a:stretch>
+        </a:blipFill>
+      </dgm:spPr>
+      <dgm:extLst>
+        <a:ext uri="{E40237B7-FDA0-4F09-8148-C483321AD2D9}">
+          <dgm14:cNvPr xmlns:dgm14="http://schemas.microsoft.com/office/drawing/2010/diagram" id="0" name="" descr="Email"/>
+        </a:ext>
+      </dgm:extLst>
+    </dgm:pt>
+    <dgm:pt modelId="{14AF40E4-7BC2-431E-A3E8-A9EBD3F6DF27}" type="pres">
+      <dgm:prSet presAssocID="{D4B3BAF0-1DFF-452A-8E9F-7F6DAEDD5259}" presName="spaceRect" presStyleCnt="0"/>
+      <dgm:spPr/>
+    </dgm:pt>
+    <dgm:pt modelId="{1B40DF30-A746-419C-8E38-FCE8F971C852}" type="pres">
+      <dgm:prSet presAssocID="{D4B3BAF0-1DFF-452A-8E9F-7F6DAEDD5259}" presName="textRect" presStyleLbl="revTx" presStyleIdx="6" presStyleCnt="8">
+        <dgm:presLayoutVars>
+          <dgm:chMax val="1"/>
+          <dgm:chPref val="1"/>
+        </dgm:presLayoutVars>
+      </dgm:prSet>
+      <dgm:spPr/>
+    </dgm:pt>
+    <dgm:pt modelId="{D74BBFFF-A7D5-4755-928F-20DA8330DE1B}" type="pres">
+      <dgm:prSet presAssocID="{37073D6E-DE9C-466D-B8A7-DA360793B53F}" presName="sibTrans" presStyleLbl="sibTrans2D1" presStyleIdx="0" presStyleCnt="0"/>
+      <dgm:spPr/>
+    </dgm:pt>
+    <dgm:pt modelId="{A1019E3C-27AE-43B4-B945-E6087245F03A}" type="pres">
+      <dgm:prSet presAssocID="{E3A74F75-AC17-48AD-A734-885D21E05F60}" presName="compNode" presStyleCnt="0"/>
+      <dgm:spPr/>
+    </dgm:pt>
+    <dgm:pt modelId="{90BBE456-1271-41E3-A4A0-7981AB2AB571}" type="pres">
+      <dgm:prSet presAssocID="{E3A74F75-AC17-48AD-A734-885D21E05F60}" presName="iconBgRect" presStyleLbl="bgShp" presStyleIdx="7" presStyleCnt="8"/>
+      <dgm:spPr/>
+    </dgm:pt>
+    <dgm:pt modelId="{2B7FF431-6AED-4904-933E-DC5FEE4BFE90}" type="pres">
+      <dgm:prSet presAssocID="{E3A74F75-AC17-48AD-A734-885D21E05F60}" presName="iconRect" presStyleLbl="node1" presStyleIdx="7" presStyleCnt="8"/>
+      <dgm:spPr>
+        <a:blipFill>
+          <a:blip xmlns:r="http://schemas.openxmlformats.org/officeDocument/2006/relationships" r:embed="rId15">
+            <a:extLst>
+              <a:ext uri="{28A0092B-C50C-407E-A947-70E740481C1C}">
+                <a14:useLocalDpi xmlns:a14="http://schemas.microsoft.com/office/drawing/2010/main" val="0"/>
+              </a:ext>
+              <a:ext uri="{96DAC541-7B7A-43D3-8B79-37D633B846F1}">
+                <asvg:svgBlip xmlns:asvg="http://schemas.microsoft.com/office/drawing/2016/SVG/main" r:embed="rId16"/>
+              </a:ext>
+            </a:extLst>
+          </a:blip>
+          <a:stretch>
+            <a:fillRect/>
+          </a:stretch>
+        </a:blipFill>
+      </dgm:spPr>
+      <dgm:extLst>
+        <a:ext uri="{E40237B7-FDA0-4F09-8148-C483321AD2D9}">
+          <dgm14:cNvPr xmlns:dgm14="http://schemas.microsoft.com/office/drawing/2010/diagram" id="0" name="" descr="Database"/>
+        </a:ext>
+      </dgm:extLst>
+    </dgm:pt>
+    <dgm:pt modelId="{6FC63E64-412F-4214-AB09-1798438F30D4}" type="pres">
+      <dgm:prSet presAssocID="{E3A74F75-AC17-48AD-A734-885D21E05F60}" presName="spaceRect" presStyleCnt="0"/>
+      <dgm:spPr/>
+    </dgm:pt>
+    <dgm:pt modelId="{3F7E97DC-2B49-4675-ACFB-DE26AFA41FDD}" type="pres">
+      <dgm:prSet presAssocID="{E3A74F75-AC17-48AD-A734-885D21E05F60}" presName="textRect" presStyleLbl="revTx" presStyleIdx="7" presStyleCnt="8">
+        <dgm:presLayoutVars>
+          <dgm:chMax val="1"/>
+          <dgm:chPref val="1"/>
+        </dgm:presLayoutVars>
+      </dgm:prSet>
+      <dgm:spPr/>
+    </dgm:pt>
+  </dgm:ptLst>
+  <dgm:cxnLst>
+    <dgm:cxn modelId="{383B4016-4C19-4B2F-8487-066D9BE2E9BE}" type="presOf" srcId="{E5B63A6D-49F9-4FFB-98B2-A8BE431F9CD6}" destId="{CAABA910-E77F-4BBA-AB26-EFAF7D5A42B3}" srcOrd="0" destOrd="0" presId="urn:microsoft.com/office/officeart/2018/2/layout/IconCircleList"/>
+    <dgm:cxn modelId="{4FC51E18-3D43-40B6-8ABD-C8F0DD2AADFE}" srcId="{DF5A7E0E-00B7-4A9C-A3C3-ECB4D9BF32BC}" destId="{E3A74F75-AC17-48AD-A734-885D21E05F60}" srcOrd="7" destOrd="0" parTransId="{A78D69D4-C481-4375-86E7-E6DA0FDB81C4}" sibTransId="{476BB39E-B252-4D9F-A234-5C771C87B329}"/>
+    <dgm:cxn modelId="{FA54E01D-6922-47D8-9FBE-C78FDCB006FE}" type="presOf" srcId="{D4B3BAF0-1DFF-452A-8E9F-7F6DAEDD5259}" destId="{1B40DF30-A746-419C-8E38-FCE8F971C852}" srcOrd="0" destOrd="0" presId="urn:microsoft.com/office/officeart/2018/2/layout/IconCircleList"/>
+    <dgm:cxn modelId="{AD7BDC29-341E-45F4-AC6D-EDB5812013E3}" srcId="{DF5A7E0E-00B7-4A9C-A3C3-ECB4D9BF32BC}" destId="{A936FE28-DE30-4F99-9D61-A0E9F5DEDAEB}" srcOrd="2" destOrd="0" parTransId="{56422E37-A5DC-436A-AEFC-E932DC9A3BB8}" sibTransId="{533C9DD2-E670-4E24-8788-2DFF1C707758}"/>
+    <dgm:cxn modelId="{51E24B2F-0359-432E-85DB-CAB8CA647DA9}" srcId="{DF5A7E0E-00B7-4A9C-A3C3-ECB4D9BF32BC}" destId="{05172726-9EC8-4DAB-9C24-AF72B6B26FE5}" srcOrd="3" destOrd="0" parTransId="{73FFB3CB-7C33-41DD-8A12-882B39708925}" sibTransId="{AA1BEEFC-D513-46CB-9B46-15F5BB078A9E}"/>
+    <dgm:cxn modelId="{D2776030-A5D4-40F6-A5EF-A48622E7DEE8}" type="presOf" srcId="{C9B88B39-EB2D-4ABF-8671-D02D136D903F}" destId="{688FBCBE-48AB-492D-A16C-7647775AC9B3}" srcOrd="0" destOrd="0" presId="urn:microsoft.com/office/officeart/2018/2/layout/IconCircleList"/>
+    <dgm:cxn modelId="{9A5FF334-2F24-4B52-BDC9-64A44BE99DBE}" type="presOf" srcId="{472CDD00-1D69-4A6B-8AC4-8A36F0E79CA1}" destId="{2C92A4C9-A4A1-486F-BB11-2CE4FCC41BC8}" srcOrd="0" destOrd="0" presId="urn:microsoft.com/office/officeart/2018/2/layout/IconCircleList"/>
+    <dgm:cxn modelId="{8442D637-55B4-4B32-902C-4B64404AF09A}" type="presOf" srcId="{AA1BEEFC-D513-46CB-9B46-15F5BB078A9E}" destId="{EA867568-FABB-40E0-A8DC-2830EDAED5E9}" srcOrd="0" destOrd="0" presId="urn:microsoft.com/office/officeart/2018/2/layout/IconCircleList"/>
+    <dgm:cxn modelId="{E4931362-CEA6-46A7-8B79-64FE4862E462}" srcId="{DF5A7E0E-00B7-4A9C-A3C3-ECB4D9BF32BC}" destId="{6153FF18-8BD2-45BB-854A-CD8632CDC26A}" srcOrd="5" destOrd="0" parTransId="{3F312DDF-C86D-4D1A-BEA9-CA1ED720A1E9}" sibTransId="{5A6C4911-DC52-4C0C-AB33-5529B1A85664}"/>
+    <dgm:cxn modelId="{61439842-D820-42EC-8B75-2CB8E6C16D4E}" type="presOf" srcId="{694B7AF4-3A8B-4ADF-926E-D04343A67A5B}" destId="{78D769C6-C2A1-4934-8341-175D00ECACE4}" srcOrd="0" destOrd="0" presId="urn:microsoft.com/office/officeart/2018/2/layout/IconCircleList"/>
+    <dgm:cxn modelId="{8563A864-B2CF-4112-B3EA-459656073B2C}" srcId="{DF5A7E0E-00B7-4A9C-A3C3-ECB4D9BF32BC}" destId="{694B7AF4-3A8B-4ADF-926E-D04343A67A5B}" srcOrd="0" destOrd="0" parTransId="{52F53AF0-7B6B-477F-BFA1-7477333598B6}" sibTransId="{E2B6EA70-59A0-4B65-AAAD-E68BF09AE32C}"/>
+    <dgm:cxn modelId="{057C216F-C623-4183-9313-45DF76E23918}" srcId="{DF5A7E0E-00B7-4A9C-A3C3-ECB4D9BF32BC}" destId="{D4B3BAF0-1DFF-452A-8E9F-7F6DAEDD5259}" srcOrd="6" destOrd="0" parTransId="{529EDF02-577C-4951-983B-D7146AD68EE1}" sibTransId="{37073D6E-DE9C-466D-B8A7-DA360793B53F}"/>
+    <dgm:cxn modelId="{9FD73359-065B-4CFD-9856-C822F7A97EB7}" type="presOf" srcId="{5A6C4911-DC52-4C0C-AB33-5529B1A85664}" destId="{136ACD61-CD3B-4B4A-B271-6B179AC197A7}" srcOrd="0" destOrd="0" presId="urn:microsoft.com/office/officeart/2018/2/layout/IconCircleList"/>
+    <dgm:cxn modelId="{7C8DB87F-B5CC-4F31-B5E4-ED8CF1BDA5A3}" type="presOf" srcId="{FAE58B5E-C93F-41D0-A6F6-D1E16200C15F}" destId="{014EF6EE-6A61-415B-9F59-82878761BCF6}" srcOrd="0" destOrd="0" presId="urn:microsoft.com/office/officeart/2018/2/layout/IconCircleList"/>
+    <dgm:cxn modelId="{D1F84C86-A4DC-4047-8F8E-A51ACEB18D71}" type="presOf" srcId="{533C9DD2-E670-4E24-8788-2DFF1C707758}" destId="{1B1B7DA3-360E-4232-A669-53A1E80E14B7}" srcOrd="0" destOrd="0" presId="urn:microsoft.com/office/officeart/2018/2/layout/IconCircleList"/>
+    <dgm:cxn modelId="{61AB9A92-99E3-4DFD-BD81-99510D6BE229}" type="presOf" srcId="{37073D6E-DE9C-466D-B8A7-DA360793B53F}" destId="{D74BBFFF-A7D5-4755-928F-20DA8330DE1B}" srcOrd="0" destOrd="0" presId="urn:microsoft.com/office/officeart/2018/2/layout/IconCircleList"/>
+    <dgm:cxn modelId="{38C85E96-213F-449F-98F8-2E3914350254}" type="presOf" srcId="{E2B6EA70-59A0-4B65-AAAD-E68BF09AE32C}" destId="{0DBA7B9D-6474-46AF-881B-D93034A3AFDD}" srcOrd="0" destOrd="0" presId="urn:microsoft.com/office/officeart/2018/2/layout/IconCircleList"/>
+    <dgm:cxn modelId="{2905FCAC-39B5-4172-A4FB-DE4F8D7FAC85}" type="presOf" srcId="{6153FF18-8BD2-45BB-854A-CD8632CDC26A}" destId="{F4629CC3-0C20-4301-9F76-4BAD0A2A8F00}" srcOrd="0" destOrd="0" presId="urn:microsoft.com/office/officeart/2018/2/layout/IconCircleList"/>
+    <dgm:cxn modelId="{7FA264AF-DC97-4397-A601-9A7741CE43CB}" type="presOf" srcId="{DF5A7E0E-00B7-4A9C-A3C3-ECB4D9BF32BC}" destId="{F81935D9-ED78-4E69-99F9-0E39E5576FC3}" srcOrd="0" destOrd="0" presId="urn:microsoft.com/office/officeart/2018/2/layout/IconCircleList"/>
+    <dgm:cxn modelId="{6D03BEC5-659F-4BC5-A484-13D3B1B8F949}" type="presOf" srcId="{A936FE28-DE30-4F99-9D61-A0E9F5DEDAEB}" destId="{B2D728B1-EBB0-4B82-A07E-5A89FFDCFC6C}" srcOrd="0" destOrd="0" presId="urn:microsoft.com/office/officeart/2018/2/layout/IconCircleList"/>
+    <dgm:cxn modelId="{560700C7-0D7A-401A-96D6-21BE1D10372B}" srcId="{DF5A7E0E-00B7-4A9C-A3C3-ECB4D9BF32BC}" destId="{FAE58B5E-C93F-41D0-A6F6-D1E16200C15F}" srcOrd="1" destOrd="0" parTransId="{3F225B14-8235-484D-8566-E644604961F1}" sibTransId="{E5B63A6D-49F9-4FFB-98B2-A8BE431F9CD6}"/>
+    <dgm:cxn modelId="{D3D34EF3-A831-4F86-A88B-1FE184433EC2}" srcId="{DF5A7E0E-00B7-4A9C-A3C3-ECB4D9BF32BC}" destId="{472CDD00-1D69-4A6B-8AC4-8A36F0E79CA1}" srcOrd="4" destOrd="0" parTransId="{8E9D8986-50DA-4A02-84B3-0AF8D257A10B}" sibTransId="{C9B88B39-EB2D-4ABF-8671-D02D136D903F}"/>
+    <dgm:cxn modelId="{29B17EF6-E0CA-4D91-854D-C62997C473CA}" type="presOf" srcId="{05172726-9EC8-4DAB-9C24-AF72B6B26FE5}" destId="{849CD35C-B223-47BF-8151-9396B4E709FE}" srcOrd="0" destOrd="0" presId="urn:microsoft.com/office/officeart/2018/2/layout/IconCircleList"/>
+    <dgm:cxn modelId="{01F44BF7-2E8C-452F-A489-BF982C147C9D}" type="presOf" srcId="{E3A74F75-AC17-48AD-A734-885D21E05F60}" destId="{3F7E97DC-2B49-4675-ACFB-DE26AFA41FDD}" srcOrd="0" destOrd="0" presId="urn:microsoft.com/office/officeart/2018/2/layout/IconCircleList"/>
+    <dgm:cxn modelId="{5EB0C63A-22A8-4F4B-87B4-BB3B4622797A}" type="presParOf" srcId="{F81935D9-ED78-4E69-99F9-0E39E5576FC3}" destId="{522A7C9A-4EA9-4DDE-996C-76B8BD70627D}" srcOrd="0" destOrd="0" presId="urn:microsoft.com/office/officeart/2018/2/layout/IconCircleList"/>
+    <dgm:cxn modelId="{FECE67FA-6C78-458F-B8AA-2CE406DF5B20}" type="presParOf" srcId="{522A7C9A-4EA9-4DDE-996C-76B8BD70627D}" destId="{4E6D419B-BC5A-4E67-8223-0A4521DD8DB4}" srcOrd="0" destOrd="0" presId="urn:microsoft.com/office/officeart/2018/2/layout/IconCircleList"/>
+    <dgm:cxn modelId="{B983F07E-1827-4283-B5B2-49FD7BCAFE26}" type="presParOf" srcId="{4E6D419B-BC5A-4E67-8223-0A4521DD8DB4}" destId="{2AD9908B-4848-434F-9EFE-0BC3A842C512}" srcOrd="0" destOrd="0" presId="urn:microsoft.com/office/officeart/2018/2/layout/IconCircleList"/>
+    <dgm:cxn modelId="{A94CEB66-9870-4ED9-8882-DF201D317F6B}" type="presParOf" srcId="{4E6D419B-BC5A-4E67-8223-0A4521DD8DB4}" destId="{4BAE8EAF-ADBE-4539-806A-4E0C49C7972A}" srcOrd="1" destOrd="0" presId="urn:microsoft.com/office/officeart/2018/2/layout/IconCircleList"/>
+    <dgm:cxn modelId="{1B1854DE-31EB-4757-9B83-B672F6ACD52D}" type="presParOf" srcId="{4E6D419B-BC5A-4E67-8223-0A4521DD8DB4}" destId="{5A72B12D-36FB-4963-A09D-CABBD85A79D8}" srcOrd="2" destOrd="0" presId="urn:microsoft.com/office/officeart/2018/2/layout/IconCircleList"/>
+    <dgm:cxn modelId="{2E7C11FF-7492-4D06-8880-03F6B135AFA6}" type="presParOf" srcId="{4E6D419B-BC5A-4E67-8223-0A4521DD8DB4}" destId="{78D769C6-C2A1-4934-8341-175D00ECACE4}" srcOrd="3" destOrd="0" presId="urn:microsoft.com/office/officeart/2018/2/layout/IconCircleList"/>
+    <dgm:cxn modelId="{55F14747-9565-456C-85B8-CFB6D6256A7A}" type="presParOf" srcId="{522A7C9A-4EA9-4DDE-996C-76B8BD70627D}" destId="{0DBA7B9D-6474-46AF-881B-D93034A3AFDD}" srcOrd="1" destOrd="0" presId="urn:microsoft.com/office/officeart/2018/2/layout/IconCircleList"/>
+    <dgm:cxn modelId="{1915B752-B10D-452C-9EC7-FBEFE5ADCE53}" type="presParOf" srcId="{522A7C9A-4EA9-4DDE-996C-76B8BD70627D}" destId="{3B2DC819-7056-4EAE-AEA4-9FD9879A0ADE}" srcOrd="2" destOrd="0" presId="urn:microsoft.com/office/officeart/2018/2/layout/IconCircleList"/>
+    <dgm:cxn modelId="{515B55F4-1C31-43B5-A334-6FF7810A9856}" type="presParOf" srcId="{3B2DC819-7056-4EAE-AEA4-9FD9879A0ADE}" destId="{6429BE27-F80E-40E8-AD6E-BCF5F22ACF2F}" srcOrd="0" destOrd="0" presId="urn:microsoft.com/office/officeart/2018/2/layout/IconCircleList"/>
+    <dgm:cxn modelId="{182204B4-1631-4894-994E-91F661555457}" type="presParOf" srcId="{3B2DC819-7056-4EAE-AEA4-9FD9879A0ADE}" destId="{906EF14B-2438-4714-AD22-63842EB6F1E0}" srcOrd="1" destOrd="0" presId="urn:microsoft.com/office/officeart/2018/2/layout/IconCircleList"/>
+    <dgm:cxn modelId="{4BA73D34-421A-4BF1-B30A-92834D315A90}" type="presParOf" srcId="{3B2DC819-7056-4EAE-AEA4-9FD9879A0ADE}" destId="{FE623779-3B7E-40B4-B073-2778679AA538}" srcOrd="2" destOrd="0" presId="urn:microsoft.com/office/officeart/2018/2/layout/IconCircleList"/>
+    <dgm:cxn modelId="{30FBCA72-9A13-42DA-8069-D66F8A7C6412}" type="presParOf" srcId="{3B2DC819-7056-4EAE-AEA4-9FD9879A0ADE}" destId="{014EF6EE-6A61-415B-9F59-82878761BCF6}" srcOrd="3" destOrd="0" presId="urn:microsoft.com/office/officeart/2018/2/layout/IconCircleList"/>
+    <dgm:cxn modelId="{F824F9E2-AE12-4B0D-BA8E-D09296CD9A16}" type="presParOf" srcId="{522A7C9A-4EA9-4DDE-996C-76B8BD70627D}" destId="{CAABA910-E77F-4BBA-AB26-EFAF7D5A42B3}" srcOrd="3" destOrd="0" presId="urn:microsoft.com/office/officeart/2018/2/layout/IconCircleList"/>
+    <dgm:cxn modelId="{DCE59419-8604-4D4A-9424-26D9153F8A59}" type="presParOf" srcId="{522A7C9A-4EA9-4DDE-996C-76B8BD70627D}" destId="{6156EBE7-C30F-4D08-9FA5-70E13AC42593}" srcOrd="4" destOrd="0" presId="urn:microsoft.com/office/officeart/2018/2/layout/IconCircleList"/>
+    <dgm:cxn modelId="{0AE05C71-6B04-405E-8659-B63E1C8D3AD0}" type="presParOf" srcId="{6156EBE7-C30F-4D08-9FA5-70E13AC42593}" destId="{93EFC311-3163-4675-AD5A-7C5466D8B716}" srcOrd="0" destOrd="0" presId="urn:microsoft.com/office/officeart/2018/2/layout/IconCircleList"/>
+    <dgm:cxn modelId="{F71CA7A1-4F22-448A-9B9D-9983FF4070D1}" type="presParOf" srcId="{6156EBE7-C30F-4D08-9FA5-70E13AC42593}" destId="{D53E28EE-343E-461D-B22A-DCB62CB19F62}" srcOrd="1" destOrd="0" presId="urn:microsoft.com/office/officeart/2018/2/layout/IconCircleList"/>
+    <dgm:cxn modelId="{6A3BE9F3-0C6F-4241-BFAD-12E78AA020C7}" type="presParOf" srcId="{6156EBE7-C30F-4D08-9FA5-70E13AC42593}" destId="{5BF33D79-4656-41CD-A6E8-A83A4A468FC5}" srcOrd="2" destOrd="0" presId="urn:microsoft.com/office/officeart/2018/2/layout/IconCircleList"/>
+    <dgm:cxn modelId="{0B487F4E-8ECF-4750-85F6-FA8DE120786E}" type="presParOf" srcId="{6156EBE7-C30F-4D08-9FA5-70E13AC42593}" destId="{B2D728B1-EBB0-4B82-A07E-5A89FFDCFC6C}" srcOrd="3" destOrd="0" presId="urn:microsoft.com/office/officeart/2018/2/layout/IconCircleList"/>
+    <dgm:cxn modelId="{A86D8215-8DCC-4D66-A2E5-641D77CAE9BF}" type="presParOf" srcId="{522A7C9A-4EA9-4DDE-996C-76B8BD70627D}" destId="{1B1B7DA3-360E-4232-A669-53A1E80E14B7}" srcOrd="5" destOrd="0" presId="urn:microsoft.com/office/officeart/2018/2/layout/IconCircleList"/>
+    <dgm:cxn modelId="{1FFD0FEB-010D-4495-B944-5C658543BA79}" type="presParOf" srcId="{522A7C9A-4EA9-4DDE-996C-76B8BD70627D}" destId="{4B0EE68C-2568-4B79-8471-A9098B85DB20}" srcOrd="6" destOrd="0" presId="urn:microsoft.com/office/officeart/2018/2/layout/IconCircleList"/>
+    <dgm:cxn modelId="{E43AEDD5-C865-4AAF-A708-9CCD01F1165F}" type="presParOf" srcId="{4B0EE68C-2568-4B79-8471-A9098B85DB20}" destId="{D086BA99-BDD5-4735-80BD-B0517490BB2B}" srcOrd="0" destOrd="0" presId="urn:microsoft.com/office/officeart/2018/2/layout/IconCircleList"/>
+    <dgm:cxn modelId="{AED0DEF1-268C-4883-9442-D2C294E00C57}" type="presParOf" srcId="{4B0EE68C-2568-4B79-8471-A9098B85DB20}" destId="{31A3621F-3969-491A-A712-E795557EBBD1}" srcOrd="1" destOrd="0" presId="urn:microsoft.com/office/officeart/2018/2/layout/IconCircleList"/>
+    <dgm:cxn modelId="{9D7E6706-E62D-4523-B9AB-124BDA1119E0}" type="presParOf" srcId="{4B0EE68C-2568-4B79-8471-A9098B85DB20}" destId="{55E9C20E-C647-45FF-870D-25E0975085F5}" srcOrd="2" destOrd="0" presId="urn:microsoft.com/office/officeart/2018/2/layout/IconCircleList"/>
+    <dgm:cxn modelId="{BFFFE442-1484-4081-9C40-863D20340E09}" type="presParOf" srcId="{4B0EE68C-2568-4B79-8471-A9098B85DB20}" destId="{849CD35C-B223-47BF-8151-9396B4E709FE}" srcOrd="3" destOrd="0" presId="urn:microsoft.com/office/officeart/2018/2/layout/IconCircleList"/>
+    <dgm:cxn modelId="{830FD383-C9D0-4CC4-945C-1878D8E2595A}" type="presParOf" srcId="{522A7C9A-4EA9-4DDE-996C-76B8BD70627D}" destId="{EA867568-FABB-40E0-A8DC-2830EDAED5E9}" srcOrd="7" destOrd="0" presId="urn:microsoft.com/office/officeart/2018/2/layout/IconCircleList"/>
+    <dgm:cxn modelId="{86BFFFEC-B2C5-4CDC-B15B-5EF426B8D3BB}" type="presParOf" srcId="{522A7C9A-4EA9-4DDE-996C-76B8BD70627D}" destId="{B4793F64-45F5-41AF-8C7D-3B30C8F64560}" srcOrd="8" destOrd="0" presId="urn:microsoft.com/office/officeart/2018/2/layout/IconCircleList"/>
+    <dgm:cxn modelId="{A03CE083-0241-4268-B324-C9B05F96B54C}" type="presParOf" srcId="{B4793F64-45F5-41AF-8C7D-3B30C8F64560}" destId="{230E90DD-B592-4283-A161-126B3624F6DA}" srcOrd="0" destOrd="0" presId="urn:microsoft.com/office/officeart/2018/2/layout/IconCircleList"/>
+    <dgm:cxn modelId="{697CB9D0-BDBC-4F8B-BE39-CAADF543577A}" type="presParOf" srcId="{B4793F64-45F5-41AF-8C7D-3B30C8F64560}" destId="{1E2A6E66-6D92-4B3C-946C-D067F50F008C}" srcOrd="1" destOrd="0" presId="urn:microsoft.com/office/officeart/2018/2/layout/IconCircleList"/>
+    <dgm:cxn modelId="{4C03B9BA-42E4-4019-8A88-2FB49567758D}" type="presParOf" srcId="{B4793F64-45F5-41AF-8C7D-3B30C8F64560}" destId="{B773059A-2183-4C7C-A11B-AF404735963D}" srcOrd="2" destOrd="0" presId="urn:microsoft.com/office/officeart/2018/2/layout/IconCircleList"/>
+    <dgm:cxn modelId="{A3CA4DA4-ADDC-4157-845B-678C26343DD1}" type="presParOf" srcId="{B4793F64-45F5-41AF-8C7D-3B30C8F64560}" destId="{2C92A4C9-A4A1-486F-BB11-2CE4FCC41BC8}" srcOrd="3" destOrd="0" presId="urn:microsoft.com/office/officeart/2018/2/layout/IconCircleList"/>
+    <dgm:cxn modelId="{641AE11D-1FDB-42F2-BF0B-837C2C2F4D83}" type="presParOf" srcId="{522A7C9A-4EA9-4DDE-996C-76B8BD70627D}" destId="{688FBCBE-48AB-492D-A16C-7647775AC9B3}" srcOrd="9" destOrd="0" presId="urn:microsoft.com/office/officeart/2018/2/layout/IconCircleList"/>
+    <dgm:cxn modelId="{A8F92E8E-3342-4C60-84B5-090DEC84F003}" type="presParOf" srcId="{522A7C9A-4EA9-4DDE-996C-76B8BD70627D}" destId="{B5B05572-F54B-4E8A-95F5-3023B86A8F6C}" srcOrd="10" destOrd="0" presId="urn:microsoft.com/office/officeart/2018/2/layout/IconCircleList"/>
+    <dgm:cxn modelId="{3F18E374-6ECF-45EE-83FE-D2761B1E77F8}" type="presParOf" srcId="{B5B05572-F54B-4E8A-95F5-3023B86A8F6C}" destId="{5E08B028-D48B-43E3-8B29-4B2BAEB7BB71}" srcOrd="0" destOrd="0" presId="urn:microsoft.com/office/officeart/2018/2/layout/IconCircleList"/>
+    <dgm:cxn modelId="{8CA335B2-6D55-4EA9-AFAB-82B6BF330F11}" type="presParOf" srcId="{B5B05572-F54B-4E8A-95F5-3023B86A8F6C}" destId="{5C0DFA92-FC88-416D-A93F-4F63BA45CB72}" srcOrd="1" destOrd="0" presId="urn:microsoft.com/office/officeart/2018/2/layout/IconCircleList"/>
+    <dgm:cxn modelId="{95439461-9704-4464-BDF4-1C331F1761DE}" type="presParOf" srcId="{B5B05572-F54B-4E8A-95F5-3023B86A8F6C}" destId="{B35F52B9-86A2-4F18-88F3-34CB4E661EEE}" srcOrd="2" destOrd="0" presId="urn:microsoft.com/office/officeart/2018/2/layout/IconCircleList"/>
+    <dgm:cxn modelId="{5DC9E60E-3376-470E-9402-8F363BC282AC}" type="presParOf" srcId="{B5B05572-F54B-4E8A-95F5-3023B86A8F6C}" destId="{F4629CC3-0C20-4301-9F76-4BAD0A2A8F00}" srcOrd="3" destOrd="0" presId="urn:microsoft.com/office/officeart/2018/2/layout/IconCircleList"/>
+    <dgm:cxn modelId="{C4FF8361-8CCC-4C21-A3A0-FAE2EA14475A}" type="presParOf" srcId="{522A7C9A-4EA9-4DDE-996C-76B8BD70627D}" destId="{136ACD61-CD3B-4B4A-B271-6B179AC197A7}" srcOrd="11" destOrd="0" presId="urn:microsoft.com/office/officeart/2018/2/layout/IconCircleList"/>
+    <dgm:cxn modelId="{429985C4-64EB-408D-BA9D-C82A5040D4B0}" type="presParOf" srcId="{522A7C9A-4EA9-4DDE-996C-76B8BD70627D}" destId="{8A7BB095-EF89-4C1D-9655-2D1CE3770D9E}" srcOrd="12" destOrd="0" presId="urn:microsoft.com/office/officeart/2018/2/layout/IconCircleList"/>
+    <dgm:cxn modelId="{57697E89-2B9D-466C-A7DA-0E15D4B1B4EA}" type="presParOf" srcId="{8A7BB095-EF89-4C1D-9655-2D1CE3770D9E}" destId="{58B8AE8F-260D-42F7-BBE5-DD2F7E1CBF28}" srcOrd="0" destOrd="0" presId="urn:microsoft.com/office/officeart/2018/2/layout/IconCircleList"/>
+    <dgm:cxn modelId="{4E5DED21-0270-4215-BF2B-BA874D4F8CC4}" type="presParOf" srcId="{8A7BB095-EF89-4C1D-9655-2D1CE3770D9E}" destId="{93F08456-3D4B-4A75-9D1B-DAA22C0971BE}" srcOrd="1" destOrd="0" presId="urn:microsoft.com/office/officeart/2018/2/layout/IconCircleList"/>
+    <dgm:cxn modelId="{2F154868-4FC6-40D7-BA2D-962BB6527081}" type="presParOf" srcId="{8A7BB095-EF89-4C1D-9655-2D1CE3770D9E}" destId="{14AF40E4-7BC2-431E-A3E8-A9EBD3F6DF27}" srcOrd="2" destOrd="0" presId="urn:microsoft.com/office/officeart/2018/2/layout/IconCircleList"/>
+    <dgm:cxn modelId="{B931A172-3B68-4F0D-B250-081F315AA79A}" type="presParOf" srcId="{8A7BB095-EF89-4C1D-9655-2D1CE3770D9E}" destId="{1B40DF30-A746-419C-8E38-FCE8F971C852}" srcOrd="3" destOrd="0" presId="urn:microsoft.com/office/officeart/2018/2/layout/IconCircleList"/>
+    <dgm:cxn modelId="{2F70CEEF-9428-49DA-9690-551E008FDEA9}" type="presParOf" srcId="{522A7C9A-4EA9-4DDE-996C-76B8BD70627D}" destId="{D74BBFFF-A7D5-4755-928F-20DA8330DE1B}" srcOrd="13" destOrd="0" presId="urn:microsoft.com/office/officeart/2018/2/layout/IconCircleList"/>
+    <dgm:cxn modelId="{6208005F-D4C5-4656-A834-6C482721322E}" type="presParOf" srcId="{522A7C9A-4EA9-4DDE-996C-76B8BD70627D}" destId="{A1019E3C-27AE-43B4-B945-E6087245F03A}" srcOrd="14" destOrd="0" presId="urn:microsoft.com/office/officeart/2018/2/layout/IconCircleList"/>
+    <dgm:cxn modelId="{EAE52BEA-8783-4117-BD74-6ADCB177D460}" type="presParOf" srcId="{A1019E3C-27AE-43B4-B945-E6087245F03A}" destId="{90BBE456-1271-41E3-A4A0-7981AB2AB571}" srcOrd="0" destOrd="0" presId="urn:microsoft.com/office/officeart/2018/2/layout/IconCircleList"/>
+    <dgm:cxn modelId="{7DE4BFBC-31C0-484F-BBB3-02AB9A9404A4}" type="presParOf" srcId="{A1019E3C-27AE-43B4-B945-E6087245F03A}" destId="{2B7FF431-6AED-4904-933E-DC5FEE4BFE90}" srcOrd="1" destOrd="0" presId="urn:microsoft.com/office/officeart/2018/2/layout/IconCircleList"/>
+    <dgm:cxn modelId="{6F1C0923-B8D7-46C9-A16B-F8FDDA24CBBC}" type="presParOf" srcId="{A1019E3C-27AE-43B4-B945-E6087245F03A}" destId="{6FC63E64-412F-4214-AB09-1798438F30D4}" srcOrd="2" destOrd="0" presId="urn:microsoft.com/office/officeart/2018/2/layout/IconCircleList"/>
+    <dgm:cxn modelId="{2D5B9637-CD0C-46E3-8793-187A9B60D04A}" type="presParOf" srcId="{A1019E3C-27AE-43B4-B945-E6087245F03A}" destId="{3F7E97DC-2B49-4675-ACFB-DE26AFA41FDD}" srcOrd="3" destOrd="0" presId="urn:microsoft.com/office/officeart/2018/2/layout/IconCircleList"/>
+  </dgm:cxnLst>
+  <dgm:bg/>
+  <dgm:whole/>
+  <dgm:extLst>
+    <a:ext uri="http://schemas.microsoft.com/office/drawing/2008/diagram">
+      <dsp:dataModelExt xmlns:dsp="http://schemas.microsoft.com/office/drawing/2008/diagram" relId="rId22" minVer="http://schemas.openxmlformats.org/drawingml/2006/diagram"/>
+    </a:ext>
+  </dgm:extLst>
+</dgm:dataModel>
+</file>
+
+<file path=ppt/diagrams/drawing1.xml><?xml version="1.0" encoding="utf-8"?>
+<dsp:drawing xmlns:dgm="http://schemas.openxmlformats.org/drawingml/2006/diagram" xmlns:dsp="http://schemas.microsoft.com/office/drawing/2008/diagram" xmlns:a="http://schemas.openxmlformats.org/drawingml/2006/main">
+  <dsp:spTree>
+    <dsp:nvGrpSpPr>
+      <dsp:cNvPr id="0" name=""/>
+      <dsp:cNvGrpSpPr/>
+    </dsp:nvGrpSpPr>
+    <dsp:grpSpPr/>
+    <dsp:sp modelId="{2AD9908B-4848-434F-9EFE-0BC3A842C512}">
+      <dsp:nvSpPr>
+        <dsp:cNvPr id="0" name=""/>
+        <dsp:cNvSpPr/>
+      </dsp:nvSpPr>
+      <dsp:spPr>
+        <a:xfrm>
+          <a:off x="50955" y="151181"/>
+          <a:ext cx="655422" cy="655422"/>
+        </a:xfrm>
+        <a:prstGeom prst="ellipse">
+          <a:avLst/>
+        </a:prstGeom>
+        <a:solidFill>
+          <a:schemeClr val="accent1">
+            <a:tint val="40000"/>
+            <a:hueOff val="0"/>
+            <a:satOff val="0"/>
+            <a:lumOff val="0"/>
+            <a:alphaOff val="0"/>
+          </a:schemeClr>
+        </a:solidFill>
+        <a:ln>
+          <a:noFill/>
+        </a:ln>
+        <a:effectLst/>
+      </dsp:spPr>
+      <dsp:style>
+        <a:lnRef idx="0">
+          <a:scrgbClr r="0" g="0" b="0"/>
+        </a:lnRef>
+        <a:fillRef idx="1">
+          <a:scrgbClr r="0" g="0" b="0"/>
+        </a:fillRef>
+        <a:effectRef idx="0">
+          <a:scrgbClr r="0" g="0" b="0"/>
+        </a:effectRef>
+        <a:fontRef idx="minor"/>
+      </dsp:style>
+    </dsp:sp>
+    <dsp:sp modelId="{4BAE8EAF-ADBE-4539-806A-4E0C49C7972A}">
+      <dsp:nvSpPr>
+        <dsp:cNvPr id="0" name=""/>
+        <dsp:cNvSpPr/>
+      </dsp:nvSpPr>
+      <dsp:spPr>
+        <a:xfrm>
+          <a:off x="188594" y="288820"/>
+          <a:ext cx="380144" cy="380144"/>
+        </a:xfrm>
+        <a:prstGeom prst="rect">
+          <a:avLst/>
+        </a:prstGeom>
+        <a:blipFill>
+          <a:blip xmlns:r="http://schemas.openxmlformats.org/officeDocument/2006/relationships" r:embed="rId1">
+            <a:extLst>
+              <a:ext uri="{28A0092B-C50C-407E-A947-70E740481C1C}">
+                <a14:useLocalDpi xmlns:a14="http://schemas.microsoft.com/office/drawing/2010/main" val="0"/>
+              </a:ext>
+              <a:ext uri="{96DAC541-7B7A-43D3-8B79-37D633B846F1}">
+                <asvg:svgBlip xmlns:asvg="http://schemas.microsoft.com/office/drawing/2016/SVG/main" r:embed="rId2"/>
+              </a:ext>
+            </a:extLst>
+          </a:blip>
+          <a:stretch>
+            <a:fillRect/>
+          </a:stretch>
+        </a:blipFill>
+        <a:ln w="19050" cap="flat" cmpd="sng" algn="ctr">
+          <a:solidFill>
+            <a:schemeClr val="lt1">
+              <a:hueOff val="0"/>
+              <a:satOff val="0"/>
+              <a:lumOff val="0"/>
+              <a:alphaOff val="0"/>
+            </a:schemeClr>
+          </a:solidFill>
+          <a:prstDash val="solid"/>
+          <a:miter lim="800000"/>
+        </a:ln>
+        <a:effectLst/>
+      </dsp:spPr>
+      <dsp:style>
+        <a:lnRef idx="2">
+          <a:scrgbClr r="0" g="0" b="0"/>
+        </a:lnRef>
+        <a:fillRef idx="1">
+          <a:scrgbClr r="0" g="0" b="0"/>
+        </a:fillRef>
+        <a:effectRef idx="0">
+          <a:scrgbClr r="0" g="0" b="0"/>
+        </a:effectRef>
+        <a:fontRef idx="minor">
+          <a:schemeClr val="lt1"/>
+        </a:fontRef>
+      </dsp:style>
+    </dsp:sp>
+    <dsp:sp modelId="{78D769C6-C2A1-4934-8341-175D00ECACE4}">
+      <dsp:nvSpPr>
+        <dsp:cNvPr id="0" name=""/>
+        <dsp:cNvSpPr/>
+      </dsp:nvSpPr>
+      <dsp:spPr>
+        <a:xfrm>
+          <a:off x="846825" y="151181"/>
+          <a:ext cx="1544923" cy="655422"/>
+        </a:xfrm>
+        <a:prstGeom prst="rect">
+          <a:avLst/>
+        </a:prstGeom>
+        <a:noFill/>
+        <a:ln>
+          <a:noFill/>
+        </a:ln>
+        <a:effectLst/>
+      </dsp:spPr>
+      <dsp:style>
+        <a:lnRef idx="0">
+          <a:scrgbClr r="0" g="0" b="0"/>
+        </a:lnRef>
+        <a:fillRef idx="0">
+          <a:scrgbClr r="0" g="0" b="0"/>
+        </a:fillRef>
+        <a:effectRef idx="0">
+          <a:scrgbClr r="0" g="0" b="0"/>
+        </a:effectRef>
+        <a:fontRef idx="minor"/>
+      </dsp:style>
+      <dsp:txBody>
+        <a:bodyPr spcFirstLastPara="0" vert="horz" wrap="square" lIns="0" tIns="0" rIns="0" bIns="0" numCol="1" spcCol="1270" anchor="ctr" anchorCtr="0">
+          <a:noAutofit/>
+        </a:bodyPr>
+        <a:lstStyle/>
+        <a:p>
+          <a:pPr marL="0" lvl="0" indent="0" algn="l" defTabSz="889000">
+            <a:lnSpc>
+              <a:spcPct val="100000"/>
+            </a:lnSpc>
+            <a:spcBef>
+              <a:spcPct val="0"/>
+            </a:spcBef>
+            <a:spcAft>
+              <a:spcPct val="35000"/>
+            </a:spcAft>
+            <a:buNone/>
+          </a:pPr>
+          <a:r>
+            <a:rPr lang="en-GB" sz="2000" kern="1200" dirty="0"/>
+            <a:t>Python - Main Programming Language</a:t>
+          </a:r>
+          <a:endParaRPr lang="en-US" sz="2000" kern="1200" dirty="0"/>
+        </a:p>
+      </dsp:txBody>
+      <dsp:txXfrm>
+        <a:off x="846825" y="151181"/>
+        <a:ext cx="1544923" cy="655422"/>
+      </dsp:txXfrm>
+    </dsp:sp>
+    <dsp:sp modelId="{6429BE27-F80E-40E8-AD6E-BCF5F22ACF2F}">
+      <dsp:nvSpPr>
+        <dsp:cNvPr id="0" name=""/>
+        <dsp:cNvSpPr/>
+      </dsp:nvSpPr>
+      <dsp:spPr>
+        <a:xfrm>
+          <a:off x="2660939" y="151181"/>
+          <a:ext cx="655422" cy="655422"/>
+        </a:xfrm>
+        <a:prstGeom prst="ellipse">
+          <a:avLst/>
+        </a:prstGeom>
+        <a:solidFill>
+          <a:schemeClr val="accent1">
+            <a:tint val="40000"/>
+            <a:hueOff val="0"/>
+            <a:satOff val="0"/>
+            <a:lumOff val="0"/>
+            <a:alphaOff val="0"/>
+          </a:schemeClr>
+        </a:solidFill>
+        <a:ln>
+          <a:noFill/>
+        </a:ln>
+        <a:effectLst/>
+      </dsp:spPr>
+      <dsp:style>
+        <a:lnRef idx="0">
+          <a:scrgbClr r="0" g="0" b="0"/>
+        </a:lnRef>
+        <a:fillRef idx="1">
+          <a:scrgbClr r="0" g="0" b="0"/>
+        </a:fillRef>
+        <a:effectRef idx="0">
+          <a:scrgbClr r="0" g="0" b="0"/>
+        </a:effectRef>
+        <a:fontRef idx="minor"/>
+      </dsp:style>
+    </dsp:sp>
+    <dsp:sp modelId="{906EF14B-2438-4714-AD22-63842EB6F1E0}">
+      <dsp:nvSpPr>
+        <dsp:cNvPr id="0" name=""/>
+        <dsp:cNvSpPr/>
+      </dsp:nvSpPr>
+      <dsp:spPr>
+        <a:xfrm>
+          <a:off x="2798578" y="288820"/>
+          <a:ext cx="380144" cy="380144"/>
+        </a:xfrm>
+        <a:prstGeom prst="rect">
+          <a:avLst/>
+        </a:prstGeom>
+        <a:blipFill>
+          <a:blip xmlns:r="http://schemas.openxmlformats.org/officeDocument/2006/relationships" r:embed="rId3">
+            <a:extLst>
+              <a:ext uri="{28A0092B-C50C-407E-A947-70E740481C1C}">
+                <a14:useLocalDpi xmlns:a14="http://schemas.microsoft.com/office/drawing/2010/main" val="0"/>
+              </a:ext>
+              <a:ext uri="{96DAC541-7B7A-43D3-8B79-37D633B846F1}">
+                <asvg:svgBlip xmlns:asvg="http://schemas.microsoft.com/office/drawing/2016/SVG/main" r:embed="rId4"/>
+              </a:ext>
+            </a:extLst>
+          </a:blip>
+          <a:stretch>
+            <a:fillRect/>
+          </a:stretch>
+        </a:blipFill>
+        <a:ln w="19050" cap="flat" cmpd="sng" algn="ctr">
+          <a:solidFill>
+            <a:schemeClr val="lt1">
+              <a:hueOff val="0"/>
+              <a:satOff val="0"/>
+              <a:lumOff val="0"/>
+              <a:alphaOff val="0"/>
+            </a:schemeClr>
+          </a:solidFill>
+          <a:prstDash val="solid"/>
+          <a:miter lim="800000"/>
+        </a:ln>
+        <a:effectLst/>
+      </dsp:spPr>
+      <dsp:style>
+        <a:lnRef idx="2">
+          <a:scrgbClr r="0" g="0" b="0"/>
+        </a:lnRef>
+        <a:fillRef idx="1">
+          <a:scrgbClr r="0" g="0" b="0"/>
+        </a:fillRef>
+        <a:effectRef idx="0">
+          <a:scrgbClr r="0" g="0" b="0"/>
+        </a:effectRef>
+        <a:fontRef idx="minor">
+          <a:schemeClr val="lt1"/>
+        </a:fontRef>
+      </dsp:style>
+    </dsp:sp>
+    <dsp:sp modelId="{014EF6EE-6A61-415B-9F59-82878761BCF6}">
+      <dsp:nvSpPr>
+        <dsp:cNvPr id="0" name=""/>
+        <dsp:cNvSpPr/>
+      </dsp:nvSpPr>
+      <dsp:spPr>
+        <a:xfrm>
+          <a:off x="3456809" y="151181"/>
+          <a:ext cx="1544923" cy="655422"/>
+        </a:xfrm>
+        <a:prstGeom prst="rect">
+          <a:avLst/>
+        </a:prstGeom>
+        <a:noFill/>
+        <a:ln>
+          <a:noFill/>
+        </a:ln>
+        <a:effectLst/>
+      </dsp:spPr>
+      <dsp:style>
+        <a:lnRef idx="0">
+          <a:scrgbClr r="0" g="0" b="0"/>
+        </a:lnRef>
+        <a:fillRef idx="0">
+          <a:scrgbClr r="0" g="0" b="0"/>
+        </a:fillRef>
+        <a:effectRef idx="0">
+          <a:scrgbClr r="0" g="0" b="0"/>
+        </a:effectRef>
+        <a:fontRef idx="minor"/>
+      </dsp:style>
+      <dsp:txBody>
+        <a:bodyPr spcFirstLastPara="0" vert="horz" wrap="square" lIns="0" tIns="0" rIns="0" bIns="0" numCol="1" spcCol="1270" anchor="ctr" anchorCtr="0">
+          <a:noAutofit/>
+        </a:bodyPr>
+        <a:lstStyle/>
+        <a:p>
+          <a:pPr marL="0" lvl="0" indent="0" algn="l" defTabSz="889000">
+            <a:lnSpc>
+              <a:spcPct val="100000"/>
+            </a:lnSpc>
+            <a:spcBef>
+              <a:spcPct val="0"/>
+            </a:spcBef>
+            <a:spcAft>
+              <a:spcPct val="35000"/>
+            </a:spcAft>
+            <a:buNone/>
+          </a:pPr>
+          <a:r>
+            <a:rPr lang="en-GB" sz="2000" kern="1200" dirty="0"/>
+            <a:t>YOLO - Object Detection  </a:t>
+          </a:r>
+          <a:endParaRPr lang="en-US" sz="2000" kern="1200" dirty="0"/>
+        </a:p>
+      </dsp:txBody>
+      <dsp:txXfrm>
+        <a:off x="3456809" y="151181"/>
+        <a:ext cx="1544923" cy="655422"/>
+      </dsp:txXfrm>
+    </dsp:sp>
+    <dsp:sp modelId="{93EFC311-3163-4675-AD5A-7C5466D8B716}">
+      <dsp:nvSpPr>
+        <dsp:cNvPr id="0" name=""/>
+        <dsp:cNvSpPr/>
+      </dsp:nvSpPr>
+      <dsp:spPr>
+        <a:xfrm>
+          <a:off x="50955" y="1821070"/>
+          <a:ext cx="655422" cy="655422"/>
+        </a:xfrm>
+        <a:prstGeom prst="ellipse">
+          <a:avLst/>
+        </a:prstGeom>
+        <a:solidFill>
+          <a:schemeClr val="accent1">
+            <a:tint val="40000"/>
+            <a:hueOff val="0"/>
+            <a:satOff val="0"/>
+            <a:lumOff val="0"/>
+            <a:alphaOff val="0"/>
+          </a:schemeClr>
+        </a:solidFill>
+        <a:ln>
+          <a:noFill/>
+        </a:ln>
+        <a:effectLst/>
+      </dsp:spPr>
+      <dsp:style>
+        <a:lnRef idx="0">
+          <a:scrgbClr r="0" g="0" b="0"/>
+        </a:lnRef>
+        <a:fillRef idx="1">
+          <a:scrgbClr r="0" g="0" b="0"/>
+        </a:fillRef>
+        <a:effectRef idx="0">
+          <a:scrgbClr r="0" g="0" b="0"/>
+        </a:effectRef>
+        <a:fontRef idx="minor"/>
+      </dsp:style>
+    </dsp:sp>
+    <dsp:sp modelId="{D53E28EE-343E-461D-B22A-DCB62CB19F62}">
+      <dsp:nvSpPr>
+        <dsp:cNvPr id="0" name=""/>
+        <dsp:cNvSpPr/>
+      </dsp:nvSpPr>
+      <dsp:spPr>
+        <a:xfrm>
+          <a:off x="188594" y="1958709"/>
+          <a:ext cx="380144" cy="380144"/>
+        </a:xfrm>
+        <a:prstGeom prst="rect">
+          <a:avLst/>
+        </a:prstGeom>
+        <a:blipFill>
+          <a:blip xmlns:r="http://schemas.openxmlformats.org/officeDocument/2006/relationships" r:embed="rId5">
+            <a:extLst>
+              <a:ext uri="{28A0092B-C50C-407E-A947-70E740481C1C}">
+                <a14:useLocalDpi xmlns:a14="http://schemas.microsoft.com/office/drawing/2010/main" val="0"/>
+              </a:ext>
+              <a:ext uri="{96DAC541-7B7A-43D3-8B79-37D633B846F1}">
+                <asvg:svgBlip xmlns:asvg="http://schemas.microsoft.com/office/drawing/2016/SVG/main" r:embed="rId6"/>
+              </a:ext>
+            </a:extLst>
+          </a:blip>
+          <a:stretch>
+            <a:fillRect/>
+          </a:stretch>
+        </a:blipFill>
+        <a:ln w="19050" cap="flat" cmpd="sng" algn="ctr">
+          <a:solidFill>
+            <a:schemeClr val="lt1">
+              <a:hueOff val="0"/>
+              <a:satOff val="0"/>
+              <a:lumOff val="0"/>
+              <a:alphaOff val="0"/>
+            </a:schemeClr>
+          </a:solidFill>
+          <a:prstDash val="solid"/>
+          <a:miter lim="800000"/>
+        </a:ln>
+        <a:effectLst/>
+      </dsp:spPr>
+      <dsp:style>
+        <a:lnRef idx="2">
+          <a:scrgbClr r="0" g="0" b="0"/>
+        </a:lnRef>
+        <a:fillRef idx="1">
+          <a:scrgbClr r="0" g="0" b="0"/>
+        </a:fillRef>
+        <a:effectRef idx="0">
+          <a:scrgbClr r="0" g="0" b="0"/>
+        </a:effectRef>
+        <a:fontRef idx="minor">
+          <a:schemeClr val="lt1"/>
+        </a:fontRef>
+      </dsp:style>
+    </dsp:sp>
+    <dsp:sp modelId="{B2D728B1-EBB0-4B82-A07E-5A89FFDCFC6C}">
+      <dsp:nvSpPr>
+        <dsp:cNvPr id="0" name=""/>
+        <dsp:cNvSpPr/>
+      </dsp:nvSpPr>
+      <dsp:spPr>
+        <a:xfrm>
+          <a:off x="846825" y="1821070"/>
+          <a:ext cx="1544923" cy="655422"/>
+        </a:xfrm>
+        <a:prstGeom prst="rect">
+          <a:avLst/>
+        </a:prstGeom>
+        <a:noFill/>
+        <a:ln>
+          <a:noFill/>
+        </a:ln>
+        <a:effectLst/>
+      </dsp:spPr>
+      <dsp:style>
+        <a:lnRef idx="0">
+          <a:scrgbClr r="0" g="0" b="0"/>
+        </a:lnRef>
+        <a:fillRef idx="0">
+          <a:scrgbClr r="0" g="0" b="0"/>
+        </a:fillRef>
+        <a:effectRef idx="0">
+          <a:scrgbClr r="0" g="0" b="0"/>
+        </a:effectRef>
+        <a:fontRef idx="minor"/>
+      </dsp:style>
+      <dsp:txBody>
+        <a:bodyPr spcFirstLastPara="0" vert="horz" wrap="square" lIns="0" tIns="0" rIns="0" bIns="0" numCol="1" spcCol="1270" anchor="ctr" anchorCtr="0">
+          <a:noAutofit/>
+        </a:bodyPr>
+        <a:lstStyle/>
+        <a:p>
+          <a:pPr marL="0" lvl="0" indent="0" algn="l" defTabSz="889000">
+            <a:lnSpc>
+              <a:spcPct val="100000"/>
+            </a:lnSpc>
+            <a:spcBef>
+              <a:spcPct val="0"/>
+            </a:spcBef>
+            <a:spcAft>
+              <a:spcPct val="35000"/>
+            </a:spcAft>
+            <a:buNone/>
+          </a:pPr>
+          <a:r>
+            <a:rPr lang="en-GB" sz="2000" kern="1200" dirty="0" err="1"/>
+            <a:t>Ultralytics</a:t>
+          </a:r>
+          <a:r>
+            <a:rPr lang="en-GB" sz="2000" kern="1200" dirty="0"/>
+            <a:t> - Framework</a:t>
+          </a:r>
+          <a:endParaRPr lang="en-US" sz="2000" kern="1200" dirty="0"/>
+        </a:p>
+      </dsp:txBody>
+      <dsp:txXfrm>
+        <a:off x="846825" y="1821070"/>
+        <a:ext cx="1544923" cy="655422"/>
+      </dsp:txXfrm>
+    </dsp:sp>
+    <dsp:sp modelId="{D086BA99-BDD5-4735-80BD-B0517490BB2B}">
+      <dsp:nvSpPr>
+        <dsp:cNvPr id="0" name=""/>
+        <dsp:cNvSpPr/>
+      </dsp:nvSpPr>
+      <dsp:spPr>
+        <a:xfrm>
+          <a:off x="2660939" y="1821070"/>
+          <a:ext cx="655422" cy="655422"/>
+        </a:xfrm>
+        <a:prstGeom prst="ellipse">
+          <a:avLst/>
+        </a:prstGeom>
+        <a:solidFill>
+          <a:schemeClr val="accent1">
+            <a:tint val="40000"/>
+            <a:hueOff val="0"/>
+            <a:satOff val="0"/>
+            <a:lumOff val="0"/>
+            <a:alphaOff val="0"/>
+          </a:schemeClr>
+        </a:solidFill>
+        <a:ln>
+          <a:noFill/>
+        </a:ln>
+        <a:effectLst/>
+      </dsp:spPr>
+      <dsp:style>
+        <a:lnRef idx="0">
+          <a:scrgbClr r="0" g="0" b="0"/>
+        </a:lnRef>
+        <a:fillRef idx="1">
+          <a:scrgbClr r="0" g="0" b="0"/>
+        </a:fillRef>
+        <a:effectRef idx="0">
+          <a:scrgbClr r="0" g="0" b="0"/>
+        </a:effectRef>
+        <a:fontRef idx="minor"/>
+      </dsp:style>
+    </dsp:sp>
+    <dsp:sp modelId="{31A3621F-3969-491A-A712-E795557EBBD1}">
+      <dsp:nvSpPr>
+        <dsp:cNvPr id="0" name=""/>
+        <dsp:cNvSpPr/>
+      </dsp:nvSpPr>
+      <dsp:spPr>
+        <a:xfrm>
+          <a:off x="2798578" y="1958709"/>
+          <a:ext cx="380144" cy="380144"/>
+        </a:xfrm>
+        <a:prstGeom prst="rect">
+          <a:avLst/>
+        </a:prstGeom>
+        <a:blipFill>
+          <a:blip xmlns:r="http://schemas.openxmlformats.org/officeDocument/2006/relationships" r:embed="rId7">
+            <a:extLst>
+              <a:ext uri="{28A0092B-C50C-407E-A947-70E740481C1C}">
+                <a14:useLocalDpi xmlns:a14="http://schemas.microsoft.com/office/drawing/2010/main" val="0"/>
+              </a:ext>
+              <a:ext uri="{96DAC541-7B7A-43D3-8B79-37D633B846F1}">
+                <asvg:svgBlip xmlns:asvg="http://schemas.microsoft.com/office/drawing/2016/SVG/main" r:embed="rId8"/>
+              </a:ext>
+            </a:extLst>
+          </a:blip>
+          <a:stretch>
+            <a:fillRect/>
+          </a:stretch>
+        </a:blipFill>
+        <a:ln w="19050" cap="flat" cmpd="sng" algn="ctr">
+          <a:solidFill>
+            <a:schemeClr val="lt1">
+              <a:hueOff val="0"/>
+              <a:satOff val="0"/>
+              <a:lumOff val="0"/>
+              <a:alphaOff val="0"/>
+            </a:schemeClr>
+          </a:solidFill>
+          <a:prstDash val="solid"/>
+          <a:miter lim="800000"/>
+        </a:ln>
+        <a:effectLst/>
+      </dsp:spPr>
+      <dsp:style>
+        <a:lnRef idx="2">
+          <a:scrgbClr r="0" g="0" b="0"/>
+        </a:lnRef>
+        <a:fillRef idx="1">
+          <a:scrgbClr r="0" g="0" b="0"/>
+        </a:fillRef>
+        <a:effectRef idx="0">
+          <a:scrgbClr r="0" g="0" b="0"/>
+        </a:effectRef>
+        <a:fontRef idx="minor">
+          <a:schemeClr val="lt1"/>
+        </a:fontRef>
+      </dsp:style>
+    </dsp:sp>
+    <dsp:sp modelId="{849CD35C-B223-47BF-8151-9396B4E709FE}">
+      <dsp:nvSpPr>
+        <dsp:cNvPr id="0" name=""/>
+        <dsp:cNvSpPr/>
+      </dsp:nvSpPr>
+      <dsp:spPr>
+        <a:xfrm>
+          <a:off x="3456809" y="1821070"/>
+          <a:ext cx="1544923" cy="655422"/>
+        </a:xfrm>
+        <a:prstGeom prst="rect">
+          <a:avLst/>
+        </a:prstGeom>
+        <a:noFill/>
+        <a:ln>
+          <a:noFill/>
+        </a:ln>
+        <a:effectLst/>
+      </dsp:spPr>
+      <dsp:style>
+        <a:lnRef idx="0">
+          <a:scrgbClr r="0" g="0" b="0"/>
+        </a:lnRef>
+        <a:fillRef idx="0">
+          <a:scrgbClr r="0" g="0" b="0"/>
+        </a:fillRef>
+        <a:effectRef idx="0">
+          <a:scrgbClr r="0" g="0" b="0"/>
+        </a:effectRef>
+        <a:fontRef idx="minor"/>
+      </dsp:style>
+      <dsp:txBody>
+        <a:bodyPr spcFirstLastPara="0" vert="horz" wrap="square" lIns="0" tIns="0" rIns="0" bIns="0" numCol="1" spcCol="1270" anchor="ctr" anchorCtr="0">
+          <a:noAutofit/>
+        </a:bodyPr>
+        <a:lstStyle/>
+        <a:p>
+          <a:pPr marL="0" lvl="0" indent="0" algn="l" defTabSz="889000">
+            <a:lnSpc>
+              <a:spcPct val="100000"/>
+            </a:lnSpc>
+            <a:spcBef>
+              <a:spcPct val="0"/>
+            </a:spcBef>
+            <a:spcAft>
+              <a:spcPct val="35000"/>
+            </a:spcAft>
+            <a:buNone/>
+          </a:pPr>
+          <a:r>
+            <a:rPr lang="en-GB" sz="2000" kern="1200" dirty="0"/>
+            <a:t>OpenCV – Computer Vision Library</a:t>
+          </a:r>
+          <a:endParaRPr lang="en-US" sz="2000" kern="1200" dirty="0"/>
+        </a:p>
+      </dsp:txBody>
+      <dsp:txXfrm>
+        <a:off x="3456809" y="1821070"/>
+        <a:ext cx="1544923" cy="655422"/>
+      </dsp:txXfrm>
+    </dsp:sp>
+    <dsp:sp modelId="{230E90DD-B592-4283-A161-126B3624F6DA}">
+      <dsp:nvSpPr>
+        <dsp:cNvPr id="0" name=""/>
+        <dsp:cNvSpPr/>
+      </dsp:nvSpPr>
+      <dsp:spPr>
+        <a:xfrm>
+          <a:off x="50955" y="3490959"/>
+          <a:ext cx="655422" cy="655422"/>
+        </a:xfrm>
+        <a:prstGeom prst="ellipse">
+          <a:avLst/>
+        </a:prstGeom>
+        <a:solidFill>
+          <a:schemeClr val="accent1">
+            <a:tint val="40000"/>
+            <a:hueOff val="0"/>
+            <a:satOff val="0"/>
+            <a:lumOff val="0"/>
+            <a:alphaOff val="0"/>
+          </a:schemeClr>
+        </a:solidFill>
+        <a:ln>
+          <a:noFill/>
+        </a:ln>
+        <a:effectLst/>
+      </dsp:spPr>
+      <dsp:style>
+        <a:lnRef idx="0">
+          <a:scrgbClr r="0" g="0" b="0"/>
+        </a:lnRef>
+        <a:fillRef idx="1">
+          <a:scrgbClr r="0" g="0" b="0"/>
+        </a:fillRef>
+        <a:effectRef idx="0">
+          <a:scrgbClr r="0" g="0" b="0"/>
+        </a:effectRef>
+        <a:fontRef idx="minor"/>
+      </dsp:style>
+    </dsp:sp>
+    <dsp:sp modelId="{1E2A6E66-6D92-4B3C-946C-D067F50F008C}">
+      <dsp:nvSpPr>
+        <dsp:cNvPr id="0" name=""/>
+        <dsp:cNvSpPr/>
+      </dsp:nvSpPr>
+      <dsp:spPr>
+        <a:xfrm>
+          <a:off x="188594" y="3628598"/>
+          <a:ext cx="380144" cy="380144"/>
+        </a:xfrm>
+        <a:prstGeom prst="rect">
+          <a:avLst/>
+        </a:prstGeom>
+        <a:blipFill>
+          <a:blip xmlns:r="http://schemas.openxmlformats.org/officeDocument/2006/relationships" r:embed="rId9">
+            <a:extLst>
+              <a:ext uri="{28A0092B-C50C-407E-A947-70E740481C1C}">
+                <a14:useLocalDpi xmlns:a14="http://schemas.microsoft.com/office/drawing/2010/main" val="0"/>
+              </a:ext>
+              <a:ext uri="{96DAC541-7B7A-43D3-8B79-37D633B846F1}">
+                <asvg:svgBlip xmlns:asvg="http://schemas.microsoft.com/office/drawing/2016/SVG/main" r:embed="rId10"/>
+              </a:ext>
+            </a:extLst>
+          </a:blip>
+          <a:stretch>
+            <a:fillRect/>
+          </a:stretch>
+        </a:blipFill>
+        <a:ln w="19050" cap="flat" cmpd="sng" algn="ctr">
+          <a:solidFill>
+            <a:schemeClr val="lt1">
+              <a:hueOff val="0"/>
+              <a:satOff val="0"/>
+              <a:lumOff val="0"/>
+              <a:alphaOff val="0"/>
+            </a:schemeClr>
+          </a:solidFill>
+          <a:prstDash val="solid"/>
+          <a:miter lim="800000"/>
+        </a:ln>
+        <a:effectLst/>
+      </dsp:spPr>
+      <dsp:style>
+        <a:lnRef idx="2">
+          <a:scrgbClr r="0" g="0" b="0"/>
+        </a:lnRef>
+        <a:fillRef idx="1">
+          <a:scrgbClr r="0" g="0" b="0"/>
+        </a:fillRef>
+        <a:effectRef idx="0">
+          <a:scrgbClr r="0" g="0" b="0"/>
+        </a:effectRef>
+        <a:fontRef idx="minor">
+          <a:schemeClr val="lt1"/>
+        </a:fontRef>
+      </dsp:style>
+    </dsp:sp>
+    <dsp:sp modelId="{2C92A4C9-A4A1-486F-BB11-2CE4FCC41BC8}">
+      <dsp:nvSpPr>
+        <dsp:cNvPr id="0" name=""/>
+        <dsp:cNvSpPr/>
+      </dsp:nvSpPr>
+      <dsp:spPr>
+        <a:xfrm>
+          <a:off x="846825" y="3490959"/>
+          <a:ext cx="1544923" cy="655422"/>
+        </a:xfrm>
+        <a:prstGeom prst="rect">
+          <a:avLst/>
+        </a:prstGeom>
+        <a:noFill/>
+        <a:ln>
+          <a:noFill/>
+        </a:ln>
+        <a:effectLst/>
+      </dsp:spPr>
+      <dsp:style>
+        <a:lnRef idx="0">
+          <a:scrgbClr r="0" g="0" b="0"/>
+        </a:lnRef>
+        <a:fillRef idx="0">
+          <a:scrgbClr r="0" g="0" b="0"/>
+        </a:fillRef>
+        <a:effectRef idx="0">
+          <a:scrgbClr r="0" g="0" b="0"/>
+        </a:effectRef>
+        <a:fontRef idx="minor"/>
+      </dsp:style>
+      <dsp:txBody>
+        <a:bodyPr spcFirstLastPara="0" vert="horz" wrap="square" lIns="0" tIns="0" rIns="0" bIns="0" numCol="1" spcCol="1270" anchor="ctr" anchorCtr="0">
+          <a:noAutofit/>
+        </a:bodyPr>
+        <a:lstStyle/>
+        <a:p>
+          <a:pPr marL="0" lvl="0" indent="0" algn="l" defTabSz="889000">
+            <a:lnSpc>
+              <a:spcPct val="100000"/>
+            </a:lnSpc>
+            <a:spcBef>
+              <a:spcPct val="0"/>
+            </a:spcBef>
+            <a:spcAft>
+              <a:spcPct val="35000"/>
+            </a:spcAft>
+            <a:buNone/>
+          </a:pPr>
+          <a:r>
+            <a:rPr lang="en-GB" sz="2000" kern="1200" dirty="0"/>
+            <a:t>Flask – Web Framework</a:t>
+          </a:r>
+          <a:endParaRPr lang="en-US" sz="2000" kern="1200" dirty="0"/>
+        </a:p>
+      </dsp:txBody>
+      <dsp:txXfrm>
+        <a:off x="846825" y="3490959"/>
+        <a:ext cx="1544923" cy="655422"/>
+      </dsp:txXfrm>
+    </dsp:sp>
+    <dsp:sp modelId="{5E08B028-D48B-43E3-8B29-4B2BAEB7BB71}">
+      <dsp:nvSpPr>
+        <dsp:cNvPr id="0" name=""/>
+        <dsp:cNvSpPr/>
+      </dsp:nvSpPr>
+      <dsp:spPr>
+        <a:xfrm>
+          <a:off x="2660939" y="3490959"/>
+          <a:ext cx="655422" cy="655422"/>
+        </a:xfrm>
+        <a:prstGeom prst="ellipse">
+          <a:avLst/>
+        </a:prstGeom>
+        <a:solidFill>
+          <a:schemeClr val="accent1">
+            <a:tint val="40000"/>
+            <a:hueOff val="0"/>
+            <a:satOff val="0"/>
+            <a:lumOff val="0"/>
+            <a:alphaOff val="0"/>
+          </a:schemeClr>
+        </a:solidFill>
+        <a:ln>
+          <a:noFill/>
+        </a:ln>
+        <a:effectLst/>
+      </dsp:spPr>
+      <dsp:style>
+        <a:lnRef idx="0">
+          <a:scrgbClr r="0" g="0" b="0"/>
+        </a:lnRef>
+        <a:fillRef idx="1">
+          <a:scrgbClr r="0" g="0" b="0"/>
+        </a:fillRef>
+        <a:effectRef idx="0">
+          <a:scrgbClr r="0" g="0" b="0"/>
+        </a:effectRef>
+        <a:fontRef idx="minor"/>
+      </dsp:style>
+    </dsp:sp>
+    <dsp:sp modelId="{5C0DFA92-FC88-416D-A93F-4F63BA45CB72}">
+      <dsp:nvSpPr>
+        <dsp:cNvPr id="0" name=""/>
+        <dsp:cNvSpPr/>
+      </dsp:nvSpPr>
+      <dsp:spPr>
+        <a:xfrm>
+          <a:off x="2798578" y="3628598"/>
+          <a:ext cx="380144" cy="380144"/>
+        </a:xfrm>
+        <a:prstGeom prst="rect">
+          <a:avLst/>
+        </a:prstGeom>
+        <a:blipFill>
+          <a:blip xmlns:r="http://schemas.openxmlformats.org/officeDocument/2006/relationships" r:embed="rId11">
+            <a:extLst>
+              <a:ext uri="{28A0092B-C50C-407E-A947-70E740481C1C}">
+                <a14:useLocalDpi xmlns:a14="http://schemas.microsoft.com/office/drawing/2010/main" val="0"/>
+              </a:ext>
+              <a:ext uri="{96DAC541-7B7A-43D3-8B79-37D633B846F1}">
+                <asvg:svgBlip xmlns:asvg="http://schemas.microsoft.com/office/drawing/2016/SVG/main" r:embed="rId12"/>
+              </a:ext>
+            </a:extLst>
+          </a:blip>
+          <a:stretch>
+            <a:fillRect/>
+          </a:stretch>
+        </a:blipFill>
+        <a:ln w="19050" cap="flat" cmpd="sng" algn="ctr">
+          <a:solidFill>
+            <a:schemeClr val="lt1">
+              <a:hueOff val="0"/>
+              <a:satOff val="0"/>
+              <a:lumOff val="0"/>
+              <a:alphaOff val="0"/>
+            </a:schemeClr>
+          </a:solidFill>
+          <a:prstDash val="solid"/>
+          <a:miter lim="800000"/>
+        </a:ln>
+        <a:effectLst/>
+      </dsp:spPr>
+      <dsp:style>
+        <a:lnRef idx="2">
+          <a:scrgbClr r="0" g="0" b="0"/>
+        </a:lnRef>
+        <a:fillRef idx="1">
+          <a:scrgbClr r="0" g="0" b="0"/>
+        </a:fillRef>
+        <a:effectRef idx="0">
+          <a:scrgbClr r="0" g="0" b="0"/>
+        </a:effectRef>
+        <a:fontRef idx="minor">
+          <a:schemeClr val="lt1"/>
+        </a:fontRef>
+      </dsp:style>
+    </dsp:sp>
+    <dsp:sp modelId="{F4629CC3-0C20-4301-9F76-4BAD0A2A8F00}">
+      <dsp:nvSpPr>
+        <dsp:cNvPr id="0" name=""/>
+        <dsp:cNvSpPr/>
+      </dsp:nvSpPr>
+      <dsp:spPr>
+        <a:xfrm>
+          <a:off x="3456809" y="3490959"/>
+          <a:ext cx="1544923" cy="655422"/>
+        </a:xfrm>
+        <a:prstGeom prst="rect">
+          <a:avLst/>
+        </a:prstGeom>
+        <a:noFill/>
+        <a:ln>
+          <a:noFill/>
+        </a:ln>
+        <a:effectLst/>
+      </dsp:spPr>
+      <dsp:style>
+        <a:lnRef idx="0">
+          <a:scrgbClr r="0" g="0" b="0"/>
+        </a:lnRef>
+        <a:fillRef idx="0">
+          <a:scrgbClr r="0" g="0" b="0"/>
+        </a:fillRef>
+        <a:effectRef idx="0">
+          <a:scrgbClr r="0" g="0" b="0"/>
+        </a:effectRef>
+        <a:fontRef idx="minor"/>
+      </dsp:style>
+      <dsp:txBody>
+        <a:bodyPr spcFirstLastPara="0" vert="horz" wrap="square" lIns="0" tIns="0" rIns="0" bIns="0" numCol="1" spcCol="1270" anchor="ctr" anchorCtr="0">
+          <a:noAutofit/>
+        </a:bodyPr>
+        <a:lstStyle/>
+        <a:p>
+          <a:pPr marL="0" lvl="0" indent="0" algn="l" defTabSz="933450">
+            <a:lnSpc>
+              <a:spcPct val="100000"/>
+            </a:lnSpc>
+            <a:spcBef>
+              <a:spcPct val="0"/>
+            </a:spcBef>
+            <a:spcAft>
+              <a:spcPct val="35000"/>
+            </a:spcAft>
+            <a:buNone/>
+          </a:pPr>
+          <a:r>
+            <a:rPr lang="en-GB" sz="2100" kern="1200"/>
+            <a:t>React – Front End</a:t>
+          </a:r>
+          <a:endParaRPr lang="en-US" sz="2100" kern="1200"/>
+        </a:p>
+      </dsp:txBody>
+      <dsp:txXfrm>
+        <a:off x="3456809" y="3490959"/>
+        <a:ext cx="1544923" cy="655422"/>
+      </dsp:txXfrm>
+    </dsp:sp>
+    <dsp:sp modelId="{58B8AE8F-260D-42F7-BBE5-DD2F7E1CBF28}">
+      <dsp:nvSpPr>
+        <dsp:cNvPr id="0" name=""/>
+        <dsp:cNvSpPr/>
+      </dsp:nvSpPr>
+      <dsp:spPr>
+        <a:xfrm>
+          <a:off x="50955" y="5160848"/>
+          <a:ext cx="655422" cy="655422"/>
+        </a:xfrm>
+        <a:prstGeom prst="ellipse">
+          <a:avLst/>
+        </a:prstGeom>
+        <a:solidFill>
+          <a:schemeClr val="accent1">
+            <a:tint val="40000"/>
+            <a:hueOff val="0"/>
+            <a:satOff val="0"/>
+            <a:lumOff val="0"/>
+            <a:alphaOff val="0"/>
+          </a:schemeClr>
+        </a:solidFill>
+        <a:ln>
+          <a:noFill/>
+        </a:ln>
+        <a:effectLst/>
+      </dsp:spPr>
+      <dsp:style>
+        <a:lnRef idx="0">
+          <a:scrgbClr r="0" g="0" b="0"/>
+        </a:lnRef>
+        <a:fillRef idx="1">
+          <a:scrgbClr r="0" g="0" b="0"/>
+        </a:fillRef>
+        <a:effectRef idx="0">
+          <a:scrgbClr r="0" g="0" b="0"/>
+        </a:effectRef>
+        <a:fontRef idx="minor"/>
+      </dsp:style>
+    </dsp:sp>
+    <dsp:sp modelId="{93F08456-3D4B-4A75-9D1B-DAA22C0971BE}">
+      <dsp:nvSpPr>
+        <dsp:cNvPr id="0" name=""/>
+        <dsp:cNvSpPr/>
+      </dsp:nvSpPr>
+      <dsp:spPr>
+        <a:xfrm>
+          <a:off x="188594" y="5298486"/>
+          <a:ext cx="380144" cy="380144"/>
+        </a:xfrm>
+        <a:prstGeom prst="rect">
+          <a:avLst/>
+        </a:prstGeom>
+        <a:blipFill>
+          <a:blip xmlns:r="http://schemas.openxmlformats.org/officeDocument/2006/relationships" r:embed="rId13">
+            <a:extLst>
+              <a:ext uri="{28A0092B-C50C-407E-A947-70E740481C1C}">
+                <a14:useLocalDpi xmlns:a14="http://schemas.microsoft.com/office/drawing/2010/main" val="0"/>
+              </a:ext>
+              <a:ext uri="{96DAC541-7B7A-43D3-8B79-37D633B846F1}">
+                <asvg:svgBlip xmlns:asvg="http://schemas.microsoft.com/office/drawing/2016/SVG/main" r:embed="rId14"/>
+              </a:ext>
+            </a:extLst>
+          </a:blip>
+          <a:stretch>
+            <a:fillRect/>
+          </a:stretch>
+        </a:blipFill>
+        <a:ln w="19050" cap="flat" cmpd="sng" algn="ctr">
+          <a:solidFill>
+            <a:schemeClr val="lt1">
+              <a:hueOff val="0"/>
+              <a:satOff val="0"/>
+              <a:lumOff val="0"/>
+              <a:alphaOff val="0"/>
+            </a:schemeClr>
+          </a:solidFill>
+          <a:prstDash val="solid"/>
+          <a:miter lim="800000"/>
+        </a:ln>
+        <a:effectLst/>
+      </dsp:spPr>
+      <dsp:style>
+        <a:lnRef idx="2">
+          <a:scrgbClr r="0" g="0" b="0"/>
+        </a:lnRef>
+        <a:fillRef idx="1">
+          <a:scrgbClr r="0" g="0" b="0"/>
+        </a:fillRef>
+        <a:effectRef idx="0">
+          <a:scrgbClr r="0" g="0" b="0"/>
+        </a:effectRef>
+        <a:fontRef idx="minor">
+          <a:schemeClr val="lt1"/>
+        </a:fontRef>
+      </dsp:style>
+    </dsp:sp>
+    <dsp:sp modelId="{1B40DF30-A746-419C-8E38-FCE8F971C852}">
+      <dsp:nvSpPr>
+        <dsp:cNvPr id="0" name=""/>
+        <dsp:cNvSpPr/>
+      </dsp:nvSpPr>
+      <dsp:spPr>
+        <a:xfrm>
+          <a:off x="846825" y="5160848"/>
+          <a:ext cx="1544923" cy="655422"/>
+        </a:xfrm>
+        <a:prstGeom prst="rect">
+          <a:avLst/>
+        </a:prstGeom>
+        <a:noFill/>
+        <a:ln>
+          <a:noFill/>
+        </a:ln>
+        <a:effectLst/>
+      </dsp:spPr>
+      <dsp:style>
+        <a:lnRef idx="0">
+          <a:scrgbClr r="0" g="0" b="0"/>
+        </a:lnRef>
+        <a:fillRef idx="0">
+          <a:scrgbClr r="0" g="0" b="0"/>
+        </a:fillRef>
+        <a:effectRef idx="0">
+          <a:scrgbClr r="0" g="0" b="0"/>
+        </a:effectRef>
+        <a:fontRef idx="minor"/>
+      </dsp:style>
+      <dsp:txBody>
+        <a:bodyPr spcFirstLastPara="0" vert="horz" wrap="square" lIns="0" tIns="0" rIns="0" bIns="0" numCol="1" spcCol="1270" anchor="ctr" anchorCtr="0">
+          <a:noAutofit/>
+        </a:bodyPr>
+        <a:lstStyle/>
+        <a:p>
+          <a:pPr marL="0" lvl="0" indent="0" algn="l" defTabSz="889000">
+            <a:lnSpc>
+              <a:spcPct val="100000"/>
+            </a:lnSpc>
+            <a:spcBef>
+              <a:spcPct val="0"/>
+            </a:spcBef>
+            <a:spcAft>
+              <a:spcPct val="35000"/>
+            </a:spcAft>
+            <a:buNone/>
+          </a:pPr>
+          <a:r>
+            <a:rPr lang="en-GB" sz="2000" kern="1200" dirty="0"/>
+            <a:t>SMTP – Email Service</a:t>
+          </a:r>
+          <a:endParaRPr lang="en-US" sz="2000" kern="1200" dirty="0"/>
+        </a:p>
+      </dsp:txBody>
+      <dsp:txXfrm>
+        <a:off x="846825" y="5160848"/>
+        <a:ext cx="1544923" cy="655422"/>
+      </dsp:txXfrm>
+    </dsp:sp>
+    <dsp:sp modelId="{90BBE456-1271-41E3-A4A0-7981AB2AB571}">
+      <dsp:nvSpPr>
+        <dsp:cNvPr id="0" name=""/>
+        <dsp:cNvSpPr/>
+      </dsp:nvSpPr>
+      <dsp:spPr>
+        <a:xfrm>
+          <a:off x="2660939" y="5160848"/>
+          <a:ext cx="655422" cy="655422"/>
+        </a:xfrm>
+        <a:prstGeom prst="ellipse">
+          <a:avLst/>
+        </a:prstGeom>
+        <a:solidFill>
+          <a:schemeClr val="accent1">
+            <a:tint val="40000"/>
+            <a:hueOff val="0"/>
+            <a:satOff val="0"/>
+            <a:lumOff val="0"/>
+            <a:alphaOff val="0"/>
+          </a:schemeClr>
+        </a:solidFill>
+        <a:ln>
+          <a:noFill/>
+        </a:ln>
+        <a:effectLst/>
+      </dsp:spPr>
+      <dsp:style>
+        <a:lnRef idx="0">
+          <a:scrgbClr r="0" g="0" b="0"/>
+        </a:lnRef>
+        <a:fillRef idx="1">
+          <a:scrgbClr r="0" g="0" b="0"/>
+        </a:fillRef>
+        <a:effectRef idx="0">
+          <a:scrgbClr r="0" g="0" b="0"/>
+        </a:effectRef>
+        <a:fontRef idx="minor"/>
+      </dsp:style>
+    </dsp:sp>
+    <dsp:sp modelId="{2B7FF431-6AED-4904-933E-DC5FEE4BFE90}">
+      <dsp:nvSpPr>
+        <dsp:cNvPr id="0" name=""/>
+        <dsp:cNvSpPr/>
+      </dsp:nvSpPr>
+      <dsp:spPr>
+        <a:xfrm>
+          <a:off x="2798578" y="5298486"/>
+          <a:ext cx="380144" cy="380144"/>
+        </a:xfrm>
+        <a:prstGeom prst="rect">
+          <a:avLst/>
+        </a:prstGeom>
+        <a:blipFill>
+          <a:blip xmlns:r="http://schemas.openxmlformats.org/officeDocument/2006/relationships" r:embed="rId15">
+            <a:extLst>
+              <a:ext uri="{28A0092B-C50C-407E-A947-70E740481C1C}">
+                <a14:useLocalDpi xmlns:a14="http://schemas.microsoft.com/office/drawing/2010/main" val="0"/>
+              </a:ext>
+              <a:ext uri="{96DAC541-7B7A-43D3-8B79-37D633B846F1}">
+                <asvg:svgBlip xmlns:asvg="http://schemas.microsoft.com/office/drawing/2016/SVG/main" r:embed="rId16"/>
+              </a:ext>
+            </a:extLst>
+          </a:blip>
+          <a:stretch>
+            <a:fillRect/>
+          </a:stretch>
+        </a:blipFill>
+        <a:ln w="19050" cap="flat" cmpd="sng" algn="ctr">
+          <a:solidFill>
+            <a:schemeClr val="lt1">
+              <a:hueOff val="0"/>
+              <a:satOff val="0"/>
+              <a:lumOff val="0"/>
+              <a:alphaOff val="0"/>
+            </a:schemeClr>
+          </a:solidFill>
+          <a:prstDash val="solid"/>
+          <a:miter lim="800000"/>
+        </a:ln>
+        <a:effectLst/>
+      </dsp:spPr>
+      <dsp:style>
+        <a:lnRef idx="2">
+          <a:scrgbClr r="0" g="0" b="0"/>
+        </a:lnRef>
+        <a:fillRef idx="1">
+          <a:scrgbClr r="0" g="0" b="0"/>
+        </a:fillRef>
+        <a:effectRef idx="0">
+          <a:scrgbClr r="0" g="0" b="0"/>
+        </a:effectRef>
+        <a:fontRef idx="minor">
+          <a:schemeClr val="lt1"/>
+        </a:fontRef>
+      </dsp:style>
+    </dsp:sp>
+    <dsp:sp modelId="{3F7E97DC-2B49-4675-ACFB-DE26AFA41FDD}">
+      <dsp:nvSpPr>
+        <dsp:cNvPr id="0" name=""/>
+        <dsp:cNvSpPr/>
+      </dsp:nvSpPr>
+      <dsp:spPr>
+        <a:xfrm>
+          <a:off x="3456809" y="5160848"/>
+          <a:ext cx="1544923" cy="655422"/>
+        </a:xfrm>
+        <a:prstGeom prst="rect">
+          <a:avLst/>
+        </a:prstGeom>
+        <a:noFill/>
+        <a:ln>
+          <a:noFill/>
+        </a:ln>
+        <a:effectLst/>
+      </dsp:spPr>
+      <dsp:style>
+        <a:lnRef idx="0">
+          <a:scrgbClr r="0" g="0" b="0"/>
+        </a:lnRef>
+        <a:fillRef idx="0">
+          <a:scrgbClr r="0" g="0" b="0"/>
+        </a:fillRef>
+        <a:effectRef idx="0">
+          <a:scrgbClr r="0" g="0" b="0"/>
+        </a:effectRef>
+        <a:fontRef idx="minor"/>
+      </dsp:style>
+      <dsp:txBody>
+        <a:bodyPr spcFirstLastPara="0" vert="horz" wrap="square" lIns="0" tIns="0" rIns="0" bIns="0" numCol="1" spcCol="1270" anchor="ctr" anchorCtr="0">
+          <a:noAutofit/>
+        </a:bodyPr>
+        <a:lstStyle/>
+        <a:p>
+          <a:pPr marL="0" lvl="0" indent="0" algn="l" defTabSz="933450">
+            <a:lnSpc>
+              <a:spcPct val="100000"/>
+            </a:lnSpc>
+            <a:spcBef>
+              <a:spcPct val="0"/>
+            </a:spcBef>
+            <a:spcAft>
+              <a:spcPct val="35000"/>
+            </a:spcAft>
+            <a:buNone/>
+          </a:pPr>
+          <a:r>
+            <a:rPr lang="en-GB" sz="2100" kern="1200"/>
+            <a:t>MySQL - Database</a:t>
+          </a:r>
+          <a:endParaRPr lang="en-US" sz="2100" kern="1200"/>
+        </a:p>
+      </dsp:txBody>
+      <dsp:txXfrm>
+        <a:off x="3456809" y="5160848"/>
+        <a:ext cx="1544923" cy="655422"/>
+      </dsp:txXfrm>
+    </dsp:sp>
+  </dsp:spTree>
+</dsp:drawing>
+</file>
+
+<file path=ppt/diagrams/layout1.xml><?xml version="1.0" encoding="utf-8"?>
+<dgm:layoutDef xmlns:dgm="http://schemas.openxmlformats.org/drawingml/2006/diagram" xmlns:a="http://schemas.openxmlformats.org/drawingml/2006/main" uniqueId="urn:microsoft.com/office/officeart/2018/2/layout/IconCircleList">
+  <dgm:title val="Icon Circle List"/>
+  <dgm:desc val="Use to show non-sequential or grouped chunks of information accompanied by related visuals. Circular shapes can hold an icon or small picture and corresponding text box shows Level 1 text. Works best for icons or small pictures with medium-length descriptions."/>
+  <dgm:catLst>
+    <dgm:cat type="icon" pri="500"/>
+  </dgm:catLst>
+  <dgm:sampData useDef="1">
+    <dgm:dataModel>
+      <dgm:ptLst/>
+      <dgm:bg/>
+      <dgm:whole/>
+    </dgm:dataModel>
+  </dgm:sampData>
+  <dgm:styleData useDef="1">
+    <dgm:dataModel>
+      <dgm:ptLst/>
+      <dgm:bg/>
+      <dgm:whole/>
+    </dgm:dataModel>
+  </dgm:styleData>
+  <dgm:clrData useDef="1">
+    <dgm:dataModel>
+      <dgm:ptLst/>
+      <dgm:bg/>
+      <dgm:whole/>
+    </dgm:dataModel>
+  </dgm:clrData>
+  <dgm:layoutNode name="root">
+    <dgm:varLst>
+      <dgm:dir/>
+      <dgm:resizeHandles val="exact"/>
+    </dgm:varLst>
+    <dgm:alg type="sp"/>
+    <dgm:shape xmlns:r="http://schemas.openxmlformats.org/officeDocument/2006/relationships" r:blip="">
+      <dgm:adjLst/>
+    </dgm:shape>
+    <dgm:presOf/>
+    <dgm:choose name="Name0">
+      <dgm:if name="Name1" axis="ch" ptType="node" func="cnt" op="lte" val="3">
+        <dgm:constrLst>
+          <dgm:constr type="w" for="ch" forName="container" refType="w"/>
+          <dgm:constr type="h" for="ch" forName="container" refType="h" fact="0.4"/>
+        </dgm:constrLst>
+      </dgm:if>
+      <dgm:else name="Name2">
+        <dgm:constrLst>
+          <dgm:constr type="w" for="ch" forName="container" refType="w"/>
+          <dgm:constr type="h" for="ch" forName="container" refType="h"/>
+        </dgm:constrLst>
+      </dgm:else>
+    </dgm:choose>
+    <dgm:ruleLst>
+      <dgm:rule type="h" for="ch" forName="container" val="INF" fact="NaN" max="NaN"/>
+    </dgm:ruleLst>
+    <dgm:layoutNode name="container">
+      <dgm:varLst>
+        <dgm:dir/>
+        <dgm:resizeHandles val="exact"/>
+      </dgm:varLst>
+      <dgm:choose name="Name3">
+        <dgm:if name="Name4" axis="self" func="var" arg="dir" op="equ" val="norm">
+          <dgm:alg type="snake">
+            <dgm:param type="grDir" val="tL"/>
+            <dgm:param type="flowDir" val="row"/>
+            <dgm:param type="contDir" val="sameDir"/>
+          </dgm:alg>
+        </dgm:if>
+        <dgm:else name="Name5">
+          <dgm:alg type="snake">
+            <dgm:param type="grDir" val="tR"/>
+            <dgm:param type="flowDir" val="row"/>
+            <dgm:param type="contDir" val="sameDir"/>
+          </dgm:alg>
+        </dgm:else>
+      </dgm:choose>
+      <dgm:shape xmlns:r="http://schemas.openxmlformats.org/officeDocument/2006/relationships" r:blip="">
+        <dgm:adjLst/>
+      </dgm:shape>
+      <dgm:presOf/>
+      <dgm:constrLst>
+        <dgm:constr type="w" for="ch" forName="compNode" refType="w"/>
+        <dgm:constr type="h" for="ch" forName="compNode" refType="w" fact="0.28"/>
+        <dgm:constr type="w" for="ch" forName="sibTrans" refType="w" refFor="ch" refForName="compNode" fact="0.115"/>
+        <dgm:constr type="sp" refType="h" op="equ" fact="0.17"/>
+        <dgm:constr type="primFontSz" for="des" ptType="node" op="equ" val="24"/>
+        <dgm:constr type="h" for="des" forName="compNode" op="equ"/>
+        <dgm:constr type="h" for="des" forName="iconBgRect" op="equ"/>
+      </dgm:constrLst>
+      <dgm:ruleLst>
+        <dgm:rule type="w" for="ch" forName="compNode" val="60" fact="NaN" max="NaN"/>
+      </dgm:ruleLst>
+      <dgm:forEach name="Name6" axis="ch" ptType="node">
+        <dgm:layoutNode name="compNode">
+          <dgm:alg type="composite"/>
+          <dgm:shape xmlns:r="http://schemas.openxmlformats.org/officeDocument/2006/relationships" r:blip="">
+            <dgm:adjLst/>
+          </dgm:shape>
+          <dgm:presOf axis="self"/>
+          <dgm:constrLst>
+            <dgm:constr type="w" for="ch" forName="iconBgRect" refType="w" fact="0.28"/>
+            <dgm:constr type="h" for="ch" forName="iconBgRect" refType="w" refFor="ch" refForName="iconBgRect"/>
+            <dgm:constr type="t" for="ch" forName="iconBgRect"/>
+            <dgm:constr type="l" for="ch" forName="iconBgRect"/>
+            <dgm:constr type="w" for="ch" forName="iconRect" refType="w" refFor="ch" refForName="iconBgRect" fact="0.58"/>
+            <dgm:constr type="h" for="ch" forName="iconRect" refType="w" refFor="ch" refForName="iconRect"/>
+            <dgm:constr type="ctrX" for="ch" forName="iconRect" refType="ctrX" refFor="ch" refForName="iconBgRect"/>
+            <dgm:constr type="ctrY" for="ch" forName="iconRect" refType="ctrY" refFor="ch" refForName="iconBgRect"/>
+            <dgm:constr type="w" for="ch" forName="spaceRect" refType="w" fact="0.06"/>
+            <dgm:constr type="h" for="ch" forName="spaceRect" refType="h" refFor="ch" refForName="iconBgRect"/>
+            <dgm:constr type="t" for="ch" forName="spaceRect" refType="t" refFor="ch" refForName="iconBgRect"/>
+            <dgm:constr type="l" for="ch" forName="spaceRect" refType="r" refFor="ch" refForName="iconBgRect"/>
+            <dgm:constr type="h" for="ch" forName="textRect" refType="h" refFor="ch" refForName="iconBgRect"/>
+            <dgm:constr type="t" for="ch" forName="textRect" refType="t" refFor="ch" refForName="iconBgRect"/>
+            <dgm:constr type="l" for="ch" forName="textRect" refType="r" refFor="ch" refForName="spaceRect"/>
+          </dgm:constrLst>
+          <dgm:ruleLst/>
+          <dgm:layoutNode name="iconBgRect" styleLbl="bgShp">
+            <dgm:alg type="sp"/>
+            <dgm:shape xmlns:r="http://schemas.openxmlformats.org/officeDocument/2006/relationships" type="ellipse" r:blip="">
+              <dgm:adjLst/>
+            </dgm:shape>
+            <dgm:presOf/>
+            <dgm:constrLst/>
+            <dgm:ruleLst/>
+          </dgm:layoutNode>
+          <dgm:layoutNode name="iconRect" styleLbl="node1">
+            <dgm:alg type="sp"/>
+            <dgm:shape xmlns:r="http://schemas.openxmlformats.org/officeDocument/2006/relationships" type="rect" r:blip="" blipPhldr="1">
+              <dgm:adjLst/>
+            </dgm:shape>
+            <dgm:presOf/>
+            <dgm:constrLst/>
+            <dgm:ruleLst/>
+          </dgm:layoutNode>
+          <dgm:layoutNode name="spaceRect">
+            <dgm:alg type="sp"/>
+            <dgm:shape xmlns:r="http://schemas.openxmlformats.org/officeDocument/2006/relationships" r:blip="">
+              <dgm:adjLst/>
+            </dgm:shape>
+            <dgm:presOf/>
+            <dgm:constrLst/>
+            <dgm:ruleLst/>
+          </dgm:layoutNode>
+          <dgm:layoutNode name="textRect" styleLbl="revTx">
+            <dgm:varLst>
+              <dgm:chMax val="1"/>
+              <dgm:chPref val="1"/>
+            </dgm:varLst>
+            <dgm:choose name="Name7">
+              <dgm:if name="Name8" func="var" arg="dir" op="equ" val="norm">
+                <dgm:alg type="tx">
+                  <dgm:param type="txAnchorVert" val="mid"/>
+                  <dgm:param type="parTxLTRAlign" val="l"/>
+                  <dgm:param type="shpTxLTRAlignCh" val="l"/>
+                  <dgm:param type="parTxRTLAlign" val="l"/>
+                  <dgm:param type="shpTxRTLAlignCh" val="l"/>
+                </dgm:alg>
+              </dgm:if>
+              <dgm:else name="Name9">
+                <dgm:alg type="tx">
+                  <dgm:param type="txAnchorVert" val="mid"/>
+                  <dgm:param type="parTxLTRAlign" val="r"/>
+                  <dgm:param type="shpTxLTRAlignCh" val="r"/>
+                  <dgm:param type="parTxRTLAlign" val="r"/>
+                  <dgm:param type="shpTxRTLAlignCh" val="r"/>
+                </dgm:alg>
+              </dgm:else>
+            </dgm:choose>
+            <dgm:shape xmlns:r="http://schemas.openxmlformats.org/officeDocument/2006/relationships" type="rect" r:blip="">
+              <dgm:adjLst/>
+            </dgm:shape>
+            <dgm:presOf axis="self" ptType="node"/>
+            <dgm:constrLst>
+              <dgm:constr type="lMarg"/>
+              <dgm:constr type="rMarg"/>
+              <dgm:constr type="tMarg"/>
+              <dgm:constr type="bMarg"/>
+            </dgm:constrLst>
+            <dgm:ruleLst>
+              <dgm:rule type="primFontSz" val="11" fact="NaN" max="NaN"/>
+            </dgm:ruleLst>
+          </dgm:layoutNode>
+        </dgm:layoutNode>
+        <dgm:forEach name="Name10" axis="followSib" ptType="sibTrans" cnt="1">
+          <dgm:layoutNode name="sibTrans">
+            <dgm:alg type="sp"/>
+            <dgm:shape xmlns:r="http://schemas.openxmlformats.org/officeDocument/2006/relationships" type="rect" r:blip="" hideGeom="1">
+              <dgm:adjLst/>
+            </dgm:shape>
+            <dgm:presOf axis="self"/>
+            <dgm:constrLst/>
+            <dgm:ruleLst/>
+          </dgm:layoutNode>
+        </dgm:forEach>
+      </dgm:forEach>
+    </dgm:layoutNode>
+  </dgm:layoutNode>
+  <dgm:extLst>
+    <a:ext uri="{68A01E43-0DF5-4B5B-8FA6-DAF915123BFB}">
+      <dgm1612:lstStyle xmlns:dgm1612="http://schemas.microsoft.com/office/drawing/2016/12/diagram">
+        <a:lvl1pPr>
+          <a:lnSpc>
+            <a:spcPct val="100000"/>
+          </a:lnSpc>
+        </a:lvl1pPr>
+      </dgm1612:lstStyle>
+    </a:ext>
+  </dgm:extLst>
+</dgm:layoutDef>
+</file>
+
+<file path=ppt/diagrams/quickStyle1.xml><?xml version="1.0" encoding="utf-8"?>
+<dgm:styleDef xmlns:dgm="http://schemas.openxmlformats.org/drawingml/2006/diagram" xmlns:a="http://schemas.openxmlformats.org/drawingml/2006/main" uniqueId="urn:microsoft.com/office/officeart/2005/8/quickstyle/simple1">
+  <dgm:title val=""/>
+  <dgm:desc val=""/>
+  <dgm:catLst>
+    <dgm:cat type="simple" pri="10100"/>
+  </dgm:catLst>
+  <dgm:scene3d>
+    <a:camera prst="orthographicFront"/>
+    <a:lightRig rig="threePt" dir="t"/>
+  </dgm:scene3d>
+  <dgm:styleLbl name="node0">
+    <dgm:scene3d>
+      <a:camera prst="orthographicFront"/>
+      <a:lightRig rig="threePt" dir="t"/>
+    </dgm:scene3d>
+    <dgm:sp3d/>
+    <dgm:txPr/>
+    <dgm:style>
+      <a:lnRef idx="2">
+        <a:scrgbClr r="0" g="0" b="0"/>
+      </a:lnRef>
+      <a:fillRef idx="1">
+        <a:scrgbClr r="0" g="0" b="0"/>
+      </a:fillRef>
+      <a:effectRef idx="0">
+        <a:scrgbClr r="0" g="0" b="0"/>
+      </a:effectRef>
+      <a:fontRef idx="minor">
+        <a:schemeClr val="lt1"/>
+      </a:fontRef>
+    </dgm:style>
+  </dgm:styleLbl>
+  <dgm:styleLbl name="lnNode1">
+    <dgm:scene3d>
+      <a:camera prst="orthographicFront"/>
+      <a:lightRig rig="threePt" dir="t"/>
+    </dgm:scene3d>
+    <dgm:sp3d/>
+    <dgm:txPr/>
+    <dgm:style>
+      <a:lnRef idx="2">
+        <a:scrgbClr r="0" g="0" b="0"/>
+      </a:lnRef>
+      <a:fillRef idx="1">
+        <a:scrgbClr r="0" g="0" b="0"/>
+      </a:fillRef>
+      <a:effectRef idx="0">
+        <a:scrgbClr r="0" g="0" b="0"/>
+      </a:effectRef>
+      <a:fontRef idx="minor">
+        <a:schemeClr val="lt1"/>
+      </a:fontRef>
+    </dgm:style>
+  </dgm:styleLbl>
+  <dgm:styleLbl name="vennNode1">
+    <dgm:scene3d>
+      <a:camera prst="orthographicFront"/>
+      <a:lightRig rig="threePt" dir="t"/>
+    </dgm:scene3d>
+    <dgm:sp3d/>
+    <dgm:txPr/>
+    <dgm:style>
+      <a:lnRef idx="2">
+        <a:scrgbClr r="0" g="0" b="0"/>
+      </a:lnRef>
+      <a:fillRef idx="1">
+        <a:scrgbClr r="0" g="0" b="0"/>
+      </a:fillRef>
+      <a:effectRef idx="0">
+        <a:scrgbClr r="0" g="0" b="0"/>
+      </a:effectRef>
+      <a:fontRef idx="minor">
+        <a:schemeClr val="tx1"/>
+      </a:fontRef>
+    </dgm:style>
+  </dgm:styleLbl>
+  <dgm:styleLbl name="alignNode1">
+    <dgm:scene3d>
+      <a:camera prst="orthographicFront"/>
+      <a:lightRig rig="threePt" dir="t"/>
+    </dgm:scene3d>
+    <dgm:sp3d/>
+    <dgm:txPr/>
+    <dgm:style>
+      <a:lnRef idx="2">
+        <a:scrgbClr r="0" g="0" b="0"/>
+      </a:lnRef>
+      <a:fillRef idx="1">
+        <a:scrgbClr r="0" g="0" b="0"/>
+      </a:fillRef>
+      <a:effectRef idx="0">
+        <a:scrgbClr r="0" g="0" b="0"/>
+      </a:effectRef>
+      <a:fontRef idx="minor">
+        <a:schemeClr val="lt1"/>
+      </a:fontRef>
+    </dgm:style>
+  </dgm:styleLbl>
+  <dgm:styleLbl name="node1">
+    <dgm:scene3d>
+      <a:camera prst="orthographicFront"/>
+      <a:lightRig rig="threePt" dir="t"/>
+    </dgm:scene3d>
+    <dgm:sp3d/>
+    <dgm:txPr/>
+    <dgm:style>
+      <a:lnRef idx="2">
+        <a:scrgbClr r="0" g="0" b="0"/>
+      </a:lnRef>
+      <a:fillRef idx="1">
+        <a:scrgbClr r="0" g="0" b="0"/>
+      </a:fillRef>
+      <a:effectRef idx="0">
+        <a:scrgbClr r="0" g="0" b="0"/>
+      </a:effectRef>
+      <a:fontRef idx="minor">
+        <a:schemeClr val="lt1"/>
+      </a:fontRef>
+    </dgm:style>
+  </dgm:styleLbl>
+  <dgm:styleLbl name="node2">
+    <dgm:scene3d>
+      <a:camera prst="orthographicFront"/>
+      <a:lightRig rig="threePt" dir="t"/>
+    </dgm:scene3d>
+    <dgm:sp3d/>
+    <dgm:txPr/>
+    <dgm:style>
+      <a:lnRef idx="2">
+        <a:scrgbClr r="0" g="0" b="0"/>
+      </a:lnRef>
+      <a:fillRef idx="1">
+        <a:scrgbClr r="0" g="0" b="0"/>
+      </a:fillRef>
+      <a:effectRef idx="0">
+        <a:scrgbClr r="0" g="0" b="0"/>
+      </a:effectRef>
+      <a:fontRef idx="minor">
+        <a:schemeClr val="lt1"/>
+      </a:fontRef>
+    </dgm:style>
+  </dgm:styleLbl>
+  <dgm:styleLbl name="node3">
+    <dgm:scene3d>
+      <a:camera prst="orthographicFront"/>
+      <a:lightRig rig="threePt" dir="t"/>
+    </dgm:scene3d>
+    <dgm:sp3d/>
+    <dgm:txPr/>
+    <dgm:style>
+      <a:lnRef idx="2">
+        <a:scrgbClr r="0" g="0" b="0"/>
+      </a:lnRef>
+      <a:fillRef idx="1">
+        <a:scrgbClr r="0" g="0" b="0"/>
+      </a:fillRef>
+      <a:effectRef idx="0">
+        <a:scrgbClr r="0" g="0" b="0"/>
+      </a:effectRef>
+      <a:fontRef idx="minor">
+        <a:schemeClr val="lt1"/>
+      </a:fontRef>
+    </dgm:style>
+  </dgm:styleLbl>
+  <dgm:styleLbl name="node4">
+    <dgm:scene3d>
+      <a:camera prst="orthographicFront"/>
+      <a:lightRig rig="threePt" dir="t"/>
+    </dgm:scene3d>
+    <dgm:sp3d/>
+    <dgm:txPr/>
+    <dgm:style>
+      <a:lnRef idx="2">
+        <a:scrgbClr r="0" g="0" b="0"/>
+      </a:lnRef>
+      <a:fillRef idx="1">
+        <a:scrgbClr r="0" g="0" b="0"/>
+      </a:fillRef>
+      <a:effectRef idx="0">
+        <a:scrgbClr r="0" g="0" b="0"/>
+      </a:effectRef>
+      <a:fontRef idx="minor">
+        <a:schemeClr val="lt1"/>
+      </a:fontRef>
+    </dgm:style>
+  </dgm:styleLbl>
+  <dgm:styleLbl name="fgImgPlace1">
+    <dgm:scene3d>
+      <a:camera prst="orthographicFront"/>
+      <a:lightRig rig="threePt" dir="t"/>
+    </dgm:scene3d>
+    <dgm:sp3d/>
+    <dgm:txPr/>
+    <dgm:style>
+      <a:lnRef idx="2">
+        <a:scrgbClr r="0" g="0" b="0"/>
+      </a:lnRef>
+      <a:fillRef idx="1">
+        <a:scrgbClr r="0" g="0" b="0"/>
+      </a:fillRef>
+      <a:effectRef idx="0">
+        <a:scrgbClr r="0" g="0" b="0"/>
+      </a:effectRef>
+      <a:fontRef idx="minor"/>
+    </dgm:style>
+  </dgm:styleLbl>
+  <dgm:styleLbl name="alignImgPlace1">
+    <dgm:scene3d>
+      <a:camera prst="orthographicFront"/>
+      <a:lightRig rig="threePt" dir="t"/>
+    </dgm:scene3d>
+    <dgm:sp3d/>
+    <dgm:txPr/>
+    <dgm:style>
+      <a:lnRef idx="2">
+        <a:scrgbClr r="0" g="0" b="0"/>
+      </a:lnRef>
+      <a:fillRef idx="1">
+        <a:scrgbClr r="0" g="0" b="0"/>
+      </a:fillRef>
+      <a:effectRef idx="0">
+        <a:scrgbClr r="0" g="0" b="0"/>
+      </a:effectRef>
+      <a:fontRef idx="minor"/>
+    </dgm:style>
+  </dgm:styleLbl>
+  <dgm:styleLbl name="bgImgPlace1">
+    <dgm:scene3d>
+      <a:camera prst="orthographicFront"/>
+      <a:lightRig rig="threePt" dir="t"/>
+    </dgm:scene3d>
+    <dgm:sp3d/>
+    <dgm:txPr/>
+    <dgm:style>
+      <a:lnRef idx="2">
+        <a:scrgbClr r="0" g="0" b="0"/>
+      </a:lnRef>
+      <a:fillRef idx="1">
+        <a:scrgbClr r="0" g="0" b="0"/>
+      </a:fillRef>
+      <a:effectRef idx="0">
+        <a:scrgbClr r="0" g="0" b="0"/>
+      </a:effectRef>
+      <a:fontRef idx="minor"/>
+    </dgm:style>
+  </dgm:styleLbl>
+  <dgm:styleLbl name="sibTrans2D1">
+    <dgm:scene3d>
+      <a:camera prst="orthographicFront"/>
+      <a:lightRig rig="threePt" dir="t"/>
+    </dgm:scene3d>
+    <dgm:sp3d/>
+    <dgm:txPr/>
+    <dgm:style>
+      <a:lnRef idx="0">
+        <a:scrgbClr r="0" g="0" b="0"/>
+      </a:lnRef>
+      <a:fillRef idx="1">
+        <a:scrgbClr r="0" g="0" b="0"/>
+      </a:fillRef>
+      <a:effectRef idx="0">
+        <a:scrgbClr r="0" g="0" b="0"/>
+      </a:effectRef>
+      <a:fontRef idx="minor">
+        <a:schemeClr val="lt1"/>
+      </a:fontRef>
+    </dgm:style>
+  </dgm:styleLbl>
+  <dgm:styleLbl name="fgSibTrans2D1">
+    <dgm:scene3d>
+      <a:camera prst="orthographicFront"/>
+      <a:lightRig rig="threePt" dir="t"/>
+    </dgm:scene3d>
+    <dgm:sp3d/>
+    <dgm:txPr/>
+    <dgm:style>
+      <a:lnRef idx="0">
+        <a:scrgbClr r="0" g="0" b="0"/>
+      </a:lnRef>
+      <a:fillRef idx="1">
+        <a:scrgbClr r="0" g="0" b="0"/>
+      </a:fillRef>
+      <a:effectRef idx="0">
+        <a:scrgbClr r="0" g="0" b="0"/>
+      </a:effectRef>
+      <a:fontRef idx="minor">
+        <a:schemeClr val="lt1"/>
+      </a:fontRef>
+    </dgm:style>
+  </dgm:styleLbl>
+  <dgm:styleLbl name="bgSibTrans2D1">
+    <dgm:scene3d>
+      <a:camera prst="orthographicFront"/>
+      <a:lightRig rig="threePt" dir="t"/>
+    </dgm:scene3d>
+    <dgm:sp3d/>
+    <dgm:txPr/>
+    <dgm:style>
+      <a:lnRef idx="0">
+        <a:scrgbClr r="0" g="0" b="0"/>
+      </a:lnRef>
+      <a:fillRef idx="1">
+        <a:scrgbClr r="0" g="0" b="0"/>
+      </a:fillRef>
+      <a:effectRef idx="0">
+        <a:scrgbClr r="0" g="0" b="0"/>
+      </a:effectRef>
+      <a:fontRef idx="minor">
+        <a:schemeClr val="lt1"/>
+      </a:fontRef>
+    </dgm:style>
+  </dgm:styleLbl>
+  <dgm:styleLbl name="sibTrans1D1">
+    <dgm:scene3d>
+      <a:camera prst="orthographicFront"/>
+      <a:lightRig rig="threePt" dir="t"/>
+    </dgm:scene3d>
+    <dgm:sp3d/>
+    <dgm:txPr/>
+    <dgm:style>
+      <a:lnRef idx="1">
+        <a:scrgbClr r="0" g="0" b="0"/>
+      </a:lnRef>
+      <a:fillRef idx="0">
+        <a:scrgbClr r="0" g="0" b="0"/>
+      </a:fillRef>
+      <a:effectRef idx="0">
+        <a:scrgbClr r="0" g="0" b="0"/>
+      </a:effectRef>
+      <a:fontRef idx="minor"/>
+    </dgm:style>
+  </dgm:styleLbl>
+  <dgm:styleLbl name="callout">
+    <dgm:scene3d>
+      <a:camera prst="orthographicFront"/>
+      <a:lightRig rig="threePt" dir="t"/>
+    </dgm:scene3d>
+    <dgm:sp3d/>
+    <dgm:txPr/>
+    <dgm:style>
+      <a:lnRef idx="2">
+        <a:scrgbClr r="0" g="0" b="0"/>
+      </a:lnRef>
+      <a:fillRef idx="1">
+        <a:scrgbClr r="0" g="0" b="0"/>
+      </a:fillRef>
+      <a:effectRef idx="0">
+        <a:scrgbClr r="0" g="0" b="0"/>
+      </a:effectRef>
+      <a:fontRef idx="minor"/>
+    </dgm:style>
+  </dgm:styleLbl>
+  <dgm:styleLbl name="asst0">
+    <dgm:scene3d>
+      <a:camera prst="orthographicFront"/>
+      <a:lightRig rig="threePt" dir="t"/>
+    </dgm:scene3d>
+    <dgm:sp3d/>
+    <dgm:txPr/>
+    <dgm:style>
+      <a:lnRef idx="2">
+        <a:scrgbClr r="0" g="0" b="0"/>
+      </a:lnRef>
+      <a:fillRef idx="1">
+        <a:scrgbClr r="0" g="0" b="0"/>
+      </a:fillRef>
+      <a:effectRef idx="0">
+        <a:scrgbClr r="0" g="0" b="0"/>
+      </a:effectRef>
+      <a:fontRef idx="minor">
+        <a:schemeClr val="lt1"/>
+      </a:fontRef>
+    </dgm:style>
+  </dgm:styleLbl>
+  <dgm:styleLbl name="asst1">
+    <dgm:scene3d>
+      <a:camera prst="orthographicFront"/>
+      <a:lightRig rig="threePt" dir="t"/>
+    </dgm:scene3d>
+    <dgm:sp3d/>
+    <dgm:txPr/>
+    <dgm:style>
+      <a:lnRef idx="2">
+        <a:scrgbClr r="0" g="0" b="0"/>
+      </a:lnRef>
+      <a:fillRef idx="1">
+        <a:scrgbClr r="0" g="0" b="0"/>
+      </a:fillRef>
+      <a:effectRef idx="0">
+        <a:scrgbClr r="0" g="0" b="0"/>
+      </a:effectRef>
+      <a:fontRef idx="minor">
+        <a:schemeClr val="lt1"/>
+      </a:fontRef>
+    </dgm:style>
+  </dgm:styleLbl>
+  <dgm:styleLbl name="asst2">
+    <dgm:scene3d>
+      <a:camera prst="orthographicFront"/>
+      <a:lightRig rig="threePt" dir="t"/>
+    </dgm:scene3d>
+    <dgm:sp3d/>
+    <dgm:txPr/>
+    <dgm:style>
+      <a:lnRef idx="2">
+        <a:scrgbClr r="0" g="0" b="0"/>
+      </a:lnRef>
+      <a:fillRef idx="1">
+        <a:scrgbClr r="0" g="0" b="0"/>
+      </a:fillRef>
+      <a:effectRef idx="0">
+        <a:scrgbClr r="0" g="0" b="0"/>
+      </a:effectRef>
+      <a:fontRef idx="minor">
+        <a:schemeClr val="lt1"/>
+      </a:fontRef>
+    </dgm:style>
+  </dgm:styleLbl>
+  <dgm:styleLbl name="asst3">
+    <dgm:scene3d>
+      <a:camera prst="orthographicFront"/>
+      <a:lightRig rig="threePt" dir="t"/>
+    </dgm:scene3d>
+    <dgm:sp3d/>
+    <dgm:txPr/>
+    <dgm:style>
+      <a:lnRef idx="2">
+        <a:scrgbClr r="0" g="0" b="0"/>
+      </a:lnRef>
+      <a:fillRef idx="1">
+        <a:scrgbClr r="0" g="0" b="0"/>
+      </a:fillRef>
+      <a:effectRef idx="0">
+        <a:scrgbClr r="0" g="0" b="0"/>
+      </a:effectRef>
+      <a:fontRef idx="minor">
+        <a:schemeClr val="lt1"/>
+      </a:fontRef>
+    </dgm:style>
+  </dgm:styleLbl>
+  <dgm:styleLbl name="asst4">
+    <dgm:scene3d>
+      <a:camera prst="orthographicFront"/>
+      <a:lightRig rig="threePt" dir="t"/>
+    </dgm:scene3d>
+    <dgm:sp3d/>
+    <dgm:txPr/>
+    <dgm:style>
+      <a:lnRef idx="2">
+        <a:scrgbClr r="0" g="0" b="0"/>
+      </a:lnRef>
+      <a:fillRef idx="1">
+        <a:scrgbClr r="0" g="0" b="0"/>
+      </a:fillRef>
+      <a:effectRef idx="0">
+        <a:scrgbClr r="0" g="0" b="0"/>
+      </a:effectRef>
+      <a:fontRef idx="minor">
+        <a:schemeClr val="lt1"/>
+      </a:fontRef>
+    </dgm:style>
+  </dgm:styleLbl>
+  <dgm:styleLbl name="parChTrans2D1">
+    <dgm:scene3d>
+      <a:camera prst="orthographicFront"/>
+      <a:lightRig rig="threePt" dir="t"/>
+    </dgm:scene3d>
+    <dgm:sp3d/>
+    <dgm:txPr/>
+    <dgm:style>
+      <a:lnRef idx="2">
+        <a:scrgbClr r="0" g="0" b="0"/>
+      </a:lnRef>
+      <a:fillRef idx="1">
+        <a:scrgbClr r="0" g="0" b="0"/>
+      </a:fillRef>
+      <a:effectRef idx="0">
+        <a:scrgbClr r="0" g="0" b="0"/>
+      </a:effectRef>
+      <a:fontRef idx="minor">
+        <a:schemeClr val="lt1"/>
+      </a:fontRef>
+    </dgm:style>
+  </dgm:styleLbl>
+  <dgm:styleLbl name="parChTrans2D2">
+    <dgm:scene3d>
+      <a:camera prst="orthographicFront"/>
+      <a:lightRig rig="threePt" dir="t"/>
+    </dgm:scene3d>
+    <dgm:sp3d/>
+    <dgm:txPr/>
+    <dgm:style>
+      <a:lnRef idx="2">
+        <a:scrgbClr r="0" g="0" b="0"/>
+      </a:lnRef>
+      <a:fillRef idx="1">
+        <a:scrgbClr r="0" g="0" b="0"/>
+      </a:fillRef>
+      <a:effectRef idx="0">
+        <a:scrgbClr r="0" g="0" b="0"/>
+      </a:effectRef>
+      <a:fontRef idx="minor">
+        <a:schemeClr val="lt1"/>
+      </a:fontRef>
+    </dgm:style>
+  </dgm:styleLbl>
+  <dgm:styleLbl name="parChTrans2D3">
+    <dgm:scene3d>
+      <a:camera prst="orthographicFront"/>
+      <a:lightRig rig="threePt" dir="t"/>
+    </dgm:scene3d>
+    <dgm:sp3d/>
+    <dgm:txPr/>
+    <dgm:style>
+      <a:lnRef idx="2">
+        <a:scrgbClr r="0" g="0" b="0"/>
+      </a:lnRef>
+      <a:fillRef idx="1">
+        <a:scrgbClr r="0" g="0" b="0"/>
+      </a:fillRef>
+      <a:effectRef idx="0">
+        <a:scrgbClr r="0" g="0" b="0"/>
+      </a:effectRef>
+      <a:fontRef idx="minor">
+        <a:schemeClr val="lt1"/>
+      </a:fontRef>
+    </dgm:style>
+  </dgm:styleLbl>
+  <dgm:styleLbl name="parChTrans2D4">
+    <dgm:scene3d>
+      <a:camera prst="orthographicFront"/>
+      <a:lightRig rig="threePt" dir="t"/>
+    </dgm:scene3d>
+    <dgm:sp3d/>
+    <dgm:txPr/>
+    <dgm:style>
+      <a:lnRef idx="2">
+        <a:scrgbClr r="0" g="0" b="0"/>
+      </a:lnRef>
+      <a:fillRef idx="1">
+        <a:scrgbClr r="0" g="0" b="0"/>
+      </a:fillRef>
+      <a:effectRef idx="0">
+        <a:scrgbClr r="0" g="0" b="0"/>
+      </a:effectRef>
+      <a:fontRef idx="minor">
+        <a:schemeClr val="lt1"/>
+      </a:fontRef>
+    </dgm:style>
+  </dgm:styleLbl>
+  <dgm:styleLbl name="parChTrans1D1">
+    <dgm:scene3d>
+      <a:camera prst="orthographicFront"/>
+      <a:lightRig rig="threePt" dir="t"/>
+    </dgm:scene3d>
+    <dgm:sp3d/>
+    <dgm:txPr/>
+    <dgm:style>
+      <a:lnRef idx="2">
+        <a:scrgbClr r="0" g="0" b="0"/>
+      </a:lnRef>
+      <a:fillRef idx="0">
+        <a:scrgbClr r="0" g="0" b="0"/>
+      </a:fillRef>
+      <a:effectRef idx="0">
+        <a:scrgbClr r="0" g="0" b="0"/>
+      </a:effectRef>
+      <a:fontRef idx="minor"/>
+    </dgm:style>
+  </dgm:styleLbl>
+  <dgm:styleLbl name="parChTrans1D2">
+    <dgm:scene3d>
+      <a:camera prst="orthographicFront"/>
+      <a:lightRig rig="threePt" dir="t"/>
+    </dgm:scene3d>
+    <dgm:sp3d/>
+    <dgm:txPr/>
+    <dgm:style>
+      <a:lnRef idx="2">
+        <a:scrgbClr r="0" g="0" b="0"/>
+      </a:lnRef>
+      <a:fillRef idx="0">
+        <a:scrgbClr r="0" g="0" b="0"/>
+      </a:fillRef>
+      <a:effectRef idx="0">
+        <a:scrgbClr r="0" g="0" b="0"/>
+      </a:effectRef>
+      <a:fontRef idx="minor"/>
+    </dgm:style>
+  </dgm:styleLbl>
+  <dgm:styleLbl name="parChTrans1D3">
+    <dgm:scene3d>
+      <a:camera prst="orthographicFront"/>
+      <a:lightRig rig="threePt" dir="t"/>
+    </dgm:scene3d>
+    <dgm:sp3d/>
+    <dgm:txPr/>
+    <dgm:style>
+      <a:lnRef idx="2">
+        <a:scrgbClr r="0" g="0" b="0"/>
+      </a:lnRef>
+      <a:fillRef idx="0">
+        <a:scrgbClr r="0" g="0" b="0"/>
+      </a:fillRef>
+      <a:effectRef idx="0">
+        <a:scrgbClr r="0" g="0" b="0"/>
+      </a:effectRef>
+      <a:fontRef idx="minor"/>
+    </dgm:style>
+  </dgm:styleLbl>
+  <dgm:styleLbl name="parChTrans1D4">
+    <dgm:scene3d>
+      <a:camera prst="orthographicFront"/>
+      <a:lightRig rig="threePt" dir="t"/>
+    </dgm:scene3d>
+    <dgm:sp3d/>
+    <dgm:txPr/>
+    <dgm:style>
+      <a:lnRef idx="2">
+        <a:scrgbClr r="0" g="0" b="0"/>
+      </a:lnRef>
+      <a:fillRef idx="0">
+        <a:scrgbClr r="0" g="0" b="0"/>
+      </a:fillRef>
+      <a:effectRef idx="0">
+        <a:scrgbClr r="0" g="0" b="0"/>
+      </a:effectRef>
+      <a:fontRef idx="minor"/>
+    </dgm:style>
+  </dgm:styleLbl>
+  <dgm:styleLbl name="fgAcc1">
+    <dgm:scene3d>
+      <a:camera prst="orthographicFront"/>
+      <a:lightRig rig="threePt" dir="t"/>
+    </dgm:scene3d>
+    <dgm:sp3d/>
+    <dgm:txPr/>
+    <dgm:style>
+      <a:lnRef idx="2">
+        <a:scrgbClr r="0" g="0" b="0"/>
+      </a:lnRef>
+      <a:fillRef idx="1">
+        <a:scrgbClr r="0" g="0" b="0"/>
+      </a:fillRef>
+      <a:effectRef idx="0">
+        <a:scrgbClr r="0" g="0" b="0"/>
+      </a:effectRef>
+      <a:fontRef idx="minor"/>
+    </dgm:style>
+  </dgm:styleLbl>
+  <dgm:styleLbl name="conFgAcc1">
+    <dgm:scene3d>
+      <a:camera prst="orthographicFront"/>
+      <a:lightRig rig="threePt" dir="t"/>
+    </dgm:scene3d>
+    <dgm:sp3d/>
+    <dgm:txPr/>
+    <dgm:style>
+      <a:lnRef idx="2">
+        <a:scrgbClr r="0" g="0" b="0"/>
+      </a:lnRef>
+      <a:fillRef idx="1">
+        <a:scrgbClr r="0" g="0" b="0"/>
+      </a:fillRef>
+      <a:effectRef idx="0">
+        <a:scrgbClr r="0" g="0" b="0"/>
+      </a:effectRef>
+      <a:fontRef idx="minor"/>
+    </dgm:style>
+  </dgm:styleLbl>
+  <dgm:styleLbl name="alignAcc1">
+    <dgm:scene3d>
+      <a:camera prst="orthographicFront"/>
+      <a:lightRig rig="threePt" dir="t"/>
+    </dgm:scene3d>
+    <dgm:sp3d/>
+    <dgm:txPr/>
+    <dgm:style>
+      <a:lnRef idx="2">
+        <a:scrgbClr r="0" g="0" b="0"/>
+      </a:lnRef>
+      <a:fillRef idx="1">
+        <a:scrgbClr r="0" g="0" b="0"/>
+      </a:fillRef>
+      <a:effectRef idx="0">
+        <a:scrgbClr r="0" g="0" b="0"/>
+      </a:effectRef>
+      <a:fontRef idx="minor"/>
+    </dgm:style>
+  </dgm:styleLbl>
+  <dgm:styleLbl name="trAlignAcc1">
+    <dgm:scene3d>
+      <a:camera prst="orthographicFront"/>
+      <a:lightRig rig="threePt" dir="t"/>
+    </dgm:scene3d>
+    <dgm:sp3d/>
+    <dgm:txPr/>
+    <dgm:style>
+      <a:lnRef idx="1">
+        <a:scrgbClr r="0" g="0" b="0"/>
+      </a:lnRef>
+      <a:fillRef idx="1">
+        <a:scrgbClr r="0" g="0" b="0"/>
+      </a:fillRef>
+      <a:effectRef idx="0">
+        <a:scrgbClr r="0" g="0" b="0"/>
+      </a:effectRef>
+      <a:fontRef idx="minor"/>
+    </dgm:style>
+  </dgm:styleLbl>
+  <dgm:styleLbl name="bgAcc1">
+    <dgm:scene3d>
+      <a:camera prst="orthographicFront"/>
+      <a:lightRig rig="threePt" dir="t"/>
+    </dgm:scene3d>
+    <dgm:sp3d/>
+    <dgm:txPr/>
+    <dgm:style>
+      <a:lnRef idx="2">
+        <a:scrgbClr r="0" g="0" b="0"/>
+      </a:lnRef>
+      <a:fillRef idx="1">
+        <a:scrgbClr r="0" g="0" b="0"/>
+      </a:fillRef>
+      <a:effectRef idx="0">
+        <a:scrgbClr r="0" g="0" b="0"/>
+      </a:effectRef>
+      <a:fontRef idx="minor"/>
+    </dgm:style>
+  </dgm:styleLbl>
+  <dgm:styleLbl name="solidFgAcc1">
+    <dgm:scene3d>
+      <a:camera prst="orthographicFront"/>
+      <a:lightRig rig="threePt" dir="t"/>
+    </dgm:scene3d>
+    <dgm:sp3d/>
+    <dgm:txPr/>
+    <dgm:style>
+      <a:lnRef idx="2">
+        <a:scrgbClr r="0" g="0" b="0"/>
+      </a:lnRef>
+      <a:fillRef idx="1">
+        <a:scrgbClr r="0" g="0" b="0"/>
+      </a:fillRef>
+      <a:effectRef idx="0">
+        <a:scrgbClr r="0" g="0" b="0"/>
+      </a:effectRef>
+      <a:fontRef idx="minor"/>
+    </dgm:style>
+  </dgm:styleLbl>
+  <dgm:styleLbl name="solidAlignAcc1">
+    <dgm:scene3d>
+      <a:camera prst="orthographicFront"/>
+      <a:lightRig rig="threePt" dir="t"/>
+    </dgm:scene3d>
+    <dgm:sp3d/>
+    <dgm:txPr/>
+    <dgm:style>
+      <a:lnRef idx="2">
+        <a:scrgbClr r="0" g="0" b="0"/>
+      </a:lnRef>
+      <a:fillRef idx="1">
+        <a:scrgbClr r="0" g="0" b="0"/>
+      </a:fillRef>
+      <a:effectRef idx="0">
+        <a:scrgbClr r="0" g="0" b="0"/>
+      </a:effectRef>
+      <a:fontRef idx="minor"/>
+    </dgm:style>
+  </dgm:styleLbl>
+  <dgm:styleLbl name="solidBgAcc1">
+    <dgm:scene3d>
+      <a:camera prst="orthographicFront"/>
+      <a:lightRig rig="threePt" dir="t"/>
+    </dgm:scene3d>
+    <dgm:sp3d/>
+    <dgm:txPr/>
+    <dgm:style>
+      <a:lnRef idx="2">
+        <a:scrgbClr r="0" g="0" b="0"/>
+      </a:lnRef>
+      <a:fillRef idx="1">
+        <a:scrgbClr r="0" g="0" b="0"/>
+      </a:fillRef>
+      <a:effectRef idx="0">
+        <a:scrgbClr r="0" g="0" b="0"/>
+      </a:effectRef>
+      <a:fontRef idx="minor"/>
+    </dgm:style>
+  </dgm:styleLbl>
+  <dgm:styleLbl name="fgAccFollowNode1">
+    <dgm:scene3d>
+      <a:camera prst="orthographicFront"/>
+      <a:lightRig rig="threePt" dir="t"/>
+    </dgm:scene3d>
+    <dgm:sp3d/>
+    <dgm:txPr/>
+    <dgm:style>
+      <a:lnRef idx="2">
+        <a:scrgbClr r="0" g="0" b="0"/>
+      </a:lnRef>
+      <a:fillRef idx="1">
+        <a:scrgbClr r="0" g="0" b="0"/>
+      </a:fillRef>
+      <a:effectRef idx="0">
+        <a:scrgbClr r="0" g="0" b="0"/>
+      </a:effectRef>
+      <a:fontRef idx="minor"/>
+    </dgm:style>
+  </dgm:styleLbl>
+  <dgm:styleLbl name="alignAccFollowNode1">
+    <dgm:scene3d>
+      <a:camera prst="orthographicFront"/>
+      <a:lightRig rig="threePt" dir="t"/>
+    </dgm:scene3d>
+    <dgm:sp3d/>
+    <dgm:txPr/>
+    <dgm:style>
+      <a:lnRef idx="2">
+        <a:scrgbClr r="0" g="0" b="0"/>
+      </a:lnRef>
+      <a:fillRef idx="1">
+        <a:scrgbClr r="0" g="0" b="0"/>
+      </a:fillRef>
+      <a:effectRef idx="0">
+        <a:scrgbClr r="0" g="0" b="0"/>
+      </a:effectRef>
+      <a:fontRef idx="minor"/>
+    </dgm:style>
+  </dgm:styleLbl>
+  <dgm:styleLbl name="bgAccFollowNode1">
+    <dgm:scene3d>
+      <a:camera prst="orthographicFront"/>
+      <a:lightRig rig="threePt" dir="t"/>
+    </dgm:scene3d>
+    <dgm:sp3d/>
+    <dgm:txPr/>
+    <dgm:style>
+      <a:lnRef idx="2">
+        <a:scrgbClr r="0" g="0" b="0"/>
+      </a:lnRef>
+      <a:fillRef idx="1">
+        <a:scrgbClr r="0" g="0" b="0"/>
+      </a:fillRef>
+      <a:effectRef idx="0">
+        <a:scrgbClr r="0" g="0" b="0"/>
+      </a:effectRef>
+      <a:fontRef idx="minor"/>
+    </dgm:style>
+  </dgm:styleLbl>
+  <dgm:styleLbl name="fgAcc0">
+    <dgm:scene3d>
+      <a:camera prst="orthographicFront"/>
+      <a:lightRig rig="threePt" dir="t"/>
+    </dgm:scene3d>
+    <dgm:sp3d/>
+    <dgm:txPr/>
+    <dgm:style>
+      <a:lnRef idx="2">
+        <a:scrgbClr r="0" g="0" b="0"/>
+      </a:lnRef>
+      <a:fillRef idx="1">
+        <a:scrgbClr r="0" g="0" b="0"/>
+      </a:fillRef>
+      <a:effectRef idx="0">
+        <a:scrgbClr r="0" g="0" b="0"/>
+      </a:effectRef>
+      <a:fontRef idx="minor"/>
+    </dgm:style>
+  </dgm:styleLbl>
+  <dgm:styleLbl name="fgAcc2">
+    <dgm:scene3d>
+      <a:camera prst="orthographicFront"/>
+      <a:lightRig rig="threePt" dir="t"/>
+    </dgm:scene3d>
+    <dgm:sp3d/>
+    <dgm:txPr/>
+    <dgm:style>
+      <a:lnRef idx="2">
+        <a:scrgbClr r="0" g="0" b="0"/>
+      </a:lnRef>
+      <a:fillRef idx="1">
+        <a:scrgbClr r="0" g="0" b="0"/>
+      </a:fillRef>
+      <a:effectRef idx="0">
+        <a:scrgbClr r="0" g="0" b="0"/>
+      </a:effectRef>
+      <a:fontRef idx="minor"/>
+    </dgm:style>
+  </dgm:styleLbl>
+  <dgm:styleLbl name="fgAcc3">
+    <dgm:scene3d>
+      <a:camera prst="orthographicFront"/>
+      <a:lightRig rig="threePt" dir="t"/>
+    </dgm:scene3d>
+    <dgm:sp3d/>
+    <dgm:txPr/>
+    <dgm:style>
+      <a:lnRef idx="2">
+        <a:scrgbClr r="0" g="0" b="0"/>
+      </a:lnRef>
+      <a:fillRef idx="1">
+        <a:scrgbClr r="0" g="0" b="0"/>
+      </a:fillRef>
+      <a:effectRef idx="0">
+        <a:scrgbClr r="0" g="0" b="0"/>
+      </a:effectRef>
+      <a:fontRef idx="minor"/>
+    </dgm:style>
+  </dgm:styleLbl>
+  <dgm:styleLbl name="fgAcc4">
+    <dgm:scene3d>
+      <a:camera prst="orthographicFront"/>
+      <a:lightRig rig="threePt" dir="t"/>
+    </dgm:scene3d>
+    <dgm:sp3d/>
+    <dgm:txPr/>
+    <dgm:style>
+      <a:lnRef idx="2">
+        <a:scrgbClr r="0" g="0" b="0"/>
+      </a:lnRef>
+      <a:fillRef idx="1">
+        <a:scrgbClr r="0" g="0" b="0"/>
+      </a:fillRef>
+      <a:effectRef idx="0">
+        <a:scrgbClr r="0" g="0" b="0"/>
+      </a:effectRef>
+      <a:fontRef idx="minor"/>
+    </dgm:style>
+  </dgm:styleLbl>
+  <dgm:styleLbl name="bgShp">
+    <dgm:scene3d>
+      <a:camera prst="orthographicFront"/>
+      <a:lightRig rig="threePt" dir="t"/>
+    </dgm:scene3d>
+    <dgm:sp3d/>
+    <dgm:txPr/>
+    <dgm:style>
+      <a:lnRef idx="0">
+        <a:scrgbClr r="0" g="0" b="0"/>
+      </a:lnRef>
+      <a:fillRef idx="1">
+        <a:scrgbClr r="0" g="0" b="0"/>
+      </a:fillRef>
+      <a:effectRef idx="0">
+        <a:scrgbClr r="0" g="0" b="0"/>
+      </a:effectRef>
+      <a:fontRef idx="minor"/>
+    </dgm:style>
+  </dgm:styleLbl>
+  <dgm:styleLbl name="dkBgShp">
+    <dgm:scene3d>
+      <a:camera prst="orthographicFront"/>
+      <a:lightRig rig="threePt" dir="t"/>
+    </dgm:scene3d>
+    <dgm:sp3d/>
+    <dgm:txPr/>
+    <dgm:style>
+      <a:lnRef idx="0">
+        <a:scrgbClr r="0" g="0" b="0"/>
+      </a:lnRef>
+      <a:fillRef idx="1">
+        <a:scrgbClr r="0" g="0" b="0"/>
+      </a:fillRef>
+      <a:effectRef idx="0">
+        <a:scrgbClr r="0" g="0" b="0"/>
+      </a:effectRef>
+      <a:fontRef idx="minor"/>
+    </dgm:style>
+  </dgm:styleLbl>
+  <dgm:styleLbl name="trBgShp">
+    <dgm:scene3d>
+      <a:camera prst="orthographicFront"/>
+      <a:lightRig rig="threePt" dir="t"/>
+    </dgm:scene3d>
+    <dgm:sp3d/>
+    <dgm:txPr/>
+    <dgm:style>
+      <a:lnRef idx="0">
+        <a:scrgbClr r="0" g="0" b="0"/>
+      </a:lnRef>
+      <a:fillRef idx="1">
+        <a:scrgbClr r="0" g="0" b="0"/>
+      </a:fillRef>
+      <a:effectRef idx="0">
+        <a:scrgbClr r="0" g="0" b="0"/>
+      </a:effectRef>
+      <a:fontRef idx="minor"/>
+    </dgm:style>
+  </dgm:styleLbl>
+  <dgm:styleLbl name="fgShp">
+    <dgm:scene3d>
+      <a:camera prst="orthographicFront"/>
+      <a:lightRig rig="threePt" dir="t"/>
+    </dgm:scene3d>
+    <dgm:sp3d/>
+    <dgm:txPr/>
+    <dgm:style>
+      <a:lnRef idx="2">
+        <a:scrgbClr r="0" g="0" b="0"/>
+      </a:lnRef>
+      <a:fillRef idx="1">
+        <a:scrgbClr r="0" g="0" b="0"/>
+      </a:fillRef>
+      <a:effectRef idx="0">
+        <a:scrgbClr r="0" g="0" b="0"/>
+      </a:effectRef>
+      <a:fontRef idx="minor"/>
+    </dgm:style>
+  </dgm:styleLbl>
+  <dgm:styleLbl name="revTx">
+    <dgm:scene3d>
+      <a:camera prst="orthographicFront"/>
+      <a:lightRig rig="threePt" dir="t"/>
+    </dgm:scene3d>
+    <dgm:sp3d/>
+    <dgm:txPr/>
+    <dgm:style>
+      <a:lnRef idx="0">
+        <a:scrgbClr r="0" g="0" b="0"/>
+      </a:lnRef>
+      <a:fillRef idx="0">
+        <a:scrgbClr r="0" g="0" b="0"/>
+      </a:fillRef>
+      <a:effectRef idx="0">
+        <a:scrgbClr r="0" g="0" b="0"/>
+      </a:effectRef>
+      <a:fontRef idx="minor"/>
+    </dgm:style>
+  </dgm:styleLbl>
+</dgm:styleDef>
+</file>
+
 <file path=ppt/notesMasters/notesMaster1.xml><?xml version="1.0" encoding="utf-8"?>
 <p:notesMaster xmlns:a="http://schemas.openxmlformats.org/drawingml/2006/main" xmlns:r="http://schemas.openxmlformats.org/officeDocument/2006/relationships" xmlns:p="http://schemas.openxmlformats.org/presentationml/2006/main">
   <p:cSld>
@@ -883,7 +5044,7 @@
           <a:p>
             <a:fld id="{8659DF86-DFAD-4383-AD85-E587D6DB3346}" type="datetimeFigureOut">
               <a:rPr lang="en-GB" smtClean="0"/>
-              <a:t>16/10/2024</a:t>
+              <a:t>23/10/2024</a:t>
             </a:fld>
             <a:endParaRPr lang="en-GB"/>
           </a:p>
@@ -1366,7 +5527,7 @@
           <a:p>
             <a:fld id="{C9A16802-6AA0-4807-9B7D-A2104C683F8A}" type="datetimeFigureOut">
               <a:rPr lang="en-GB" smtClean="0"/>
-              <a:t>16/10/2024</a:t>
+              <a:t>23/10/2024</a:t>
             </a:fld>
             <a:endParaRPr lang="en-GB"/>
           </a:p>
@@ -1536,7 +5697,7 @@
           <a:p>
             <a:fld id="{C9A16802-6AA0-4807-9B7D-A2104C683F8A}" type="datetimeFigureOut">
               <a:rPr lang="en-GB" smtClean="0"/>
-              <a:t>16/10/2024</a:t>
+              <a:t>23/10/2024</a:t>
             </a:fld>
             <a:endParaRPr lang="en-GB"/>
           </a:p>
@@ -1716,7 +5877,7 @@
           <a:p>
             <a:fld id="{C9A16802-6AA0-4807-9B7D-A2104C683F8A}" type="datetimeFigureOut">
               <a:rPr lang="en-GB" smtClean="0"/>
-              <a:t>16/10/2024</a:t>
+              <a:t>23/10/2024</a:t>
             </a:fld>
             <a:endParaRPr lang="en-GB"/>
           </a:p>
@@ -1886,7 +6047,7 @@
           <a:p>
             <a:fld id="{C9A16802-6AA0-4807-9B7D-A2104C683F8A}" type="datetimeFigureOut">
               <a:rPr lang="en-GB" smtClean="0"/>
-              <a:t>16/10/2024</a:t>
+              <a:t>23/10/2024</a:t>
             </a:fld>
             <a:endParaRPr lang="en-GB"/>
           </a:p>
@@ -2132,7 +6293,7 @@
           <a:p>
             <a:fld id="{C9A16802-6AA0-4807-9B7D-A2104C683F8A}" type="datetimeFigureOut">
               <a:rPr lang="en-GB" smtClean="0"/>
-              <a:t>16/10/2024</a:t>
+              <a:t>23/10/2024</a:t>
             </a:fld>
             <a:endParaRPr lang="en-GB"/>
           </a:p>
@@ -2364,7 +6525,7 @@
           <a:p>
             <a:fld id="{C9A16802-6AA0-4807-9B7D-A2104C683F8A}" type="datetimeFigureOut">
               <a:rPr lang="en-GB" smtClean="0"/>
-              <a:t>16/10/2024</a:t>
+              <a:t>23/10/2024</a:t>
             </a:fld>
             <a:endParaRPr lang="en-GB"/>
           </a:p>
@@ -2731,7 +6892,7 @@
           <a:p>
             <a:fld id="{C9A16802-6AA0-4807-9B7D-A2104C683F8A}" type="datetimeFigureOut">
               <a:rPr lang="en-GB" smtClean="0"/>
-              <a:t>16/10/2024</a:t>
+              <a:t>23/10/2024</a:t>
             </a:fld>
             <a:endParaRPr lang="en-GB"/>
           </a:p>
@@ -2849,7 +7010,7 @@
           <a:p>
             <a:fld id="{C9A16802-6AA0-4807-9B7D-A2104C683F8A}" type="datetimeFigureOut">
               <a:rPr lang="en-GB" smtClean="0"/>
-              <a:t>16/10/2024</a:t>
+              <a:t>23/10/2024</a:t>
             </a:fld>
             <a:endParaRPr lang="en-GB"/>
           </a:p>
@@ -2944,7 +7105,7 @@
           <a:p>
             <a:fld id="{C9A16802-6AA0-4807-9B7D-A2104C683F8A}" type="datetimeFigureOut">
               <a:rPr lang="en-GB" smtClean="0"/>
-              <a:t>16/10/2024</a:t>
+              <a:t>23/10/2024</a:t>
             </a:fld>
             <a:endParaRPr lang="en-GB"/>
           </a:p>
@@ -3221,7 +7382,7 @@
           <a:p>
             <a:fld id="{C9A16802-6AA0-4807-9B7D-A2104C683F8A}" type="datetimeFigureOut">
               <a:rPr lang="en-GB" smtClean="0"/>
-              <a:t>16/10/2024</a:t>
+              <a:t>23/10/2024</a:t>
             </a:fld>
             <a:endParaRPr lang="en-GB"/>
           </a:p>
@@ -3478,7 +7639,7 @@
           <a:p>
             <a:fld id="{C9A16802-6AA0-4807-9B7D-A2104C683F8A}" type="datetimeFigureOut">
               <a:rPr lang="en-GB" smtClean="0"/>
-              <a:t>16/10/2024</a:t>
+              <a:t>23/10/2024</a:t>
             </a:fld>
             <a:endParaRPr lang="en-GB"/>
           </a:p>
@@ -3691,7 +7852,7 @@
           <a:p>
             <a:fld id="{C9A16802-6AA0-4807-9B7D-A2104C683F8A}" type="datetimeFigureOut">
               <a:rPr lang="en-GB" smtClean="0"/>
-              <a:t>16/10/2024</a:t>
+              <a:t>23/10/2024</a:t>
             </a:fld>
             <a:endParaRPr lang="en-GB"/>
           </a:p>
@@ -4336,7 +8497,7 @@
           <a:p>
             <a:pPr algn="l"/>
             <a:r>
-              <a:rPr lang="en-GB" sz="6300" dirty="0">
+              <a:rPr lang="en-GB" sz="5400" dirty="0">
                 <a:solidFill>
                   <a:schemeClr val="accent1">
                     <a:lumMod val="75000"/>
@@ -4344,7 +8505,7 @@
                 </a:solidFill>
                 <a:latin typeface="Bell MT" panose="02020503060305020303" pitchFamily="18" charset="0"/>
               </a:rPr>
-              <a:t>Email: C00276177@SETU.ie</a:t>
+              <a:t>By: Tomas Smitas	Email: C00276177@SETU.ie</a:t>
             </a:r>
           </a:p>
         </p:txBody>
@@ -4594,129 +8755,6 @@
           </a:p>
           <a:p>
             <a:pPr algn="l"/>
-            <a:r>
-              <a:rPr lang="en-GB" sz="3200" b="1" dirty="0">
-                <a:solidFill>
-                  <a:schemeClr val="accent1">
-                    <a:lumMod val="50000"/>
-                  </a:schemeClr>
-                </a:solidFill>
-                <a:latin typeface="Bell MT" panose="02020503060305020303" pitchFamily="18" charset="0"/>
-              </a:rPr>
-              <a:t>Python - Main Programming Language</a:t>
-            </a:r>
-          </a:p>
-          <a:p>
-            <a:pPr algn="l"/>
-            <a:r>
-              <a:rPr lang="en-GB" sz="3200" b="1" dirty="0">
-                <a:solidFill>
-                  <a:schemeClr val="accent1">
-                    <a:lumMod val="50000"/>
-                  </a:schemeClr>
-                </a:solidFill>
-                <a:latin typeface="Bell MT" panose="02020503060305020303" pitchFamily="18" charset="0"/>
-              </a:rPr>
-              <a:t>YOLO - Object Detection</a:t>
-            </a:r>
-          </a:p>
-          <a:p>
-            <a:pPr algn="l"/>
-            <a:r>
-              <a:rPr lang="en-GB" sz="3200" b="1" dirty="0" err="1">
-                <a:solidFill>
-                  <a:schemeClr val="accent1">
-                    <a:lumMod val="50000"/>
-                  </a:schemeClr>
-                </a:solidFill>
-                <a:latin typeface="Bell MT" panose="02020503060305020303" pitchFamily="18" charset="0"/>
-              </a:rPr>
-              <a:t>Ultralytics</a:t>
-            </a:r>
-            <a:r>
-              <a:rPr lang="en-GB" sz="3200" b="1" dirty="0">
-                <a:solidFill>
-                  <a:schemeClr val="accent1">
-                    <a:lumMod val="50000"/>
-                  </a:schemeClr>
-                </a:solidFill>
-                <a:latin typeface="Bell MT" panose="02020503060305020303" pitchFamily="18" charset="0"/>
-              </a:rPr>
-              <a:t> - Framework</a:t>
-            </a:r>
-          </a:p>
-          <a:p>
-            <a:pPr algn="l"/>
-            <a:r>
-              <a:rPr lang="en-GB" sz="3200" b="1" dirty="0">
-                <a:solidFill>
-                  <a:schemeClr val="accent1">
-                    <a:lumMod val="50000"/>
-                  </a:schemeClr>
-                </a:solidFill>
-                <a:latin typeface="Bell MT" panose="02020503060305020303" pitchFamily="18" charset="0"/>
-              </a:rPr>
-              <a:t>OpenCV – Computer Vision Library</a:t>
-            </a:r>
-          </a:p>
-          <a:p>
-            <a:pPr algn="l"/>
-            <a:r>
-              <a:rPr lang="en-GB" sz="3200" b="1" dirty="0">
-                <a:solidFill>
-                  <a:schemeClr val="accent1">
-                    <a:lumMod val="50000"/>
-                  </a:schemeClr>
-                </a:solidFill>
-                <a:latin typeface="Bell MT" panose="02020503060305020303" pitchFamily="18" charset="0"/>
-              </a:rPr>
-              <a:t>Flask – Web Framework</a:t>
-            </a:r>
-          </a:p>
-          <a:p>
-            <a:pPr algn="l"/>
-            <a:r>
-              <a:rPr lang="en-GB" sz="3200" b="1" dirty="0">
-                <a:solidFill>
-                  <a:schemeClr val="accent1">
-                    <a:lumMod val="50000"/>
-                  </a:schemeClr>
-                </a:solidFill>
-                <a:latin typeface="Bell MT" panose="02020503060305020303" pitchFamily="18" charset="0"/>
-              </a:rPr>
-              <a:t>React – Front End</a:t>
-            </a:r>
-          </a:p>
-          <a:p>
-            <a:pPr algn="l"/>
-            <a:r>
-              <a:rPr lang="en-GB" sz="3200" b="1" dirty="0">
-                <a:solidFill>
-                  <a:schemeClr val="accent1">
-                    <a:lumMod val="50000"/>
-                  </a:schemeClr>
-                </a:solidFill>
-                <a:latin typeface="Bell MT" panose="02020503060305020303" pitchFamily="18" charset="0"/>
-              </a:rPr>
-              <a:t>SMTP – Email Service</a:t>
-            </a:r>
-          </a:p>
-          <a:p>
-            <a:pPr algn="l"/>
-            <a:r>
-              <a:rPr lang="en-GB" sz="3200" b="1" dirty="0">
-                <a:solidFill>
-                  <a:schemeClr val="accent1">
-                    <a:lumMod val="50000"/>
-                  </a:schemeClr>
-                </a:solidFill>
-                <a:latin typeface="Bell MT" panose="02020503060305020303" pitchFamily="18" charset="0"/>
-              </a:rPr>
-              <a:t>MySQL - Database</a:t>
-            </a:r>
-          </a:p>
-          <a:p>
-            <a:pPr algn="l"/>
             <a:endParaRPr lang="en-GB" sz="3600" b="1" dirty="0">
               <a:solidFill>
                 <a:schemeClr val="accent1">
@@ -4753,7 +8791,7 @@
         </p:spPr>
         <p:txBody>
           <a:bodyPr vert="horz" lIns="91440" tIns="45720" rIns="91440" bIns="45720" rtlCol="0">
-            <a:normAutofit fontScale="92500" lnSpcReduction="10000"/>
+            <a:normAutofit fontScale="92500"/>
           </a:bodyPr>
           <a:lstStyle>
             <a:lvl1pPr marL="0" indent="0" algn="ctr" defTabSz="2851191" rtl="0" eaLnBrk="1" latinLnBrk="0" hangingPunct="1">
@@ -4933,28 +8971,26 @@
             </a:r>
           </a:p>
           <a:p>
-            <a:pPr algn="l"/>
             <a:r>
-              <a:rPr lang="en-GB" sz="3500" dirty="0">
+              <a:rPr lang="en-GB" sz="3200" dirty="0">
                 <a:latin typeface="Bell MT" panose="02020503060305020303" pitchFamily="18" charset="0"/>
               </a:rPr>
               <a:t>Currently, there is no solution like this in Ireland. However, globally, a company called </a:t>
             </a:r>
             <a:r>
-              <a:rPr lang="en-GB" sz="3500" dirty="0" err="1">
+              <a:rPr lang="en-GB" sz="3200" dirty="0" err="1">
                 <a:latin typeface="Bell MT" panose="02020503060305020303" pitchFamily="18" charset="0"/>
               </a:rPr>
               <a:t>Synaedge</a:t>
             </a:r>
             <a:r>
-              <a:rPr lang="en-GB" sz="3500" dirty="0">
+              <a:rPr lang="en-GB" sz="3200" dirty="0">
                 <a:latin typeface="Bell MT" panose="02020503060305020303" pitchFamily="18" charset="0"/>
               </a:rPr>
               <a:t>, based in Switzerland, offers AI-based video surveillance that includes PPE detection. While they provide this service through their AI-powered analytics, the exact workings of their PPE detection system remain unclear.</a:t>
             </a:r>
           </a:p>
           <a:p>
-            <a:pPr algn="l"/>
             <a:r>
               <a:rPr lang="en-GB" sz="3500" dirty="0">
                 <a:latin typeface="Bell MT" panose="02020503060305020303" pitchFamily="18" charset="0"/>
@@ -5190,7 +9226,6 @@
             </a:r>
           </a:p>
           <a:p>
-            <a:pPr algn="l"/>
             <a:r>
               <a:rPr lang="en-GB" sz="3200" dirty="0">
                 <a:latin typeface="Bell MT" panose="02020503060305020303" pitchFamily="18" charset="0"/>
@@ -5645,8 +9680,8 @@
         </p:nvSpPr>
         <p:spPr>
           <a:xfrm>
-            <a:off x="20359470" y="11276986"/>
-            <a:ext cx="8892000" cy="5335597"/>
+            <a:off x="20359470" y="10983185"/>
+            <a:ext cx="8892000" cy="5923198"/>
           </a:xfrm>
           <a:prstGeom prst="rect">
             <a:avLst/>
@@ -5654,7 +9689,7 @@
         </p:spPr>
         <p:txBody>
           <a:bodyPr vert="horz" lIns="91440" tIns="45720" rIns="91440" bIns="45720" rtlCol="0">
-            <a:normAutofit/>
+            <a:normAutofit fontScale="92500"/>
           </a:bodyPr>
           <a:lstStyle>
             <a:lvl1pPr marL="0" indent="0" algn="ctr" defTabSz="2851191" rtl="0" eaLnBrk="1" latinLnBrk="0" hangingPunct="1">
@@ -5834,7 +9869,6 @@
             </a:r>
           </a:p>
           <a:p>
-            <a:pPr algn="l"/>
             <a:r>
               <a:rPr lang="en-GB" sz="3600" b="1" dirty="0">
                 <a:solidFill>
@@ -5848,20 +9882,24 @@
             </a:r>
           </a:p>
           <a:p>
-            <a:pPr algn="l"/>
+            <a:pPr marL="0" indent="0">
+              <a:buNone/>
+            </a:pPr>
             <a:r>
               <a:rPr lang="en-GB" sz="3200" b="0" i="0" dirty="0">
-                <a:solidFill>
-                  <a:srgbClr val="3F4043"/>
-                </a:solidFill>
                 <a:effectLst/>
                 <a:latin typeface="Bell MT" panose="02020503060305020303" pitchFamily="18" charset="0"/>
               </a:rPr>
-              <a:t>Quote from this individual on the idea</a:t>
+              <a:t>“</a:t>
             </a:r>
-          </a:p>
-          <a:p>
-            <a:pPr algn="l"/>
+            <a:r>
+              <a:rPr lang="en-GB" sz="3200" dirty="0">
+                <a:latin typeface="Bell MT" panose="02020503060305020303" pitchFamily="18" charset="0"/>
+              </a:rPr>
+              <a:t>This project has real potential to make a difference in construction safety. By detecting safety issues in real-time, it could actively support compliance and help prevent accidents before they happen.”</a:t>
+            </a:r>
+          </a:p>
+          <a:p>
             <a:r>
               <a:rPr lang="en-GB" sz="3600" b="1" dirty="0">
                 <a:solidFill>
@@ -5875,9 +9913,8 @@
             </a:r>
           </a:p>
           <a:p>
-            <a:pPr algn="l"/>
             <a:r>
-              <a:rPr lang="en-GB" sz="3200" b="0" i="0" dirty="0">
+              <a:rPr lang="en-GB" sz="3100" b="0" i="0" dirty="0">
                 <a:solidFill>
                   <a:srgbClr val="3F4043"/>
                 </a:solidFill>
@@ -5887,7 +9924,7 @@
               <a:t>“Excellent idea. </a:t>
             </a:r>
             <a:r>
-              <a:rPr lang="en-GB" sz="3200" dirty="0">
+              <a:rPr lang="en-GB" sz="3100" dirty="0">
                 <a:solidFill>
                   <a:srgbClr val="3F4043"/>
                 </a:solidFill>
@@ -5895,7 +9932,7 @@
               </a:rPr>
               <a:t>It would be helpful in identifying helmets and high visibility jackets on construction sites.”</a:t>
             </a:r>
-            <a:endParaRPr lang="en-GB" sz="3200" dirty="0">
+            <a:endParaRPr lang="en-GB" sz="3100" dirty="0">
               <a:solidFill>
                 <a:schemeClr val="accent1">
                   <a:lumMod val="50000"/>
@@ -6005,7 +10042,7 @@
         </p:blipFill>
         <p:spPr>
           <a:xfrm>
-            <a:off x="15357232" y="9508670"/>
+            <a:off x="11514043" y="9861432"/>
             <a:ext cx="1151263" cy="915852"/>
           </a:xfrm>
           <a:prstGeom prst="rect">
@@ -6041,8 +10078,8 @@
         </p:blipFill>
         <p:spPr>
           <a:xfrm>
-            <a:off x="17514527" y="8442849"/>
-            <a:ext cx="1085350" cy="1337881"/>
+            <a:off x="17672679" y="8012530"/>
+            <a:ext cx="919337" cy="1133241"/>
           </a:xfrm>
           <a:prstGeom prst="rect">
             <a:avLst/>
@@ -6077,8 +10114,8 @@
         </p:blipFill>
         <p:spPr>
           <a:xfrm>
-            <a:off x="17896038" y="6123809"/>
-            <a:ext cx="1407679" cy="1546810"/>
+            <a:off x="11321049" y="6354060"/>
+            <a:ext cx="1138693" cy="1251238"/>
           </a:xfrm>
           <a:prstGeom prst="rect">
             <a:avLst/>
@@ -6113,7 +10150,7 @@
         </p:blipFill>
         <p:spPr>
           <a:xfrm>
-            <a:off x="14204564" y="10337434"/>
+            <a:off x="17605215" y="9777658"/>
             <a:ext cx="1152668" cy="1049663"/>
           </a:xfrm>
           <a:prstGeom prst="rect">
@@ -6149,7 +10186,7 @@
         </p:blipFill>
         <p:spPr>
           <a:xfrm>
-            <a:off x="15600904" y="11124586"/>
+            <a:off x="11443254" y="11545686"/>
             <a:ext cx="946151" cy="946151"/>
           </a:xfrm>
           <a:prstGeom prst="rect">
@@ -6203,8 +10240,8 @@
         </p:blipFill>
         <p:spPr>
           <a:xfrm>
-            <a:off x="14348719" y="12027310"/>
-            <a:ext cx="1151262" cy="721627"/>
+            <a:off x="17447541" y="11560739"/>
+            <a:ext cx="1216383" cy="762446"/>
           </a:xfrm>
           <a:prstGeom prst="rect">
             <a:avLst/>
@@ -6272,7 +10309,7 @@
         </p:blipFill>
         <p:spPr>
           <a:xfrm>
-            <a:off x="15229574" y="7835241"/>
+            <a:off x="11354146" y="8322086"/>
             <a:ext cx="927524" cy="927524"/>
           </a:xfrm>
           <a:prstGeom prst="rect">
@@ -6336,7 +10373,7 @@
         </p:blipFill>
         <p:spPr>
           <a:xfrm>
-            <a:off x="15600904" y="6936348"/>
+            <a:off x="17402663" y="6477576"/>
             <a:ext cx="1547875" cy="822094"/>
           </a:xfrm>
           <a:prstGeom prst="rect">
@@ -6405,7 +10442,7 @@
         </p:spPr>
         <p:txBody>
           <a:bodyPr vert="horz" lIns="91440" tIns="45720" rIns="91440" bIns="45720" rtlCol="0">
-            <a:normAutofit fontScale="92500" lnSpcReduction="20000"/>
+            <a:normAutofit fontScale="85000" lnSpcReduction="10000"/>
           </a:bodyPr>
           <a:lstStyle>
             <a:lvl1pPr marL="0" indent="0" algn="ctr" defTabSz="2851191" rtl="0" eaLnBrk="1" latinLnBrk="0" hangingPunct="1">
@@ -6572,12 +10609,12 @@
             </a:lvl9pPr>
           </a:lstStyle>
           <a:p>
-            <a:pPr marL="457200" indent="-457200" algn="l">
+            <a:pPr marL="457200" indent="-457200">
               <a:buFont typeface="Arial" panose="020B0604020202020204" pitchFamily="34" charset="0"/>
               <a:buChar char="•"/>
             </a:pPr>
             <a:r>
-              <a:rPr lang="en-GB" sz="2800" dirty="0">
+              <a:rPr lang="en-GB" sz="3000" dirty="0">
                 <a:solidFill>
                   <a:schemeClr val="accent1">
                     <a:lumMod val="50000"/>
@@ -6585,16 +10622,16 @@
                 </a:solidFill>
                 <a:latin typeface="Bell MT" panose="02020503060305020303" pitchFamily="18" charset="0"/>
               </a:rPr>
-              <a:t>Poster Design NYU</a:t>
+              <a:t>Supervisor Dr Oisin Cawley</a:t>
             </a:r>
           </a:p>
           <a:p>
-            <a:pPr marL="457200" indent="-457200" algn="l">
+            <a:pPr marL="457200" indent="-457200">
               <a:buFont typeface="Arial" panose="020B0604020202020204" pitchFamily="34" charset="0"/>
               <a:buChar char="•"/>
             </a:pPr>
             <a:r>
-              <a:rPr lang="en-GB" sz="2800" dirty="0">
+              <a:rPr lang="en-GB" sz="3000" dirty="0">
                 <a:solidFill>
                   <a:schemeClr val="accent1">
                     <a:lumMod val="50000"/>
@@ -6605,7 +10642,7 @@
               <a:t>Poster Design </a:t>
             </a:r>
             <a:r>
-              <a:rPr lang="en-GB" sz="2800" dirty="0" err="1">
+              <a:rPr lang="en-GB" sz="3000" dirty="0" err="1">
                 <a:solidFill>
                   <a:schemeClr val="accent1">
                     <a:lumMod val="50000"/>
@@ -6616,7 +10653,7 @@
               <a:t>DesignLabs</a:t>
             </a:r>
             <a:r>
-              <a:rPr lang="en-GB" sz="2800" dirty="0">
+              <a:rPr lang="en-GB" sz="3000" dirty="0">
                 <a:solidFill>
                   <a:schemeClr val="accent1">
                     <a:lumMod val="50000"/>
@@ -6628,7 +10665,7 @@
             </a:r>
           </a:p>
           <a:p>
-            <a:pPr marL="457200" indent="-457200" algn="l">
+            <a:pPr marL="457200" indent="-457200">
               <a:buFont typeface="Arial" panose="020B0604020202020204" pitchFamily="34" charset="0"/>
               <a:buChar char="•"/>
             </a:pPr>
@@ -6844,7 +10881,7 @@
             </a:lvl9pPr>
           </a:lstStyle>
           <a:p>
-            <a:pPr marL="457200" indent="-457200" algn="l">
+            <a:pPr marL="457200" indent="-457200">
               <a:lnSpc>
                 <a:spcPct val="70000"/>
               </a:lnSpc>
@@ -6864,7 +10901,7 @@
             </a:r>
           </a:p>
           <a:p>
-            <a:pPr marL="457200" indent="-457200" algn="l">
+            <a:pPr marL="457200" indent="-457200">
               <a:lnSpc>
                 <a:spcPct val="70000"/>
               </a:lnSpc>
@@ -6884,7 +10921,7 @@
             </a:r>
           </a:p>
           <a:p>
-            <a:pPr marL="457200" indent="-457200" algn="l">
+            <a:pPr marL="457200" indent="-457200">
               <a:lnSpc>
                 <a:spcPct val="70000"/>
               </a:lnSpc>
@@ -6911,6 +10948,36 @@
           </a:p>
         </p:txBody>
       </p:sp>
+      <p:graphicFrame>
+        <p:nvGraphicFramePr>
+          <p:cNvPr id="12" name="Content Placeholder 32">
+            <a:extLst>
+              <a:ext uri="{FF2B5EF4-FFF2-40B4-BE49-F238E27FC236}">
+                <a16:creationId xmlns:a16="http://schemas.microsoft.com/office/drawing/2014/main" id="{3FE1D667-E932-4A74-71F5-62D266F68A5E}"/>
+              </a:ext>
+            </a:extLst>
+          </p:cNvPr>
+          <p:cNvGraphicFramePr>
+            <a:graphicFrameLocks/>
+          </p:cNvGraphicFramePr>
+          <p:nvPr>
+            <p:extLst>
+              <p:ext uri="{D42A27DB-BD31-4B8C-83A1-F6EECF244321}">
+                <p14:modId xmlns:p14="http://schemas.microsoft.com/office/powerpoint/2010/main" val="77847241"/>
+              </p:ext>
+            </p:extLst>
+          </p:nvPr>
+        </p:nvGraphicFramePr>
+        <p:xfrm>
+          <a:off x="12543376" y="6480026"/>
+          <a:ext cx="5052688" cy="5967452"/>
+        </p:xfrm>
+        <a:graphic>
+          <a:graphicData uri="http://schemas.openxmlformats.org/drawingml/2006/diagram">
+            <dgm:relIds xmlns:dgm="http://schemas.openxmlformats.org/drawingml/2006/diagram" xmlns:r="http://schemas.openxmlformats.org/officeDocument/2006/relationships" r:dm="rId18" r:lo="rId19" r:qs="rId20" r:cs="rId21"/>
+          </a:graphicData>
+        </a:graphic>
+      </p:graphicFrame>
     </p:spTree>
     <p:extLst>
       <p:ext uri="{BB962C8B-B14F-4D97-AF65-F5344CB8AC3E}">

</xml_diff>

<commit_message>
Poster design update iteration 1
</commit_message>
<xml_diff>
--- a/Poster/SiteSafeAiPoster.pptx
+++ b/Poster/SiteSafeAiPoster.pptx
@@ -5044,7 +5044,7 @@
           <a:p>
             <a:fld id="{8659DF86-DFAD-4383-AD85-E587D6DB3346}" type="datetimeFigureOut">
               <a:rPr lang="en-GB" smtClean="0"/>
-              <a:t>23/10/2024</a:t>
+              <a:t>04/12/2024</a:t>
             </a:fld>
             <a:endParaRPr lang="en-GB"/>
           </a:p>
@@ -5527,7 +5527,7 @@
           <a:p>
             <a:fld id="{C9A16802-6AA0-4807-9B7D-A2104C683F8A}" type="datetimeFigureOut">
               <a:rPr lang="en-GB" smtClean="0"/>
-              <a:t>23/10/2024</a:t>
+              <a:t>04/12/2024</a:t>
             </a:fld>
             <a:endParaRPr lang="en-GB"/>
           </a:p>
@@ -5697,7 +5697,7 @@
           <a:p>
             <a:fld id="{C9A16802-6AA0-4807-9B7D-A2104C683F8A}" type="datetimeFigureOut">
               <a:rPr lang="en-GB" smtClean="0"/>
-              <a:t>23/10/2024</a:t>
+              <a:t>04/12/2024</a:t>
             </a:fld>
             <a:endParaRPr lang="en-GB"/>
           </a:p>
@@ -5877,7 +5877,7 @@
           <a:p>
             <a:fld id="{C9A16802-6AA0-4807-9B7D-A2104C683F8A}" type="datetimeFigureOut">
               <a:rPr lang="en-GB" smtClean="0"/>
-              <a:t>23/10/2024</a:t>
+              <a:t>04/12/2024</a:t>
             </a:fld>
             <a:endParaRPr lang="en-GB"/>
           </a:p>
@@ -6047,7 +6047,7 @@
           <a:p>
             <a:fld id="{C9A16802-6AA0-4807-9B7D-A2104C683F8A}" type="datetimeFigureOut">
               <a:rPr lang="en-GB" smtClean="0"/>
-              <a:t>23/10/2024</a:t>
+              <a:t>04/12/2024</a:t>
             </a:fld>
             <a:endParaRPr lang="en-GB"/>
           </a:p>
@@ -6293,7 +6293,7 @@
           <a:p>
             <a:fld id="{C9A16802-6AA0-4807-9B7D-A2104C683F8A}" type="datetimeFigureOut">
               <a:rPr lang="en-GB" smtClean="0"/>
-              <a:t>23/10/2024</a:t>
+              <a:t>04/12/2024</a:t>
             </a:fld>
             <a:endParaRPr lang="en-GB"/>
           </a:p>
@@ -6525,7 +6525,7 @@
           <a:p>
             <a:fld id="{C9A16802-6AA0-4807-9B7D-A2104C683F8A}" type="datetimeFigureOut">
               <a:rPr lang="en-GB" smtClean="0"/>
-              <a:t>23/10/2024</a:t>
+              <a:t>04/12/2024</a:t>
             </a:fld>
             <a:endParaRPr lang="en-GB"/>
           </a:p>
@@ -6892,7 +6892,7 @@
           <a:p>
             <a:fld id="{C9A16802-6AA0-4807-9B7D-A2104C683F8A}" type="datetimeFigureOut">
               <a:rPr lang="en-GB" smtClean="0"/>
-              <a:t>23/10/2024</a:t>
+              <a:t>04/12/2024</a:t>
             </a:fld>
             <a:endParaRPr lang="en-GB"/>
           </a:p>
@@ -7010,7 +7010,7 @@
           <a:p>
             <a:fld id="{C9A16802-6AA0-4807-9B7D-A2104C683F8A}" type="datetimeFigureOut">
               <a:rPr lang="en-GB" smtClean="0"/>
-              <a:t>23/10/2024</a:t>
+              <a:t>04/12/2024</a:t>
             </a:fld>
             <a:endParaRPr lang="en-GB"/>
           </a:p>
@@ -7105,7 +7105,7 @@
           <a:p>
             <a:fld id="{C9A16802-6AA0-4807-9B7D-A2104C683F8A}" type="datetimeFigureOut">
               <a:rPr lang="en-GB" smtClean="0"/>
-              <a:t>23/10/2024</a:t>
+              <a:t>04/12/2024</a:t>
             </a:fld>
             <a:endParaRPr lang="en-GB"/>
           </a:p>
@@ -7382,7 +7382,7 @@
           <a:p>
             <a:fld id="{C9A16802-6AA0-4807-9B7D-A2104C683F8A}" type="datetimeFigureOut">
               <a:rPr lang="en-GB" smtClean="0"/>
-              <a:t>23/10/2024</a:t>
+              <a:t>04/12/2024</a:t>
             </a:fld>
             <a:endParaRPr lang="en-GB"/>
           </a:p>
@@ -7639,7 +7639,7 @@
           <a:p>
             <a:fld id="{C9A16802-6AA0-4807-9B7D-A2104C683F8A}" type="datetimeFigureOut">
               <a:rPr lang="en-GB" smtClean="0"/>
-              <a:t>23/10/2024</a:t>
+              <a:t>04/12/2024</a:t>
             </a:fld>
             <a:endParaRPr lang="en-GB"/>
           </a:p>
@@ -7852,7 +7852,7 @@
           <a:p>
             <a:fld id="{C9A16802-6AA0-4807-9B7D-A2104C683F8A}" type="datetimeFigureOut">
               <a:rPr lang="en-GB" smtClean="0"/>
-              <a:t>23/10/2024</a:t>
+              <a:t>04/12/2024</a:t>
             </a:fld>
             <a:endParaRPr lang="en-GB"/>
           </a:p>
@@ -8275,7 +8275,7 @@
         </p:nvSpPr>
         <p:spPr>
           <a:xfrm>
-            <a:off x="915988" y="646774"/>
+            <a:off x="915988" y="585814"/>
             <a:ext cx="25733931" cy="1841783"/>
           </a:xfrm>
         </p:spPr>
@@ -8537,7 +8537,7 @@
         </p:blipFill>
         <p:spPr bwMode="auto">
           <a:xfrm>
-            <a:off x="21949838" y="694751"/>
+            <a:off x="21949838" y="358108"/>
             <a:ext cx="7409387" cy="4157267"/>
           </a:xfrm>
           <a:prstGeom prst="rect">
@@ -10978,6 +10978,177 @@
           </a:graphicData>
         </a:graphic>
       </p:graphicFrame>
+      <p:sp>
+        <p:nvSpPr>
+          <p:cNvPr id="6" name="Rectangle 5">
+            <a:extLst>
+              <a:ext uri="{FF2B5EF4-FFF2-40B4-BE49-F238E27FC236}">
+                <a16:creationId xmlns:a16="http://schemas.microsoft.com/office/drawing/2014/main" id="{2A96329E-22CF-3941-0CA3-9DAF3B65375A}"/>
+              </a:ext>
+            </a:extLst>
+          </p:cNvPr>
+          <p:cNvSpPr/>
+          <p:nvPr/>
+        </p:nvSpPr>
+        <p:spPr>
+          <a:xfrm>
+            <a:off x="496252" y="396240"/>
+            <a:ext cx="29282707" cy="20591145"/>
+          </a:xfrm>
+          <a:prstGeom prst="rect">
+            <a:avLst/>
+          </a:prstGeom>
+          <a:noFill/>
+          <a:ln w="127000" cap="flat" cmpd="sng" algn="ctr">
+            <a:solidFill>
+              <a:schemeClr val="accent4"/>
+            </a:solidFill>
+            <a:prstDash val="solid"/>
+            <a:round/>
+            <a:headEnd type="none" w="med" len="med"/>
+            <a:tailEnd type="none" w="med" len="med"/>
+          </a:ln>
+        </p:spPr>
+        <p:style>
+          <a:lnRef idx="0">
+            <a:scrgbClr r="0" g="0" b="0"/>
+          </a:lnRef>
+          <a:fillRef idx="0">
+            <a:scrgbClr r="0" g="0" b="0"/>
+          </a:fillRef>
+          <a:effectRef idx="0">
+            <a:scrgbClr r="0" g="0" b="0"/>
+          </a:effectRef>
+          <a:fontRef idx="minor">
+            <a:schemeClr val="accent4"/>
+          </a:fontRef>
+        </p:style>
+        <p:txBody>
+          <a:bodyPr rtlCol="0" anchor="ctr"/>
+          <a:lstStyle/>
+          <a:p>
+            <a:pPr algn="ctr"/>
+            <a:endParaRPr lang="en-GB"/>
+          </a:p>
+        </p:txBody>
+      </p:sp>
+      <p:cxnSp>
+        <p:nvCxnSpPr>
+          <p:cNvPr id="14" name="Straight Connector 13">
+            <a:extLst>
+              <a:ext uri="{FF2B5EF4-FFF2-40B4-BE49-F238E27FC236}">
+                <a16:creationId xmlns:a16="http://schemas.microsoft.com/office/drawing/2014/main" id="{66E2B1C3-6028-5874-BEBC-373BA0CF295C}"/>
+              </a:ext>
+            </a:extLst>
+          </p:cNvPr>
+          <p:cNvCxnSpPr>
+            <a:cxnSpLocks/>
+          </p:cNvCxnSpPr>
+          <p:nvPr/>
+        </p:nvCxnSpPr>
+        <p:spPr>
+          <a:xfrm flipV="1">
+            <a:off x="496253" y="4477242"/>
+            <a:ext cx="29282707" cy="0"/>
+          </a:xfrm>
+          <a:prstGeom prst="line">
+            <a:avLst/>
+          </a:prstGeom>
+          <a:ln w="127000"/>
+        </p:spPr>
+        <p:style>
+          <a:lnRef idx="3">
+            <a:schemeClr val="accent4"/>
+          </a:lnRef>
+          <a:fillRef idx="0">
+            <a:schemeClr val="accent4"/>
+          </a:fillRef>
+          <a:effectRef idx="2">
+            <a:schemeClr val="accent4"/>
+          </a:effectRef>
+          <a:fontRef idx="minor">
+            <a:schemeClr val="tx1"/>
+          </a:fontRef>
+        </p:style>
+      </p:cxnSp>
+      <p:cxnSp>
+        <p:nvCxnSpPr>
+          <p:cNvPr id="24" name="Straight Connector 23">
+            <a:extLst>
+              <a:ext uri="{FF2B5EF4-FFF2-40B4-BE49-F238E27FC236}">
+                <a16:creationId xmlns:a16="http://schemas.microsoft.com/office/drawing/2014/main" id="{C8A56C2A-3A63-D881-BBAA-7245B6FF6AA8}"/>
+              </a:ext>
+            </a:extLst>
+          </p:cNvPr>
+          <p:cNvCxnSpPr>
+            <a:cxnSpLocks/>
+          </p:cNvCxnSpPr>
+          <p:nvPr/>
+        </p:nvCxnSpPr>
+        <p:spPr>
+          <a:xfrm flipH="1">
+            <a:off x="10394182" y="4477240"/>
+            <a:ext cx="0" cy="16510142"/>
+          </a:xfrm>
+          <a:prstGeom prst="line">
+            <a:avLst/>
+          </a:prstGeom>
+          <a:ln w="127000"/>
+        </p:spPr>
+        <p:style>
+          <a:lnRef idx="3">
+            <a:schemeClr val="accent4"/>
+          </a:lnRef>
+          <a:fillRef idx="0">
+            <a:schemeClr val="accent4"/>
+          </a:fillRef>
+          <a:effectRef idx="2">
+            <a:schemeClr val="accent4"/>
+          </a:effectRef>
+          <a:fontRef idx="minor">
+            <a:schemeClr val="tx1"/>
+          </a:fontRef>
+        </p:style>
+      </p:cxnSp>
+      <p:cxnSp>
+        <p:nvCxnSpPr>
+          <p:cNvPr id="36" name="Straight Connector 35">
+            <a:extLst>
+              <a:ext uri="{FF2B5EF4-FFF2-40B4-BE49-F238E27FC236}">
+                <a16:creationId xmlns:a16="http://schemas.microsoft.com/office/drawing/2014/main" id="{5787EC07-0CA3-ECFD-2F87-920EED5DF527}"/>
+              </a:ext>
+            </a:extLst>
+          </p:cNvPr>
+          <p:cNvCxnSpPr>
+            <a:cxnSpLocks/>
+          </p:cNvCxnSpPr>
+          <p:nvPr/>
+        </p:nvCxnSpPr>
+        <p:spPr>
+          <a:xfrm>
+            <a:off x="19900420" y="4477242"/>
+            <a:ext cx="0" cy="16510142"/>
+          </a:xfrm>
+          <a:prstGeom prst="line">
+            <a:avLst/>
+          </a:prstGeom>
+          <a:ln w="127000"/>
+        </p:spPr>
+        <p:style>
+          <a:lnRef idx="3">
+            <a:schemeClr val="accent4"/>
+          </a:lnRef>
+          <a:fillRef idx="0">
+            <a:schemeClr val="accent4"/>
+          </a:fillRef>
+          <a:effectRef idx="2">
+            <a:schemeClr val="accent4"/>
+          </a:effectRef>
+          <a:fontRef idx="minor">
+            <a:schemeClr val="tx1"/>
+          </a:fontRef>
+        </p:style>
+      </p:cxnSp>
     </p:spTree>
     <p:extLst>
       <p:ext uri="{BB962C8B-B14F-4D97-AF65-F5344CB8AC3E}">

</xml_diff>